<commit_message>
Reframe: cash flows TradFi->TradFi, DLT is the messaging/coordination layer
- TL;DR, title, architecture diagram recast: money never on-chain
- Section 4 atomicity -> coordination problem (correlate off-chain cash to on-chain message)
- Deck slides 1/4/5/12 updated to match

Co-Authored-By: Claude Opus 4.8 (1M context) <noreply@anthropic.com>
</commit_message>
<xml_diff>
--- a/RCN-CMTAT-FireFly-Gateway.pptx
+++ b/RCN-CMTAT-FireFly-Gateway.pptx
@@ -3378,7 +3378,7 @@
         <p:spPr>
           <a:xfrm>
             <a:off x="1097280" y="3977639"/>
-            <a:ext cx="10058400" cy="1097280"/>
+            <a:ext cx="10241280" cy="1188720"/>
           </a:xfrm>
           <a:prstGeom prst="rect">
             <a:avLst/>
@@ -3403,7 +3403,25 @@
                 </a:solidFill>
                 <a:latin typeface="Calibri"/>
               </a:rPr>
-              <a:t>TradFi instant rails  →  Hyperledger FireFly orchestrator  →  CMTAT tokens</a:t>
+              <a:t>Cash flows </a:t>
+            </a:r>
+            <a:r>
+              <a:rPr sz="1900" b="1">
+                <a:solidFill>
+                  <a:srgbClr val="C8922B"/>
+                </a:solidFill>
+                <a:latin typeface="Calibri"/>
+              </a:rPr>
+              <a:t>TradFi → TradFi</a:t>
+            </a:r>
+            <a:r>
+              <a:rPr sz="1900" b="0">
+                <a:solidFill>
+                  <a:srgbClr val="BFD2F0"/>
+                </a:solidFill>
+                <a:latin typeface="Calibri"/>
+              </a:rPr>
+              <a:t>.  The permissioned DLT is the shared</a:t>
             </a:r>
           </a:p>
           <a:p>
@@ -3419,7 +3437,7 @@
                 </a:solidFill>
                 <a:latin typeface="Calibri"/>
               </a:rPr>
-              <a:t>representing Reverse Convertible Notes, cross-border &amp; multi-jurisdiction.</a:t>
+              <a:t>messaging / coordination layer — FireFly minting CMTAT tokens for RCNs.</a:t>
             </a:r>
           </a:p>
         </p:txBody>
@@ -6522,7 +6540,7 @@
         <p:spPr>
           <a:xfrm>
             <a:off x="1097280" y="1965960"/>
-            <a:ext cx="10058400" cy="1463040"/>
+            <a:ext cx="10241280" cy="1737360"/>
           </a:xfrm>
           <a:prstGeom prst="rect">
             <a:avLst/>
@@ -6541,13 +6559,13 @@
               </a:lnSpc>
             </a:pPr>
             <a:r>
-              <a:rPr sz="3400" b="1">
+              <a:rPr sz="3200" b="1">
                 <a:solidFill>
                   <a:srgbClr val="FFFFFF"/>
                 </a:solidFill>
                 <a:latin typeface="Calibri"/>
               </a:rPr>
-              <a:t>The token is easy.</a:t>
+              <a:t>Fiat in. Fiat out. TradFi both ends.</a:t>
             </a:r>
           </a:p>
           <a:p>
@@ -6557,13 +6575,13 @@
               </a:lnSpc>
             </a:pPr>
             <a:r>
-              <a:rPr sz="3000" b="1">
+              <a:rPr sz="2900" b="1">
                 <a:solidFill>
                   <a:srgbClr val="BFD2F0"/>
                 </a:solidFill>
                 <a:latin typeface="Calibri"/>
               </a:rPr>
-              <a:t>Atomicity across two finalities, across jurisdictions,</a:t>
+              <a:t>The DLT is the shared message bus —</a:t>
             </a:r>
           </a:p>
           <a:p>
@@ -6573,13 +6591,13 @@
               </a:lnSpc>
             </a:pPr>
             <a:r>
-              <a:rPr sz="3000" b="1">
+              <a:rPr sz="2900" b="1">
                 <a:solidFill>
                   <a:srgbClr val="BFD2F0"/>
                 </a:solidFill>
                 <a:latin typeface="Calibri"/>
               </a:rPr>
-              <a:t>is the architecture.</a:t>
+              <a:t>correlation, not value transfer, is the architecture.</a:t>
             </a:r>
           </a:p>
         </p:txBody>
@@ -8764,7 +8782,7 @@
                 </a:solidFill>
                 <a:latin typeface="Calibri"/>
               </a:rPr>
-              <a:t>TradFi INSTANT-PAYMENT DOMAIN</a:t>
+              <a:t>① CASH — TradFi → TradFi</a:t>
             </a:r>
           </a:p>
         </p:txBody>
@@ -8893,7 +8911,7 @@
                 </a:solidFill>
                 <a:latin typeface="Calibri"/>
               </a:rPr>
-              <a:t>GATEWAY</a:t>
+              <a:t>② GATEWAY — correlates</a:t>
             </a:r>
           </a:p>
         </p:txBody>
@@ -9022,7 +9040,7 @@
                 </a:solidFill>
                 <a:latin typeface="Calibri"/>
               </a:rPr>
-              <a:t>PERMISSIONED DLT DOMAIN</a:t>
+              <a:t>③ DLT — MESSAGING (no cash)</a:t>
             </a:r>
           </a:p>
         </p:txBody>
@@ -9123,7 +9141,7 @@
                 </a:solidFill>
                 <a:latin typeface="Calibri"/>
               </a:rPr>
-              <a:t>pays on instant rail</a:t>
+              <a:t>fiat in ↓   ·   fiat out ↑</a:t>
             </a:r>
           </a:p>
         </p:txBody>
@@ -9208,7 +9226,7 @@
                 </a:solidFill>
                 <a:latin typeface="Calibri"/>
               </a:rPr>
-              <a:t>Instant Rail</a:t>
+              <a:t>Instant Rail IN</a:t>
             </a:r>
           </a:p>
           <a:p>
@@ -9224,7 +9242,7 @@
                 </a:solidFill>
                 <a:latin typeface="Calibri"/>
               </a:rPr>
-              <a:t>SEPA Inst · TIPS · FedNow · RTP · FPS</a:t>
+              <a:t>subscribe — SEPA Inst · FedNow · RTP</a:t>
             </a:r>
           </a:p>
         </p:txBody>
@@ -9325,7 +9343,7 @@
                 </a:solidFill>
                 <a:latin typeface="Calibri"/>
               </a:rPr>
-              <a:t>scheme participant · escrow</a:t>
+              <a:t>escrow · client-money</a:t>
             </a:r>
           </a:p>
         </p:txBody>
@@ -9410,7 +9428,7 @@
                 </a:solidFill>
                 <a:latin typeface="Calibri"/>
               </a:rPr>
-              <a:t>Core Banking Ledger</a:t>
+              <a:t>Instant Rail OUT</a:t>
             </a:r>
           </a:p>
           <a:p>
@@ -9426,7 +9444,7 @@
                 </a:solidFill>
                 <a:latin typeface="Calibri"/>
               </a:rPr>
-              <a:t>ISO 20022 pacs.002 finality</a:t>
+              <a:t>coupon · redemption par → client</a:t>
             </a:r>
           </a:p>
         </p:txBody>
@@ -9931,7 +9949,7 @@
                 </a:solidFill>
                 <a:latin typeface="Calibri"/>
               </a:rPr>
-              <a:t>+ RuleEngine</a:t>
+              <a:t>shared golden record + message</a:t>
             </a:r>
           </a:p>
         </p:txBody>
@@ -10016,7 +10034,7 @@
                 </a:solidFill>
                 <a:latin typeface="Calibri"/>
               </a:rPr>
-              <a:t>On-chain Register</a:t>
+              <a:t>Authoritative Register</a:t>
             </a:r>
           </a:p>
           <a:p>
@@ -10218,7 +10236,7 @@
                 </a:solidFill>
                 <a:latin typeface="Calibri"/>
               </a:rPr>
-              <a:t>Events / Receipts</a:t>
+              <a:t>Coordination Events</a:t>
             </a:r>
           </a:p>
           <a:p>
@@ -10234,7 +10252,7 @@
                 </a:solidFill>
                 <a:latin typeface="Calibri"/>
               </a:rPr>
-              <a:t>back to reconciliation</a:t>
+              <a:t>mint · snapshot · burn → payout</a:t>
             </a:r>
           </a:p>
         </p:txBody>
@@ -10379,7 +10397,7 @@
                 </a:solidFill>
                 <a:latin typeface="Calibri"/>
               </a:rPr>
-              <a:t>CASH LEG VS SECURITY LEG</a:t>
+              <a:t>NO ON-CHAIN VALUE LEG TO MAKE ATOMIC</a:t>
             </a:r>
           </a:p>
         </p:txBody>
@@ -10418,7 +10436,7 @@
                 </a:solidFill>
                 <a:latin typeface="Calibri"/>
               </a:rPr>
-              <a:t>The atomicity problem — the actual hard part</a:t>
+              <a:t>The coordination problem — the actual hard part</a:t>
             </a:r>
           </a:p>
         </p:txBody>
@@ -10534,13 +10552,13 @@
               </a:lnSpc>
             </a:pPr>
             <a:r>
-              <a:rPr sz="1400" b="0">
+              <a:rPr sz="1350" b="0">
                 <a:solidFill>
                   <a:srgbClr val="5A6778"/>
                 </a:solidFill>
                 <a:latin typeface="Calibri"/>
               </a:rPr>
-              <a:t>A domestic instant rail and a DLT have independent, non-atomic finality. You cannot two-phase-commit FedNow and an EVM block.</a:t>
+              <a:t>Cash stays in TradFi; the DLT only messages. So the problem isn’t atomic value transfer — it’s correlating an off-chain cash event to an on-chain message, exactly once, with a safe reversal.</a:t>
             </a:r>
           </a:p>
         </p:txBody>
@@ -10869,7 +10887,7 @@
                 </a:solidFill>
                 <a:latin typeface="Calibri"/>
               </a:rPr>
-              <a:t>Confirm cash → then mint</a:t>
+              <a:t>Cash finality → then message (mint)</a:t>
             </a:r>
           </a:p>
         </p:txBody>
@@ -10908,7 +10926,7 @@
                 </a:solidFill>
                 <a:latin typeface="Calibri"/>
               </a:rPr>
-              <a:t>Window of “cash taken, token not minted.” Must reconcile + reverse.</a:t>
+              <a:t>Window of “cash taken, note not recorded.” Must reconcile + reverse.</a:t>
             </a:r>
           </a:p>
         </p:txBody>
@@ -11037,7 +11055,7 @@
                 </a:solidFill>
                 <a:latin typeface="Calibri"/>
               </a:rPr>
-              <a:t>Escrow / conditional</a:t>
+              <a:t>Escrow + msg-on-finality  ✅</a:t>
             </a:r>
           </a:p>
         </p:txBody>
@@ -11076,7 +11094,7 @@
                 </a:solidFill>
                 <a:latin typeface="Calibri"/>
               </a:rPr>
-              <a:t>Cash in client-money escrow; mint on release; auto-refund on timeout</a:t>
+              <a:t>Escrow held; mint only on confirmed finality; auto-refund on timeout</a:t>
             </a:r>
           </a:p>
         </p:txBody>
@@ -11115,7 +11133,7 @@
                 </a:solidFill>
                 <a:latin typeface="Calibri"/>
               </a:rPr>
-              <a:t>Strong client protection; needs safeguarded account.</a:t>
+              <a:t>Strong client protection; needs safeguarded account. Recommended.</a:t>
             </a:r>
           </a:p>
         </p:txBody>
@@ -11244,7 +11262,7 @@
                 </a:solidFill>
                 <a:latin typeface="Calibri"/>
               </a:rPr>
-              <a:t>PvP / DvP (HTLC / notary)</a:t>
+              <a:t>Escrow release gated on mint</a:t>
             </a:r>
           </a:p>
         </p:txBody>
@@ -11283,7 +11301,7 @@
                 </a:solidFill>
                 <a:latin typeface="Calibri"/>
               </a:rPr>
-              <a:t>Atomic swap of cash proof ↔ token</a:t>
+              <a:t>Escrow → issuer only AFTER on-chain mint event observed</a:t>
             </a:r>
           </a:p>
         </p:txBody>
@@ -11322,7 +11340,7 @@
                 </a:solidFill>
                 <a:latin typeface="Calibri"/>
               </a:rPr>
-              <a:t>True delivery-vs-payment; needs tokenized cash or notary oracle.</a:t>
+              <a:t>Kills both races: minted-but-cash-lost and cash-released-but-not-minted.</a:t>
             </a:r>
           </a:p>
         </p:txBody>
@@ -11451,7 +11469,7 @@
                 </a:solidFill>
                 <a:latin typeface="Calibri"/>
               </a:rPr>
-              <a:t>Tokenized cash leg</a:t>
+              <a:t>Optional on-chain DvP</a:t>
             </a:r>
           </a:p>
         </p:txBody>
@@ -11490,7 +11508,7 @@
                 </a:solidFill>
                 <a:latin typeface="Calibri"/>
               </a:rPr>
-              <a:t>Stablecoin / tokenized deposit / wCBDC on same ledger</a:t>
+              <a:t>Tokenized deposit on same ledger, where law permits</a:t>
             </a:r>
           </a:p>
         </p:txBody>
@@ -11529,7 +11547,7 @@
                 </a:solidFill>
                 <a:latin typeface="Calibri"/>
               </a:rPr>
-              <a:t>Cleanest atomicity; adds money-classification (EMT / deposit token).</a:t>
+              <a:t>Cleanest atomicity — but pulls money on-chain, against the TradFi→TradFi goal.</a:t>
             </a:r>
           </a:p>
         </p:txBody>
@@ -11577,7 +11595,7 @@
                 </a:solidFill>
                 <a:latin typeface="Calibri"/>
               </a:rPr>
-              <a:t>escrow-backed sequential + idempotent reconciliation now → on-chain DvP against a tokenized deposit where permitted.</a:t>
+              <a:t>escrow + message-on-finality, escrow release gated on the mint event, idempotent reconciliation as source of truth. No value on-chain = tiny failure surface.</a:t>
             </a:r>
           </a:p>
         </p:txBody>

</xml_diff>

<commit_message>
Add design fork: token-as-register (Variant A) vs message-bus-only (Variant B)
- New section 11: legal-basis fork; B (register stays at transfer agent) = default for cross-border TradFi->TradFi
- Deck: new A-vs-B slide (now 13 slides)

Co-Authored-By: Claude Opus 4.8 (1M context) <noreply@anthropic.com>
</commit_message>
<xml_diff>
--- a/RCN-CMTAT-FireFly-Gateway.pptx
+++ b/RCN-CMTAT-FireFly-Gateway.pptx
@@ -17,6 +17,7 @@
     <p:sldId id="265" r:id="rId16"/>
     <p:sldId id="266" r:id="rId17"/>
     <p:sldId id="267" r:id="rId18"/>
+    <p:sldId id="268" r:id="rId19"/>
   </p:sldIdLst>
   <p:sldSz cx="12191695" cy="6858000" type="screen4x3"/>
   <p:notesSz cx="6858000" cy="9144000"/>
@@ -6390,6 +6391,1013 @@
 </file>
 
 <file path=ppt/slides/slide12.xml><?xml version="1.0" encoding="utf-8"?>
+<p:sld xmlns:a="http://schemas.openxmlformats.org/drawingml/2006/main" xmlns:p="http://schemas.openxmlformats.org/presentationml/2006/main" xmlns:r="http://schemas.openxmlformats.org/officeDocument/2006/relationships">
+  <p:cSld>
+    <p:spTree>
+      <p:nvGrpSpPr>
+        <p:cNvPr id="1" name=""/>
+        <p:cNvGrpSpPr/>
+        <p:nvPr/>
+      </p:nvGrpSpPr>
+      <p:grpSpPr/>
+      <p:sp>
+        <p:nvSpPr>
+          <p:cNvPr id="2" name="Rectangle 1"/>
+          <p:cNvSpPr/>
+          <p:nvPr/>
+        </p:nvSpPr>
+        <p:spPr>
+          <a:xfrm>
+            <a:off x="0" y="0"/>
+            <a:ext cx="12191695" cy="6858000"/>
+          </a:xfrm>
+          <a:prstGeom prst="rect">
+            <a:avLst/>
+          </a:prstGeom>
+          <a:solidFill>
+            <a:srgbClr val="F6F8FB"/>
+          </a:solidFill>
+          <a:ln>
+            <a:noFill/>
+          </a:ln>
+          <a:effectLst/>
+        </p:spPr>
+        <p:style>
+          <a:lnRef idx="1">
+            <a:schemeClr val="accent1"/>
+          </a:lnRef>
+          <a:fillRef idx="3">
+            <a:schemeClr val="accent1"/>
+          </a:fillRef>
+          <a:effectRef idx="2">
+            <a:schemeClr val="accent1"/>
+          </a:effectRef>
+          <a:fontRef idx="minor">
+            <a:schemeClr val="lt1"/>
+          </a:fontRef>
+        </p:style>
+        <p:txBody>
+          <a:bodyPr rtlCol="0" anchor="ctr"/>
+          <a:lstStyle/>
+          <a:p>
+            <a:pPr algn="ctr"/>
+          </a:p>
+        </p:txBody>
+      </p:sp>
+      <p:sp>
+        <p:nvSpPr>
+          <p:cNvPr id="3" name="Rectangle 2"/>
+          <p:cNvSpPr/>
+          <p:nvPr/>
+        </p:nvSpPr>
+        <p:spPr>
+          <a:xfrm>
+            <a:off x="822960" y="585216"/>
+            <a:ext cx="50292" cy="310896"/>
+          </a:xfrm>
+          <a:prstGeom prst="rect">
+            <a:avLst/>
+          </a:prstGeom>
+          <a:solidFill>
+            <a:srgbClr val="C8922B"/>
+          </a:solidFill>
+          <a:ln>
+            <a:noFill/>
+          </a:ln>
+          <a:effectLst/>
+        </p:spPr>
+        <p:style>
+          <a:lnRef idx="1">
+            <a:schemeClr val="accent1"/>
+          </a:lnRef>
+          <a:fillRef idx="3">
+            <a:schemeClr val="accent1"/>
+          </a:fillRef>
+          <a:effectRef idx="2">
+            <a:schemeClr val="accent1"/>
+          </a:effectRef>
+          <a:fontRef idx="minor">
+            <a:schemeClr val="lt1"/>
+          </a:fontRef>
+        </p:style>
+        <p:txBody>
+          <a:bodyPr rtlCol="0" anchor="ctr"/>
+          <a:lstStyle/>
+          <a:p>
+            <a:pPr algn="ctr"/>
+          </a:p>
+        </p:txBody>
+      </p:sp>
+      <p:sp>
+        <p:nvSpPr>
+          <p:cNvPr id="4" name="TextBox 3"/>
+          <p:cNvSpPr txBox="1"/>
+          <p:nvPr/>
+        </p:nvSpPr>
+        <p:spPr>
+          <a:xfrm>
+            <a:off x="987552" y="566928"/>
+            <a:ext cx="8229600" cy="365760"/>
+          </a:xfrm>
+          <a:prstGeom prst="rect">
+            <a:avLst/>
+          </a:prstGeom>
+          <a:noFill/>
+        </p:spPr>
+        <p:txBody>
+          <a:bodyPr wrap="square" anchor="t" lIns="0" rIns="0" tIns="0" bIns="0">
+            <a:spAutoFit/>
+          </a:bodyPr>
+          <a:lstStyle/>
+          <a:p>
+            <a:pPr algn="l">
+              <a:lnSpc>
+                <a:spcPct val="100000"/>
+              </a:lnSpc>
+            </a:pPr>
+            <a:r>
+              <a:rPr sz="1300" b="1">
+                <a:solidFill>
+                  <a:srgbClr val="C8922B"/>
+                </a:solidFill>
+                <a:latin typeface="Calibri"/>
+              </a:rPr>
+              <a:t>PICK ONE PER ISSUANCE</a:t>
+            </a:r>
+          </a:p>
+        </p:txBody>
+      </p:sp>
+      <p:sp>
+        <p:nvSpPr>
+          <p:cNvPr id="5" name="TextBox 4"/>
+          <p:cNvSpPr txBox="1"/>
+          <p:nvPr/>
+        </p:nvSpPr>
+        <p:spPr>
+          <a:xfrm>
+            <a:off x="822960" y="868680"/>
+            <a:ext cx="10607040" cy="822960"/>
+          </a:xfrm>
+          <a:prstGeom prst="rect">
+            <a:avLst/>
+          </a:prstGeom>
+          <a:noFill/>
+        </p:spPr>
+        <p:txBody>
+          <a:bodyPr wrap="square" anchor="t" lIns="0" rIns="0" tIns="0" bIns="0">
+            <a:spAutoFit/>
+          </a:bodyPr>
+          <a:lstStyle/>
+          <a:p>
+            <a:pPr algn="l">
+              <a:lnSpc>
+                <a:spcPct val="100000"/>
+              </a:lnSpc>
+            </a:pPr>
+            <a:r>
+              <a:rPr sz="3000" b="1">
+                <a:solidFill>
+                  <a:srgbClr val="0F1A2B"/>
+                </a:solidFill>
+                <a:latin typeface="Calibri"/>
+              </a:rPr>
+              <a:t>Design fork — is the token the register, or just the message?</a:t>
+            </a:r>
+          </a:p>
+        </p:txBody>
+      </p:sp>
+      <p:sp>
+        <p:nvSpPr>
+          <p:cNvPr id="6" name="Rectangle 5"/>
+          <p:cNvSpPr/>
+          <p:nvPr/>
+        </p:nvSpPr>
+        <p:spPr>
+          <a:xfrm>
+            <a:off x="822960" y="1572768"/>
+            <a:ext cx="10543032" cy="18288"/>
+          </a:xfrm>
+          <a:prstGeom prst="rect">
+            <a:avLst/>
+          </a:prstGeom>
+          <a:solidFill>
+            <a:srgbClr val="D9DFE7"/>
+          </a:solidFill>
+          <a:ln>
+            <a:noFill/>
+          </a:ln>
+          <a:effectLst/>
+        </p:spPr>
+        <p:style>
+          <a:lnRef idx="1">
+            <a:schemeClr val="accent1"/>
+          </a:lnRef>
+          <a:fillRef idx="3">
+            <a:schemeClr val="accent1"/>
+          </a:fillRef>
+          <a:effectRef idx="2">
+            <a:schemeClr val="accent1"/>
+          </a:effectRef>
+          <a:fontRef idx="minor">
+            <a:schemeClr val="lt1"/>
+          </a:fontRef>
+        </p:style>
+        <p:txBody>
+          <a:bodyPr rtlCol="0" anchor="ctr"/>
+          <a:lstStyle/>
+          <a:p>
+            <a:pPr algn="ctr"/>
+          </a:p>
+        </p:txBody>
+      </p:sp>
+      <p:sp>
+        <p:nvSpPr>
+          <p:cNvPr id="7" name="TextBox 6"/>
+          <p:cNvSpPr txBox="1"/>
+          <p:nvPr/>
+        </p:nvSpPr>
+        <p:spPr>
+          <a:xfrm>
+            <a:off x="11247120" y="6419088"/>
+            <a:ext cx="822960" cy="274320"/>
+          </a:xfrm>
+          <a:prstGeom prst="rect">
+            <a:avLst/>
+          </a:prstGeom>
+          <a:noFill/>
+        </p:spPr>
+        <p:txBody>
+          <a:bodyPr wrap="square" anchor="t" lIns="0" rIns="0" tIns="0" bIns="0">
+            <a:spAutoFit/>
+          </a:bodyPr>
+          <a:lstStyle/>
+          <a:p>
+            <a:pPr algn="r">
+              <a:lnSpc>
+                <a:spcPct val="100000"/>
+              </a:lnSpc>
+            </a:pPr>
+            <a:r>
+              <a:rPr sz="1100" b="0">
+                <a:solidFill>
+                  <a:srgbClr val="5A6778"/>
+                </a:solidFill>
+                <a:latin typeface="Calibri"/>
+              </a:rPr>
+              <a:t>12</a:t>
+            </a:r>
+          </a:p>
+        </p:txBody>
+      </p:sp>
+      <p:sp>
+        <p:nvSpPr>
+          <p:cNvPr id="8" name="Rounded Rectangle 7"/>
+          <p:cNvSpPr/>
+          <p:nvPr/>
+        </p:nvSpPr>
+        <p:spPr>
+          <a:xfrm>
+            <a:off x="822960" y="1828800"/>
+            <a:ext cx="5120640" cy="3977639"/>
+          </a:xfrm>
+          <a:prstGeom prst="roundRect">
+            <a:avLst/>
+          </a:prstGeom>
+          <a:solidFill>
+            <a:srgbClr val="FFFFFF"/>
+          </a:solidFill>
+          <a:ln w="12700">
+            <a:solidFill>
+              <a:srgbClr val="D9DFE7"/>
+            </a:solidFill>
+          </a:ln>
+          <a:effectLst/>
+        </p:spPr>
+        <p:style>
+          <a:lnRef idx="1">
+            <a:schemeClr val="accent1"/>
+          </a:lnRef>
+          <a:fillRef idx="3">
+            <a:schemeClr val="accent1"/>
+          </a:fillRef>
+          <a:effectRef idx="2">
+            <a:schemeClr val="accent1"/>
+          </a:effectRef>
+          <a:fontRef idx="minor">
+            <a:schemeClr val="lt1"/>
+          </a:fontRef>
+        </p:style>
+        <p:txBody>
+          <a:bodyPr rtlCol="0" anchor="ctr"/>
+          <a:lstStyle/>
+          <a:p>
+            <a:pPr algn="ctr"/>
+          </a:p>
+        </p:txBody>
+      </p:sp>
+      <p:sp>
+        <p:nvSpPr>
+          <p:cNvPr id="9" name="Round Same Side Corner Rectangle 8"/>
+          <p:cNvSpPr/>
+          <p:nvPr/>
+        </p:nvSpPr>
+        <p:spPr>
+          <a:xfrm>
+            <a:off x="822960" y="1828800"/>
+            <a:ext cx="5120640" cy="502920"/>
+          </a:xfrm>
+          <a:prstGeom prst="round2SameRect">
+            <a:avLst/>
+          </a:prstGeom>
+          <a:solidFill>
+            <a:srgbClr val="142A4A"/>
+          </a:solidFill>
+          <a:ln>
+            <a:noFill/>
+          </a:ln>
+          <a:effectLst/>
+        </p:spPr>
+        <p:style>
+          <a:lnRef idx="1">
+            <a:schemeClr val="accent1"/>
+          </a:lnRef>
+          <a:fillRef idx="3">
+            <a:schemeClr val="accent1"/>
+          </a:fillRef>
+          <a:effectRef idx="2">
+            <a:schemeClr val="accent1"/>
+          </a:effectRef>
+          <a:fontRef idx="minor">
+            <a:schemeClr val="lt1"/>
+          </a:fontRef>
+        </p:style>
+        <p:txBody>
+          <a:bodyPr rtlCol="0" anchor="ctr"/>
+          <a:lstStyle/>
+          <a:p>
+            <a:pPr algn="ctr"/>
+          </a:p>
+        </p:txBody>
+      </p:sp>
+      <p:sp>
+        <p:nvSpPr>
+          <p:cNvPr id="10" name="TextBox 9"/>
+          <p:cNvSpPr txBox="1"/>
+          <p:nvPr/>
+        </p:nvSpPr>
+        <p:spPr>
+          <a:xfrm>
+            <a:off x="1005840" y="1901952"/>
+            <a:ext cx="4754880" cy="365760"/>
+          </a:xfrm>
+          <a:prstGeom prst="rect">
+            <a:avLst/>
+          </a:prstGeom>
+          <a:noFill/>
+        </p:spPr>
+        <p:txBody>
+          <a:bodyPr wrap="square" anchor="t" lIns="0" rIns="0" tIns="0" bIns="0">
+            <a:spAutoFit/>
+          </a:bodyPr>
+          <a:lstStyle/>
+          <a:p>
+            <a:pPr algn="l">
+              <a:lnSpc>
+                <a:spcPct val="100000"/>
+              </a:lnSpc>
+            </a:pPr>
+            <a:r>
+              <a:rPr sz="1500" b="1">
+                <a:solidFill>
+                  <a:srgbClr val="FFFFFF"/>
+                </a:solidFill>
+                <a:latin typeface="Calibri"/>
+              </a:rPr>
+              <a:t>A · Token IS the register</a:t>
+            </a:r>
+            <a:r>
+              <a:rPr sz="1100" b="0">
+                <a:solidFill>
+                  <a:srgbClr val="BFD2F0"/>
+                </a:solidFill>
+                <a:latin typeface="Calibri"/>
+              </a:rPr>
+              <a:t>   (ledger-based security)</a:t>
+            </a:r>
+          </a:p>
+        </p:txBody>
+      </p:sp>
+      <p:sp>
+        <p:nvSpPr>
+          <p:cNvPr id="11" name="TextBox 10"/>
+          <p:cNvSpPr txBox="1"/>
+          <p:nvPr/>
+        </p:nvSpPr>
+        <p:spPr>
+          <a:xfrm>
+            <a:off x="1051560" y="2514600"/>
+            <a:ext cx="4663440" cy="3657600"/>
+          </a:xfrm>
+          <a:prstGeom prst="rect">
+            <a:avLst/>
+          </a:prstGeom>
+          <a:noFill/>
+        </p:spPr>
+        <p:txBody>
+          <a:bodyPr wrap="square" lIns="0" tIns="0">
+            <a:spAutoFit/>
+          </a:bodyPr>
+          <a:lstStyle/>
+          <a:p>
+            <a:pPr>
+              <a:lnSpc>
+                <a:spcPct val="105000"/>
+              </a:lnSpc>
+              <a:spcAft>
+                <a:spcPts val="800"/>
+              </a:spcAft>
+            </a:pPr>
+            <a:r>
+              <a:rPr sz="1300" b="1">
+                <a:solidFill>
+                  <a:srgbClr val="2D6CDF"/>
+                </a:solidFill>
+                <a:latin typeface="Calibri"/>
+              </a:rPr>
+              <a:t>▸ </a:t>
+            </a:r>
+            <a:r>
+              <a:rPr sz="1300" b="1">
+                <a:solidFill>
+                  <a:srgbClr val="0F1A2B"/>
+                </a:solidFill>
+                <a:latin typeface="Calibri"/>
+              </a:rPr>
+              <a:t>Legal title lives on-chain</a:t>
+            </a:r>
+            <a:r>
+              <a:rPr sz="1300" b="0">
+                <a:solidFill>
+                  <a:srgbClr val="5A6778"/>
+                </a:solidFill>
+                <a:latin typeface="Calibri"/>
+              </a:rPr>
+              <a:t> — transfer = change of title</a:t>
+            </a:r>
+          </a:p>
+          <a:p>
+            <a:pPr>
+              <a:lnSpc>
+                <a:spcPct val="105000"/>
+              </a:lnSpc>
+              <a:spcAft>
+                <a:spcPts val="800"/>
+              </a:spcAft>
+            </a:pPr>
+            <a:r>
+              <a:rPr sz="1300" b="1">
+                <a:solidFill>
+                  <a:srgbClr val="2D6CDF"/>
+                </a:solidFill>
+                <a:latin typeface="Calibri"/>
+              </a:rPr>
+              <a:t>▸ </a:t>
+            </a:r>
+            <a:r>
+              <a:rPr sz="1300" b="1">
+                <a:solidFill>
+                  <a:srgbClr val="0F1A2B"/>
+                </a:solidFill>
+                <a:latin typeface="Calibri"/>
+              </a:rPr>
+              <a:t>Needs DLT securities law</a:t>
+            </a:r>
+            <a:r>
+              <a:rPr sz="1300" b="0">
+                <a:solidFill>
+                  <a:srgbClr val="5A6778"/>
+                </a:solidFill>
+                <a:latin typeface="Calibri"/>
+              </a:rPr>
+              <a:t> — CH, EU Pilot, DE eWpG, LU</a:t>
+            </a:r>
+          </a:p>
+          <a:p>
+            <a:pPr>
+              <a:lnSpc>
+                <a:spcPct val="105000"/>
+              </a:lnSpc>
+              <a:spcAft>
+                <a:spcPts val="800"/>
+              </a:spcAft>
+            </a:pPr>
+            <a:r>
+              <a:rPr sz="1300" b="1">
+                <a:solidFill>
+                  <a:srgbClr val="2D6CDF"/>
+                </a:solidFill>
+                <a:latin typeface="Calibri"/>
+              </a:rPr>
+              <a:t>▸ </a:t>
+            </a:r>
+            <a:r>
+              <a:rPr sz="1300" b="1">
+                <a:solidFill>
+                  <a:srgbClr val="0F1A2B"/>
+                </a:solidFill>
+                <a:latin typeface="Calibri"/>
+              </a:rPr>
+              <a:t>Minimal reconciliation</a:t>
+            </a:r>
+            <a:r>
+              <a:rPr sz="1300" b="0">
+                <a:solidFill>
+                  <a:srgbClr val="5A6778"/>
+                </a:solidFill>
+                <a:latin typeface="Calibri"/>
+              </a:rPr>
+              <a:t> — the chain IS the book</a:t>
+            </a:r>
+          </a:p>
+          <a:p>
+            <a:pPr>
+              <a:lnSpc>
+                <a:spcPct val="105000"/>
+              </a:lnSpc>
+              <a:spcAft>
+                <a:spcPts val="800"/>
+              </a:spcAft>
+            </a:pPr>
+            <a:r>
+              <a:rPr sz="1300" b="1">
+                <a:solidFill>
+                  <a:srgbClr val="2D6CDF"/>
+                </a:solidFill>
+                <a:latin typeface="Calibri"/>
+              </a:rPr>
+              <a:t>▸ </a:t>
+            </a:r>
+            <a:r>
+              <a:rPr sz="1300" b="1">
+                <a:solidFill>
+                  <a:srgbClr val="0F1A2B"/>
+                </a:solidFill>
+                <a:latin typeface="Calibri"/>
+              </a:rPr>
+              <a:t>Reach limited</a:t>
+            </a:r>
+            <a:r>
+              <a:rPr sz="1300" b="0">
+                <a:solidFill>
+                  <a:srgbClr val="5A6778"/>
+                </a:solidFill>
+                <a:latin typeface="Calibri"/>
+              </a:rPr>
+              <a:t> to recognising jurisdictions</a:t>
+            </a:r>
+          </a:p>
+          <a:p>
+            <a:pPr>
+              <a:lnSpc>
+                <a:spcPct val="105000"/>
+              </a:lnSpc>
+              <a:spcAft>
+                <a:spcPts val="800"/>
+              </a:spcAft>
+            </a:pPr>
+            <a:r>
+              <a:rPr sz="1300" b="1">
+                <a:solidFill>
+                  <a:srgbClr val="2D6CDF"/>
+                </a:solidFill>
+                <a:latin typeface="Calibri"/>
+              </a:rPr>
+              <a:t>▸ </a:t>
+            </a:r>
+            <a:r>
+              <a:rPr sz="1300" b="1">
+                <a:solidFill>
+                  <a:srgbClr val="0F1A2B"/>
+                </a:solidFill>
+                <a:latin typeface="Calibri"/>
+              </a:rPr>
+              <a:t>Best:</a:t>
+            </a:r>
+            <a:r>
+              <a:rPr sz="1300" b="0">
+                <a:solidFill>
+                  <a:srgbClr val="5A6778"/>
+                </a:solidFill>
+                <a:latin typeface="Calibri"/>
+              </a:rPr>
+              <a:t> single friendly jurisdiction, full DLT-native finality</a:t>
+            </a:r>
+          </a:p>
+        </p:txBody>
+      </p:sp>
+      <p:sp>
+        <p:nvSpPr>
+          <p:cNvPr id="12" name="Rounded Rectangle 11"/>
+          <p:cNvSpPr/>
+          <p:nvPr/>
+        </p:nvSpPr>
+        <p:spPr>
+          <a:xfrm>
+            <a:off x="6126480" y="1828800"/>
+            <a:ext cx="5239512" cy="3977639"/>
+          </a:xfrm>
+          <a:prstGeom prst="roundRect">
+            <a:avLst/>
+          </a:prstGeom>
+          <a:solidFill>
+            <a:srgbClr val="FFFFFF"/>
+          </a:solidFill>
+          <a:ln w="19050">
+            <a:solidFill>
+              <a:srgbClr val="119DA4"/>
+            </a:solidFill>
+          </a:ln>
+          <a:effectLst/>
+        </p:spPr>
+        <p:style>
+          <a:lnRef idx="1">
+            <a:schemeClr val="accent1"/>
+          </a:lnRef>
+          <a:fillRef idx="3">
+            <a:schemeClr val="accent1"/>
+          </a:fillRef>
+          <a:effectRef idx="2">
+            <a:schemeClr val="accent1"/>
+          </a:effectRef>
+          <a:fontRef idx="minor">
+            <a:schemeClr val="lt1"/>
+          </a:fontRef>
+        </p:style>
+        <p:txBody>
+          <a:bodyPr rtlCol="0" anchor="ctr"/>
+          <a:lstStyle/>
+          <a:p>
+            <a:pPr algn="ctr"/>
+          </a:p>
+        </p:txBody>
+      </p:sp>
+      <p:sp>
+        <p:nvSpPr>
+          <p:cNvPr id="13" name="Round Same Side Corner Rectangle 12"/>
+          <p:cNvSpPr/>
+          <p:nvPr/>
+        </p:nvSpPr>
+        <p:spPr>
+          <a:xfrm>
+            <a:off x="6126480" y="1828800"/>
+            <a:ext cx="5239512" cy="502920"/>
+          </a:xfrm>
+          <a:prstGeom prst="round2SameRect">
+            <a:avLst/>
+          </a:prstGeom>
+          <a:solidFill>
+            <a:srgbClr val="119DA4"/>
+          </a:solidFill>
+          <a:ln>
+            <a:noFill/>
+          </a:ln>
+          <a:effectLst/>
+        </p:spPr>
+        <p:style>
+          <a:lnRef idx="1">
+            <a:schemeClr val="accent1"/>
+          </a:lnRef>
+          <a:fillRef idx="3">
+            <a:schemeClr val="accent1"/>
+          </a:fillRef>
+          <a:effectRef idx="2">
+            <a:schemeClr val="accent1"/>
+          </a:effectRef>
+          <a:fontRef idx="minor">
+            <a:schemeClr val="lt1"/>
+          </a:fontRef>
+        </p:style>
+        <p:txBody>
+          <a:bodyPr rtlCol="0" anchor="ctr"/>
+          <a:lstStyle/>
+          <a:p>
+            <a:pPr algn="ctr"/>
+          </a:p>
+        </p:txBody>
+      </p:sp>
+      <p:sp>
+        <p:nvSpPr>
+          <p:cNvPr id="14" name="TextBox 13"/>
+          <p:cNvSpPr txBox="1"/>
+          <p:nvPr/>
+        </p:nvSpPr>
+        <p:spPr>
+          <a:xfrm>
+            <a:off x="6309360" y="1901952"/>
+            <a:ext cx="4846320" cy="365760"/>
+          </a:xfrm>
+          <a:prstGeom prst="rect">
+            <a:avLst/>
+          </a:prstGeom>
+          <a:noFill/>
+        </p:spPr>
+        <p:txBody>
+          <a:bodyPr wrap="square" anchor="t" lIns="0" rIns="0" tIns="0" bIns="0">
+            <a:spAutoFit/>
+          </a:bodyPr>
+          <a:lstStyle/>
+          <a:p>
+            <a:pPr algn="l">
+              <a:lnSpc>
+                <a:spcPct val="100000"/>
+              </a:lnSpc>
+            </a:pPr>
+            <a:r>
+              <a:rPr sz="1500" b="1">
+                <a:solidFill>
+                  <a:srgbClr val="FFFFFF"/>
+                </a:solidFill>
+                <a:latin typeface="Calibri"/>
+              </a:rPr>
+              <a:t>B · Token is only the message</a:t>
+            </a:r>
+            <a:r>
+              <a:rPr sz="1100" b="1">
+                <a:solidFill>
+                  <a:srgbClr val="FFFFFF"/>
+                </a:solidFill>
+                <a:latin typeface="Calibri"/>
+              </a:rPr>
+              <a:t>   ✅ default</a:t>
+            </a:r>
+          </a:p>
+        </p:txBody>
+      </p:sp>
+      <p:sp>
+        <p:nvSpPr>
+          <p:cNvPr id="15" name="TextBox 14"/>
+          <p:cNvSpPr txBox="1"/>
+          <p:nvPr/>
+        </p:nvSpPr>
+        <p:spPr>
+          <a:xfrm>
+            <a:off x="6355080" y="2514600"/>
+            <a:ext cx="4800600" cy="3657600"/>
+          </a:xfrm>
+          <a:prstGeom prst="rect">
+            <a:avLst/>
+          </a:prstGeom>
+          <a:noFill/>
+        </p:spPr>
+        <p:txBody>
+          <a:bodyPr wrap="square" lIns="0" tIns="0">
+            <a:spAutoFit/>
+          </a:bodyPr>
+          <a:lstStyle/>
+          <a:p>
+            <a:pPr>
+              <a:lnSpc>
+                <a:spcPct val="105000"/>
+              </a:lnSpc>
+              <a:spcAft>
+                <a:spcPts val="800"/>
+              </a:spcAft>
+            </a:pPr>
+            <a:r>
+              <a:rPr sz="1300" b="1">
+                <a:solidFill>
+                  <a:srgbClr val="119DA4"/>
+                </a:solidFill>
+                <a:latin typeface="Calibri"/>
+              </a:rPr>
+              <a:t>▸ </a:t>
+            </a:r>
+            <a:r>
+              <a:rPr sz="1300" b="1">
+                <a:solidFill>
+                  <a:srgbClr val="0F1A2B"/>
+                </a:solidFill>
+                <a:latin typeface="Calibri"/>
+              </a:rPr>
+              <a:t>Register stays at transfer agent</a:t>
+            </a:r>
+            <a:r>
+              <a:rPr sz="1300" b="0">
+                <a:solidFill>
+                  <a:srgbClr val="5A6778"/>
+                </a:solidFill>
+                <a:latin typeface="Calibri"/>
+              </a:rPr>
+              <a:t> — TA book = legal truth</a:t>
+            </a:r>
+          </a:p>
+          <a:p>
+            <a:pPr>
+              <a:lnSpc>
+                <a:spcPct val="105000"/>
+              </a:lnSpc>
+              <a:spcAft>
+                <a:spcPts val="800"/>
+              </a:spcAft>
+            </a:pPr>
+            <a:r>
+              <a:rPr sz="1300" b="1">
+                <a:solidFill>
+                  <a:srgbClr val="119DA4"/>
+                </a:solidFill>
+                <a:latin typeface="Calibri"/>
+              </a:rPr>
+              <a:t>▸ </a:t>
+            </a:r>
+            <a:r>
+              <a:rPr sz="1300" b="1">
+                <a:solidFill>
+                  <a:srgbClr val="0F1A2B"/>
+                </a:solidFill>
+                <a:latin typeface="Calibri"/>
+              </a:rPr>
+              <a:t>Needs no DLT securities law</a:t>
+            </a:r>
+            <a:r>
+              <a:rPr sz="1300" b="0">
+                <a:solidFill>
+                  <a:srgbClr val="5A6778"/>
+                </a:solidFill>
+                <a:latin typeface="Calibri"/>
+              </a:rPr>
+              <a:t> — deploy anywhere, US in scope</a:t>
+            </a:r>
+          </a:p>
+          <a:p>
+            <a:pPr>
+              <a:lnSpc>
+                <a:spcPct val="105000"/>
+              </a:lnSpc>
+              <a:spcAft>
+                <a:spcPts val="800"/>
+              </a:spcAft>
+            </a:pPr>
+            <a:r>
+              <a:rPr sz="1300" b="1">
+                <a:solidFill>
+                  <a:srgbClr val="119DA4"/>
+                </a:solidFill>
+                <a:latin typeface="Calibri"/>
+              </a:rPr>
+              <a:t>▸ </a:t>
+            </a:r>
+            <a:r>
+              <a:rPr sz="1300" b="1">
+                <a:solidFill>
+                  <a:srgbClr val="0F1A2B"/>
+                </a:solidFill>
+                <a:latin typeface="Calibri"/>
+              </a:rPr>
+              <a:t>Chain ↔ TA book reconcile</a:t>
+            </a:r>
+            <a:r>
+              <a:rPr sz="1300" b="0">
+                <a:solidFill>
+                  <a:srgbClr val="5A6778"/>
+                </a:solidFill>
+                <a:latin typeface="Calibri"/>
+              </a:rPr>
+              <a:t> — chain = operational truth</a:t>
+            </a:r>
+          </a:p>
+          <a:p>
+            <a:pPr>
+              <a:lnSpc>
+                <a:spcPct val="105000"/>
+              </a:lnSpc>
+              <a:spcAft>
+                <a:spcPts val="800"/>
+              </a:spcAft>
+            </a:pPr>
+            <a:r>
+              <a:rPr sz="1300" b="1">
+                <a:solidFill>
+                  <a:srgbClr val="119DA4"/>
+                </a:solidFill>
+                <a:latin typeface="Calibri"/>
+              </a:rPr>
+              <a:t>▸ </a:t>
+            </a:r>
+            <a:r>
+              <a:rPr sz="1300" b="1">
+                <a:solidFill>
+                  <a:srgbClr val="0F1A2B"/>
+                </a:solidFill>
+                <a:latin typeface="Calibri"/>
+              </a:rPr>
+              <a:t>Broad cross-border reach</a:t>
+            </a:r>
+            <a:r>
+              <a:rPr sz="1300" b="0">
+                <a:solidFill>
+                  <a:srgbClr val="5A6778"/>
+                </a:solidFill>
+                <a:latin typeface="Calibri"/>
+              </a:rPr>
+              <a:t> — conventional security everywhere</a:t>
+            </a:r>
+          </a:p>
+          <a:p>
+            <a:pPr>
+              <a:lnSpc>
+                <a:spcPct val="105000"/>
+              </a:lnSpc>
+              <a:spcAft>
+                <a:spcPts val="800"/>
+              </a:spcAft>
+            </a:pPr>
+            <a:r>
+              <a:rPr sz="1300" b="1">
+                <a:solidFill>
+                  <a:srgbClr val="119DA4"/>
+                </a:solidFill>
+                <a:latin typeface="Calibri"/>
+              </a:rPr>
+              <a:t>▸ </a:t>
+            </a:r>
+            <a:r>
+              <a:rPr sz="1300" b="1">
+                <a:solidFill>
+                  <a:srgbClr val="0F1A2B"/>
+                </a:solidFill>
+                <a:latin typeface="Calibri"/>
+              </a:rPr>
+              <a:t>Best:</a:t>
+            </a:r>
+            <a:r>
+              <a:rPr sz="1300" b="0">
+                <a:solidFill>
+                  <a:srgbClr val="5A6778"/>
+                </a:solidFill>
+                <a:latin typeface="Calibri"/>
+              </a:rPr>
+              <a:t> multi-jurisdiction rollout, minimise legal novelty</a:t>
+            </a:r>
+          </a:p>
+        </p:txBody>
+      </p:sp>
+      <p:sp>
+        <p:nvSpPr>
+          <p:cNvPr id="16" name="TextBox 15"/>
+          <p:cNvSpPr txBox="1"/>
+          <p:nvPr/>
+        </p:nvSpPr>
+        <p:spPr>
+          <a:xfrm>
+            <a:off x="822960" y="5943600"/>
+            <a:ext cx="10515600" cy="640080"/>
+          </a:xfrm>
+          <a:prstGeom prst="rect">
+            <a:avLst/>
+          </a:prstGeom>
+          <a:noFill/>
+        </p:spPr>
+        <p:txBody>
+          <a:bodyPr wrap="square" anchor="t" lIns="0" rIns="0" tIns="0" bIns="0">
+            <a:spAutoFit/>
+          </a:bodyPr>
+          <a:lstStyle/>
+          <a:p>
+            <a:pPr algn="l">
+              <a:lnSpc>
+                <a:spcPct val="100000"/>
+              </a:lnSpc>
+            </a:pPr>
+            <a:r>
+              <a:rPr sz="1300" b="1">
+                <a:solidFill>
+                  <a:srgbClr val="C8922B"/>
+                </a:solidFill>
+                <a:latin typeface="Calibri"/>
+              </a:rPr>
+              <a:t>Code &amp; FireFly orchestration are identical. </a:t>
+            </a:r>
+            <a:r>
+              <a:rPr sz="1300" b="0">
+                <a:solidFill>
+                  <a:srgbClr val="0F1A2B"/>
+                </a:solidFill>
+                <a:latin typeface="Calibri"/>
+              </a:rPr>
+              <a:t>Only the legal wrapper, reconciliation duty, and the “legal basis” matrix row change. For a cross-border TradFi→TradFi build, B is the natural default; reserve A for a Swiss-law (or EU-Pilot) issuance wanting on-chain title finality.</a:t>
+            </a:r>
+          </a:p>
+        </p:txBody>
+      </p:sp>
+    </p:spTree>
+  </p:cSld>
+  <p:clrMapOvr>
+    <a:masterClrMapping/>
+  </p:clrMapOvr>
+</p:sld>
+</file>
+
+<file path=ppt/slides/slide13.xml><?xml version="1.0" encoding="utf-8"?>
 <p:sld xmlns:a="http://schemas.openxmlformats.org/drawingml/2006/main" xmlns:p="http://schemas.openxmlformats.org/presentationml/2006/main" xmlns:r="http://schemas.openxmlformats.org/officeDocument/2006/relationships">
   <p:cSld>
     <p:spTree>

</xml_diff>

<commit_message>
Add fiat-out sequence, Variant-B reconciler, and specialist-committee governance
- 4.2 reverse leg: on-chain event -> fiat-out (coupon/redemption) sequence
- 7.4 Variant-B reconciler: chain<->TA book equality + supply invariant, pause+alarm on divergence, on-chain recon-hash anchor
- 12 governance: specialist committee owns all ranked decisions; approval gated on-chain as a mint precondition
- Rankings in 4 and 11 reworded as committee-owned
- Deck: +3 slides (fiat-out, reconciler, committee) = 16 slides

Co-Authored-By: Claude Opus 4.8 (1M context) <noreply@anthropic.com>
</commit_message>
<xml_diff>
--- a/RCN-CMTAT-FireFly-Gateway.pptx
+++ b/RCN-CMTAT-FireFly-Gateway.pptx
@@ -18,6 +18,9 @@
     <p:sldId id="266" r:id="rId17"/>
     <p:sldId id="267" r:id="rId18"/>
     <p:sldId id="268" r:id="rId19"/>
+    <p:sldId id="269" r:id="rId20"/>
+    <p:sldId id="270" r:id="rId21"/>
+    <p:sldId id="271" r:id="rId22"/>
   </p:sldIdLst>
   <p:sldSz cx="12191695" cy="6858000" type="screen4x3"/>
   <p:notesSz cx="6858000" cy="9144000"/>
@@ -6522,7 +6525,7 @@
                 </a:solidFill>
                 <a:latin typeface="Calibri"/>
               </a:rPr>
-              <a:t>PICK ONE PER ISSUANCE</a:t>
+              <a:t>COUPON &amp; REDEMPTION</a:t>
             </a:r>
           </a:p>
         </p:txBody>
@@ -6561,7 +6564,7 @@
                 </a:solidFill>
                 <a:latin typeface="Calibri"/>
               </a:rPr>
-              <a:t>Design fork — is the token the register, or just the message?</a:t>
+              <a:t>Reverse leg — on-chain event → fiat-out</a:t>
             </a:r>
           </a:p>
         </p:txBody>
@@ -6645,6 +6648,2852 @@
                 <a:latin typeface="Calibri"/>
               </a:rPr>
               <a:t>12</a:t>
+            </a:r>
+          </a:p>
+        </p:txBody>
+      </p:sp>
+      <p:sp>
+        <p:nvSpPr>
+          <p:cNvPr id="8" name="Rounded Rectangle 7"/>
+          <p:cNvSpPr/>
+          <p:nvPr/>
+        </p:nvSpPr>
+        <p:spPr>
+          <a:xfrm>
+            <a:off x="228600" y="1645920"/>
+            <a:ext cx="1554480" cy="457200"/>
+          </a:xfrm>
+          <a:prstGeom prst="roundRect">
+            <a:avLst/>
+          </a:prstGeom>
+          <a:solidFill>
+            <a:srgbClr val="119DA4"/>
+          </a:solidFill>
+          <a:ln>
+            <a:noFill/>
+          </a:ln>
+          <a:effectLst/>
+        </p:spPr>
+        <p:style>
+          <a:lnRef idx="1">
+            <a:schemeClr val="accent1"/>
+          </a:lnRef>
+          <a:fillRef idx="3">
+            <a:schemeClr val="accent1"/>
+          </a:fillRef>
+          <a:effectRef idx="2">
+            <a:schemeClr val="accent1"/>
+          </a:effectRef>
+          <a:fontRef idx="minor">
+            <a:schemeClr val="lt1"/>
+          </a:fontRef>
+        </p:style>
+        <p:txBody>
+          <a:bodyPr rtlCol="0" anchor="ctr"/>
+          <a:lstStyle/>
+          <a:p>
+            <a:pPr algn="ctr"/>
+          </a:p>
+        </p:txBody>
+      </p:sp>
+      <p:sp>
+        <p:nvSpPr>
+          <p:cNvPr id="9" name="TextBox 8"/>
+          <p:cNvSpPr txBox="1"/>
+          <p:nvPr/>
+        </p:nvSpPr>
+        <p:spPr>
+          <a:xfrm>
+            <a:off x="228600" y="1673352"/>
+            <a:ext cx="1554480" cy="411480"/>
+          </a:xfrm>
+          <a:prstGeom prst="rect">
+            <a:avLst/>
+          </a:prstGeom>
+          <a:noFill/>
+        </p:spPr>
+        <p:txBody>
+          <a:bodyPr wrap="square" anchor="ctr" lIns="0" rIns="0" tIns="0" bIns="0">
+            <a:spAutoFit/>
+          </a:bodyPr>
+          <a:lstStyle/>
+          <a:p>
+            <a:pPr algn="ctr">
+              <a:lnSpc>
+                <a:spcPct val="90000"/>
+              </a:lnSpc>
+            </a:pPr>
+            <a:r>
+              <a:rPr sz="1050" b="1">
+                <a:solidFill>
+                  <a:srgbClr val="FFFFFF"/>
+                </a:solidFill>
+                <a:latin typeface="Calibri"/>
+              </a:rPr>
+              <a:t>CMTAT
+Token</a:t>
+            </a:r>
+          </a:p>
+        </p:txBody>
+      </p:sp>
+      <p:sp>
+        <p:nvSpPr>
+          <p:cNvPr id="10" name="Rectangle 9"/>
+          <p:cNvSpPr/>
+          <p:nvPr/>
+        </p:nvSpPr>
+        <p:spPr>
+          <a:xfrm>
+            <a:off x="1000353" y="2148840"/>
+            <a:ext cx="10972" cy="3703320"/>
+          </a:xfrm>
+          <a:prstGeom prst="rect">
+            <a:avLst/>
+          </a:prstGeom>
+          <a:solidFill>
+            <a:srgbClr val="D9DFE7"/>
+          </a:solidFill>
+          <a:ln>
+            <a:noFill/>
+          </a:ln>
+          <a:effectLst/>
+        </p:spPr>
+        <p:style>
+          <a:lnRef idx="1">
+            <a:schemeClr val="accent1"/>
+          </a:lnRef>
+          <a:fillRef idx="3">
+            <a:schemeClr val="accent1"/>
+          </a:fillRef>
+          <a:effectRef idx="2">
+            <a:schemeClr val="accent1"/>
+          </a:effectRef>
+          <a:fontRef idx="minor">
+            <a:schemeClr val="lt1"/>
+          </a:fontRef>
+        </p:style>
+        <p:txBody>
+          <a:bodyPr rtlCol="0" anchor="ctr"/>
+          <a:lstStyle/>
+          <a:p>
+            <a:pPr algn="ctr"/>
+          </a:p>
+        </p:txBody>
+      </p:sp>
+      <p:sp>
+        <p:nvSpPr>
+          <p:cNvPr id="11" name="Rounded Rectangle 10"/>
+          <p:cNvSpPr/>
+          <p:nvPr/>
+        </p:nvSpPr>
+        <p:spPr>
+          <a:xfrm>
+            <a:off x="2258568" y="1645920"/>
+            <a:ext cx="1554480" cy="457200"/>
+          </a:xfrm>
+          <a:prstGeom prst="roundRect">
+            <a:avLst/>
+          </a:prstGeom>
+          <a:solidFill>
+            <a:srgbClr val="119DA4"/>
+          </a:solidFill>
+          <a:ln>
+            <a:noFill/>
+          </a:ln>
+          <a:effectLst/>
+        </p:spPr>
+        <p:style>
+          <a:lnRef idx="1">
+            <a:schemeClr val="accent1"/>
+          </a:lnRef>
+          <a:fillRef idx="3">
+            <a:schemeClr val="accent1"/>
+          </a:fillRef>
+          <a:effectRef idx="2">
+            <a:schemeClr val="accent1"/>
+          </a:effectRef>
+          <a:fontRef idx="minor">
+            <a:schemeClr val="lt1"/>
+          </a:fontRef>
+        </p:style>
+        <p:txBody>
+          <a:bodyPr rtlCol="0" anchor="ctr"/>
+          <a:lstStyle/>
+          <a:p>
+            <a:pPr algn="ctr"/>
+          </a:p>
+        </p:txBody>
+      </p:sp>
+      <p:sp>
+        <p:nvSpPr>
+          <p:cNvPr id="12" name="TextBox 11"/>
+          <p:cNvSpPr txBox="1"/>
+          <p:nvPr/>
+        </p:nvSpPr>
+        <p:spPr>
+          <a:xfrm>
+            <a:off x="2258568" y="1673352"/>
+            <a:ext cx="1554480" cy="411480"/>
+          </a:xfrm>
+          <a:prstGeom prst="rect">
+            <a:avLst/>
+          </a:prstGeom>
+          <a:noFill/>
+        </p:spPr>
+        <p:txBody>
+          <a:bodyPr wrap="square" anchor="ctr" lIns="0" rIns="0" tIns="0" bIns="0">
+            <a:spAutoFit/>
+          </a:bodyPr>
+          <a:lstStyle/>
+          <a:p>
+            <a:pPr algn="ctr">
+              <a:lnSpc>
+                <a:spcPct val="90000"/>
+              </a:lnSpc>
+            </a:pPr>
+            <a:r>
+              <a:rPr sz="1050" b="1">
+                <a:solidFill>
+                  <a:srgbClr val="FFFFFF"/>
+                </a:solidFill>
+                <a:latin typeface="Calibri"/>
+              </a:rPr>
+              <a:t>FireFly</a:t>
+            </a:r>
+          </a:p>
+        </p:txBody>
+      </p:sp>
+      <p:sp>
+        <p:nvSpPr>
+          <p:cNvPr id="13" name="Rectangle 12"/>
+          <p:cNvSpPr/>
+          <p:nvPr/>
+        </p:nvSpPr>
+        <p:spPr>
+          <a:xfrm>
+            <a:off x="3030321" y="2148840"/>
+            <a:ext cx="10972" cy="3703320"/>
+          </a:xfrm>
+          <a:prstGeom prst="rect">
+            <a:avLst/>
+          </a:prstGeom>
+          <a:solidFill>
+            <a:srgbClr val="D9DFE7"/>
+          </a:solidFill>
+          <a:ln>
+            <a:noFill/>
+          </a:ln>
+          <a:effectLst/>
+        </p:spPr>
+        <p:style>
+          <a:lnRef idx="1">
+            <a:schemeClr val="accent1"/>
+          </a:lnRef>
+          <a:fillRef idx="3">
+            <a:schemeClr val="accent1"/>
+          </a:fillRef>
+          <a:effectRef idx="2">
+            <a:schemeClr val="accent1"/>
+          </a:effectRef>
+          <a:fontRef idx="minor">
+            <a:schemeClr val="lt1"/>
+          </a:fontRef>
+        </p:style>
+        <p:txBody>
+          <a:bodyPr rtlCol="0" anchor="ctr"/>
+          <a:lstStyle/>
+          <a:p>
+            <a:pPr algn="ctr"/>
+          </a:p>
+        </p:txBody>
+      </p:sp>
+      <p:sp>
+        <p:nvSpPr>
+          <p:cNvPr id="14" name="Rounded Rectangle 13"/>
+          <p:cNvSpPr/>
+          <p:nvPr/>
+        </p:nvSpPr>
+        <p:spPr>
+          <a:xfrm>
+            <a:off x="4288536" y="1645920"/>
+            <a:ext cx="1554480" cy="457200"/>
+          </a:xfrm>
+          <a:prstGeom prst="roundRect">
+            <a:avLst/>
+          </a:prstGeom>
+          <a:solidFill>
+            <a:srgbClr val="119DA4"/>
+          </a:solidFill>
+          <a:ln>
+            <a:noFill/>
+          </a:ln>
+          <a:effectLst/>
+        </p:spPr>
+        <p:style>
+          <a:lnRef idx="1">
+            <a:schemeClr val="accent1"/>
+          </a:lnRef>
+          <a:fillRef idx="3">
+            <a:schemeClr val="accent1"/>
+          </a:fillRef>
+          <a:effectRef idx="2">
+            <a:schemeClr val="accent1"/>
+          </a:effectRef>
+          <a:fontRef idx="minor">
+            <a:schemeClr val="lt1"/>
+          </a:fontRef>
+        </p:style>
+        <p:txBody>
+          <a:bodyPr rtlCol="0" anchor="ctr"/>
+          <a:lstStyle/>
+          <a:p>
+            <a:pPr algn="ctr"/>
+          </a:p>
+        </p:txBody>
+      </p:sp>
+      <p:sp>
+        <p:nvSpPr>
+          <p:cNvPr id="15" name="TextBox 14"/>
+          <p:cNvSpPr txBox="1"/>
+          <p:nvPr/>
+        </p:nvSpPr>
+        <p:spPr>
+          <a:xfrm>
+            <a:off x="4288536" y="1673352"/>
+            <a:ext cx="1554480" cy="411480"/>
+          </a:xfrm>
+          <a:prstGeom prst="rect">
+            <a:avLst/>
+          </a:prstGeom>
+          <a:noFill/>
+        </p:spPr>
+        <p:txBody>
+          <a:bodyPr wrap="square" anchor="ctr" lIns="0" rIns="0" tIns="0" bIns="0">
+            <a:spAutoFit/>
+          </a:bodyPr>
+          <a:lstStyle/>
+          <a:p>
+            <a:pPr algn="ctr">
+              <a:lnSpc>
+                <a:spcPct val="90000"/>
+              </a:lnSpc>
+            </a:pPr>
+            <a:r>
+              <a:rPr sz="1050" b="1">
+                <a:solidFill>
+                  <a:srgbClr val="FFFFFF"/>
+                </a:solidFill>
+                <a:latin typeface="Calibri"/>
+              </a:rPr>
+              <a:t>Recon /
+Idemp.</a:t>
+            </a:r>
+          </a:p>
+        </p:txBody>
+      </p:sp>
+      <p:sp>
+        <p:nvSpPr>
+          <p:cNvPr id="16" name="Rectangle 15"/>
+          <p:cNvSpPr/>
+          <p:nvPr/>
+        </p:nvSpPr>
+        <p:spPr>
+          <a:xfrm>
+            <a:off x="5060289" y="2148840"/>
+            <a:ext cx="10972" cy="3703320"/>
+          </a:xfrm>
+          <a:prstGeom prst="rect">
+            <a:avLst/>
+          </a:prstGeom>
+          <a:solidFill>
+            <a:srgbClr val="D9DFE7"/>
+          </a:solidFill>
+          <a:ln>
+            <a:noFill/>
+          </a:ln>
+          <a:effectLst/>
+        </p:spPr>
+        <p:style>
+          <a:lnRef idx="1">
+            <a:schemeClr val="accent1"/>
+          </a:lnRef>
+          <a:fillRef idx="3">
+            <a:schemeClr val="accent1"/>
+          </a:fillRef>
+          <a:effectRef idx="2">
+            <a:schemeClr val="accent1"/>
+          </a:effectRef>
+          <a:fontRef idx="minor">
+            <a:schemeClr val="lt1"/>
+          </a:fontRef>
+        </p:style>
+        <p:txBody>
+          <a:bodyPr rtlCol="0" anchor="ctr"/>
+          <a:lstStyle/>
+          <a:p>
+            <a:pPr algn="ctr"/>
+          </a:p>
+        </p:txBody>
+      </p:sp>
+      <p:sp>
+        <p:nvSpPr>
+          <p:cNvPr id="17" name="Rounded Rectangle 16"/>
+          <p:cNvSpPr/>
+          <p:nvPr/>
+        </p:nvSpPr>
+        <p:spPr>
+          <a:xfrm>
+            <a:off x="6318504" y="1645920"/>
+            <a:ext cx="1554480" cy="457200"/>
+          </a:xfrm>
+          <a:prstGeom prst="roundRect">
+            <a:avLst/>
+          </a:prstGeom>
+          <a:solidFill>
+            <a:srgbClr val="119DA4"/>
+          </a:solidFill>
+          <a:ln>
+            <a:noFill/>
+          </a:ln>
+          <a:effectLst/>
+        </p:spPr>
+        <p:style>
+          <a:lnRef idx="1">
+            <a:schemeClr val="accent1"/>
+          </a:lnRef>
+          <a:fillRef idx="3">
+            <a:schemeClr val="accent1"/>
+          </a:fillRef>
+          <a:effectRef idx="2">
+            <a:schemeClr val="accent1"/>
+          </a:effectRef>
+          <a:fontRef idx="minor">
+            <a:schemeClr val="lt1"/>
+          </a:fontRef>
+        </p:style>
+        <p:txBody>
+          <a:bodyPr rtlCol="0" anchor="ctr"/>
+          <a:lstStyle/>
+          <a:p>
+            <a:pPr algn="ctr"/>
+          </a:p>
+        </p:txBody>
+      </p:sp>
+      <p:sp>
+        <p:nvSpPr>
+          <p:cNvPr id="18" name="TextBox 17"/>
+          <p:cNvSpPr txBox="1"/>
+          <p:nvPr/>
+        </p:nvSpPr>
+        <p:spPr>
+          <a:xfrm>
+            <a:off x="6318504" y="1673352"/>
+            <a:ext cx="1554480" cy="411480"/>
+          </a:xfrm>
+          <a:prstGeom prst="rect">
+            <a:avLst/>
+          </a:prstGeom>
+          <a:noFill/>
+        </p:spPr>
+        <p:txBody>
+          <a:bodyPr wrap="square" anchor="ctr" lIns="0" rIns="0" tIns="0" bIns="0">
+            <a:spAutoFit/>
+          </a:bodyPr>
+          <a:lstStyle/>
+          <a:p>
+            <a:pPr algn="ctr">
+              <a:lnSpc>
+                <a:spcPct val="90000"/>
+              </a:lnSpc>
+            </a:pPr>
+            <a:r>
+              <a:rPr sz="1050" b="1">
+                <a:solidFill>
+                  <a:srgbClr val="FFFFFF"/>
+                </a:solidFill>
+                <a:latin typeface="Calibri"/>
+              </a:rPr>
+              <a:t>Payout
+Engine</a:t>
+            </a:r>
+          </a:p>
+        </p:txBody>
+      </p:sp>
+      <p:sp>
+        <p:nvSpPr>
+          <p:cNvPr id="19" name="Rectangle 18"/>
+          <p:cNvSpPr/>
+          <p:nvPr/>
+        </p:nvSpPr>
+        <p:spPr>
+          <a:xfrm>
+            <a:off x="7090257" y="2148840"/>
+            <a:ext cx="10972" cy="3703320"/>
+          </a:xfrm>
+          <a:prstGeom prst="rect">
+            <a:avLst/>
+          </a:prstGeom>
+          <a:solidFill>
+            <a:srgbClr val="D9DFE7"/>
+          </a:solidFill>
+          <a:ln>
+            <a:noFill/>
+          </a:ln>
+          <a:effectLst/>
+        </p:spPr>
+        <p:style>
+          <a:lnRef idx="1">
+            <a:schemeClr val="accent1"/>
+          </a:lnRef>
+          <a:fillRef idx="3">
+            <a:schemeClr val="accent1"/>
+          </a:fillRef>
+          <a:effectRef idx="2">
+            <a:schemeClr val="accent1"/>
+          </a:effectRef>
+          <a:fontRef idx="minor">
+            <a:schemeClr val="lt1"/>
+          </a:fontRef>
+        </p:style>
+        <p:txBody>
+          <a:bodyPr rtlCol="0" anchor="ctr"/>
+          <a:lstStyle/>
+          <a:p>
+            <a:pPr algn="ctr"/>
+          </a:p>
+        </p:txBody>
+      </p:sp>
+      <p:sp>
+        <p:nvSpPr>
+          <p:cNvPr id="20" name="Rounded Rectangle 19"/>
+          <p:cNvSpPr/>
+          <p:nvPr/>
+        </p:nvSpPr>
+        <p:spPr>
+          <a:xfrm>
+            <a:off x="8348471" y="1645920"/>
+            <a:ext cx="1554480" cy="457200"/>
+          </a:xfrm>
+          <a:prstGeom prst="roundRect">
+            <a:avLst/>
+          </a:prstGeom>
+          <a:solidFill>
+            <a:srgbClr val="119DA4"/>
+          </a:solidFill>
+          <a:ln>
+            <a:noFill/>
+          </a:ln>
+          <a:effectLst/>
+        </p:spPr>
+        <p:style>
+          <a:lnRef idx="1">
+            <a:schemeClr val="accent1"/>
+          </a:lnRef>
+          <a:fillRef idx="3">
+            <a:schemeClr val="accent1"/>
+          </a:fillRef>
+          <a:effectRef idx="2">
+            <a:schemeClr val="accent1"/>
+          </a:effectRef>
+          <a:fontRef idx="minor">
+            <a:schemeClr val="lt1"/>
+          </a:fontRef>
+        </p:style>
+        <p:txBody>
+          <a:bodyPr rtlCol="0" anchor="ctr"/>
+          <a:lstStyle/>
+          <a:p>
+            <a:pPr algn="ctr"/>
+          </a:p>
+        </p:txBody>
+      </p:sp>
+      <p:sp>
+        <p:nvSpPr>
+          <p:cNvPr id="21" name="TextBox 20"/>
+          <p:cNvSpPr txBox="1"/>
+          <p:nvPr/>
+        </p:nvSpPr>
+        <p:spPr>
+          <a:xfrm>
+            <a:off x="8348471" y="1673352"/>
+            <a:ext cx="1554480" cy="411480"/>
+          </a:xfrm>
+          <a:prstGeom prst="rect">
+            <a:avLst/>
+          </a:prstGeom>
+          <a:noFill/>
+        </p:spPr>
+        <p:txBody>
+          <a:bodyPr wrap="square" anchor="ctr" lIns="0" rIns="0" tIns="0" bIns="0">
+            <a:spAutoFit/>
+          </a:bodyPr>
+          <a:lstStyle/>
+          <a:p>
+            <a:pPr algn="ctr">
+              <a:lnSpc>
+                <a:spcPct val="90000"/>
+              </a:lnSpc>
+            </a:pPr>
+            <a:r>
+              <a:rPr sz="1050" b="1">
+                <a:solidFill>
+                  <a:srgbClr val="FFFFFF"/>
+                </a:solidFill>
+                <a:latin typeface="Calibri"/>
+              </a:rPr>
+              <a:t>Settlement
+Bank</a:t>
+            </a:r>
+          </a:p>
+        </p:txBody>
+      </p:sp>
+      <p:sp>
+        <p:nvSpPr>
+          <p:cNvPr id="22" name="Rectangle 21"/>
+          <p:cNvSpPr/>
+          <p:nvPr/>
+        </p:nvSpPr>
+        <p:spPr>
+          <a:xfrm>
+            <a:off x="9120225" y="2148840"/>
+            <a:ext cx="10972" cy="3703320"/>
+          </a:xfrm>
+          <a:prstGeom prst="rect">
+            <a:avLst/>
+          </a:prstGeom>
+          <a:solidFill>
+            <a:srgbClr val="D9DFE7"/>
+          </a:solidFill>
+          <a:ln>
+            <a:noFill/>
+          </a:ln>
+          <a:effectLst/>
+        </p:spPr>
+        <p:style>
+          <a:lnRef idx="1">
+            <a:schemeClr val="accent1"/>
+          </a:lnRef>
+          <a:fillRef idx="3">
+            <a:schemeClr val="accent1"/>
+          </a:fillRef>
+          <a:effectRef idx="2">
+            <a:schemeClr val="accent1"/>
+          </a:effectRef>
+          <a:fontRef idx="minor">
+            <a:schemeClr val="lt1"/>
+          </a:fontRef>
+        </p:style>
+        <p:txBody>
+          <a:bodyPr rtlCol="0" anchor="ctr"/>
+          <a:lstStyle/>
+          <a:p>
+            <a:pPr algn="ctr"/>
+          </a:p>
+        </p:txBody>
+      </p:sp>
+      <p:sp>
+        <p:nvSpPr>
+          <p:cNvPr id="23" name="Rounded Rectangle 22"/>
+          <p:cNvSpPr/>
+          <p:nvPr/>
+        </p:nvSpPr>
+        <p:spPr>
+          <a:xfrm>
+            <a:off x="10378439" y="1645920"/>
+            <a:ext cx="1554480" cy="457200"/>
+          </a:xfrm>
+          <a:prstGeom prst="roundRect">
+            <a:avLst/>
+          </a:prstGeom>
+          <a:solidFill>
+            <a:srgbClr val="119DA4"/>
+          </a:solidFill>
+          <a:ln>
+            <a:noFill/>
+          </a:ln>
+          <a:effectLst/>
+        </p:spPr>
+        <p:style>
+          <a:lnRef idx="1">
+            <a:schemeClr val="accent1"/>
+          </a:lnRef>
+          <a:fillRef idx="3">
+            <a:schemeClr val="accent1"/>
+          </a:fillRef>
+          <a:effectRef idx="2">
+            <a:schemeClr val="accent1"/>
+          </a:effectRef>
+          <a:fontRef idx="minor">
+            <a:schemeClr val="lt1"/>
+          </a:fontRef>
+        </p:style>
+        <p:txBody>
+          <a:bodyPr rtlCol="0" anchor="ctr"/>
+          <a:lstStyle/>
+          <a:p>
+            <a:pPr algn="ctr"/>
+          </a:p>
+        </p:txBody>
+      </p:sp>
+      <p:sp>
+        <p:nvSpPr>
+          <p:cNvPr id="24" name="TextBox 23"/>
+          <p:cNvSpPr txBox="1"/>
+          <p:nvPr/>
+        </p:nvSpPr>
+        <p:spPr>
+          <a:xfrm>
+            <a:off x="10378439" y="1673352"/>
+            <a:ext cx="1554480" cy="411480"/>
+          </a:xfrm>
+          <a:prstGeom prst="rect">
+            <a:avLst/>
+          </a:prstGeom>
+          <a:noFill/>
+        </p:spPr>
+        <p:txBody>
+          <a:bodyPr wrap="square" anchor="ctr" lIns="0" rIns="0" tIns="0" bIns="0">
+            <a:spAutoFit/>
+          </a:bodyPr>
+          <a:lstStyle/>
+          <a:p>
+            <a:pPr algn="ctr">
+              <a:lnSpc>
+                <a:spcPct val="90000"/>
+              </a:lnSpc>
+            </a:pPr>
+            <a:r>
+              <a:rPr sz="1050" b="1">
+                <a:solidFill>
+                  <a:srgbClr val="FFFFFF"/>
+                </a:solidFill>
+                <a:latin typeface="Calibri"/>
+              </a:rPr>
+              <a:t>Client</a:t>
+            </a:r>
+          </a:p>
+        </p:txBody>
+      </p:sp>
+      <p:sp>
+        <p:nvSpPr>
+          <p:cNvPr id="25" name="Rectangle 24"/>
+          <p:cNvSpPr/>
+          <p:nvPr/>
+        </p:nvSpPr>
+        <p:spPr>
+          <a:xfrm>
+            <a:off x="11150193" y="2148840"/>
+            <a:ext cx="10972" cy="3703320"/>
+          </a:xfrm>
+          <a:prstGeom prst="rect">
+            <a:avLst/>
+          </a:prstGeom>
+          <a:solidFill>
+            <a:srgbClr val="D9DFE7"/>
+          </a:solidFill>
+          <a:ln>
+            <a:noFill/>
+          </a:ln>
+          <a:effectLst/>
+        </p:spPr>
+        <p:style>
+          <a:lnRef idx="1">
+            <a:schemeClr val="accent1"/>
+          </a:lnRef>
+          <a:fillRef idx="3">
+            <a:schemeClr val="accent1"/>
+          </a:fillRef>
+          <a:effectRef idx="2">
+            <a:schemeClr val="accent1"/>
+          </a:effectRef>
+          <a:fontRef idx="minor">
+            <a:schemeClr val="lt1"/>
+          </a:fontRef>
+        </p:style>
+        <p:txBody>
+          <a:bodyPr rtlCol="0" anchor="ctr"/>
+          <a:lstStyle/>
+          <a:p>
+            <a:pPr algn="ctr"/>
+          </a:p>
+        </p:txBody>
+      </p:sp>
+      <p:sp>
+        <p:nvSpPr>
+          <p:cNvPr id="26" name="TextBox 25"/>
+          <p:cNvSpPr txBox="1"/>
+          <p:nvPr/>
+        </p:nvSpPr>
+        <p:spPr>
+          <a:xfrm>
+            <a:off x="228600" y="2395728"/>
+            <a:ext cx="2286000" cy="274320"/>
+          </a:xfrm>
+          <a:prstGeom prst="rect">
+            <a:avLst/>
+          </a:prstGeom>
+          <a:noFill/>
+        </p:spPr>
+        <p:txBody>
+          <a:bodyPr wrap="square" anchor="t" lIns="0" rIns="0" tIns="0" bIns="0">
+            <a:spAutoFit/>
+          </a:bodyPr>
+          <a:lstStyle/>
+          <a:p>
+            <a:pPr algn="l">
+              <a:lnSpc>
+                <a:spcPct val="100000"/>
+              </a:lnSpc>
+            </a:pPr>
+            <a:r>
+              <a:rPr sz="950" b="0">
+                <a:solidFill>
+                  <a:srgbClr val="5A6778"/>
+                </a:solidFill>
+                <a:latin typeface="Calibri"/>
+              </a:rPr>
+              <a:t>coupon date / maturity / autocall</a:t>
+            </a:r>
+          </a:p>
+        </p:txBody>
+      </p:sp>
+      <p:cxnSp>
+        <p:nvCxnSpPr>
+          <p:cNvPr id="27" name="Connector 26"/>
+          <p:cNvCxnSpPr/>
+          <p:nvPr/>
+        </p:nvCxnSpPr>
+        <p:spPr>
+          <a:xfrm>
+            <a:off x="1005840" y="2697480"/>
+            <a:ext cx="2029968" cy="0"/>
+          </a:xfrm>
+          <a:prstGeom prst="bentConnector3">
+            <a:avLst/>
+          </a:prstGeom>
+          <a:ln w="17780">
+            <a:prstDash val="dash"/>
+            <a:solidFill>
+              <a:srgbClr val="119DA4"/>
+            </a:solidFill>
+            <a:headEnd type="triangle" w="med" len="med"/>
+          </a:ln>
+        </p:spPr>
+        <p:style>
+          <a:lnRef idx="2">
+            <a:schemeClr val="accent1"/>
+          </a:lnRef>
+          <a:fillRef idx="0">
+            <a:schemeClr val="accent1"/>
+          </a:fillRef>
+          <a:effectRef idx="1">
+            <a:schemeClr val="accent1"/>
+          </a:effectRef>
+          <a:fontRef idx="minor">
+            <a:schemeClr val="tx1"/>
+          </a:fontRef>
+        </p:style>
+      </p:cxnSp>
+      <p:sp>
+        <p:nvSpPr>
+          <p:cNvPr id="28" name="TextBox 27"/>
+          <p:cNvSpPr txBox="1"/>
+          <p:nvPr/>
+        </p:nvSpPr>
+        <p:spPr>
+          <a:xfrm>
+            <a:off x="557783" y="2404872"/>
+            <a:ext cx="2926080" cy="274320"/>
+          </a:xfrm>
+          <a:prstGeom prst="rect">
+            <a:avLst/>
+          </a:prstGeom>
+          <a:noFill/>
+        </p:spPr>
+        <p:txBody>
+          <a:bodyPr wrap="square" anchor="t" lIns="0" rIns="0" tIns="0" bIns="0">
+            <a:spAutoFit/>
+          </a:bodyPr>
+          <a:lstStyle/>
+          <a:p>
+            <a:pPr algn="ctr">
+              <a:lnSpc>
+                <a:spcPct val="100000"/>
+              </a:lnSpc>
+            </a:pPr>
+            <a:r>
+              <a:rPr sz="1000" b="0">
+                <a:solidFill>
+                  <a:srgbClr val="119DA4"/>
+                </a:solidFill>
+                <a:latin typeface="Calibri"/>
+              </a:rPr>
+              <a:t>event: Snapshot / Redeemed</a:t>
+            </a:r>
+          </a:p>
+        </p:txBody>
+      </p:sp>
+      <p:cxnSp>
+        <p:nvCxnSpPr>
+          <p:cNvPr id="29" name="Connector 28"/>
+          <p:cNvCxnSpPr/>
+          <p:nvPr/>
+        </p:nvCxnSpPr>
+        <p:spPr>
+          <a:xfrm>
+            <a:off x="3035808" y="3108960"/>
+            <a:ext cx="2029967" cy="0"/>
+          </a:xfrm>
+          <a:prstGeom prst="bentConnector3">
+            <a:avLst/>
+          </a:prstGeom>
+          <a:ln w="17780">
+            <a:solidFill>
+              <a:srgbClr val="0F1A2B"/>
+            </a:solidFill>
+            <a:headEnd type="triangle" w="med" len="med"/>
+          </a:ln>
+        </p:spPr>
+        <p:style>
+          <a:lnRef idx="2">
+            <a:schemeClr val="accent1"/>
+          </a:lnRef>
+          <a:fillRef idx="0">
+            <a:schemeClr val="accent1"/>
+          </a:fillRef>
+          <a:effectRef idx="1">
+            <a:schemeClr val="accent1"/>
+          </a:effectRef>
+          <a:fontRef idx="minor">
+            <a:schemeClr val="tx1"/>
+          </a:fontRef>
+        </p:style>
+      </p:cxnSp>
+      <p:sp>
+        <p:nvSpPr>
+          <p:cNvPr id="30" name="TextBox 29"/>
+          <p:cNvSpPr txBox="1"/>
+          <p:nvPr/>
+        </p:nvSpPr>
+        <p:spPr>
+          <a:xfrm>
+            <a:off x="2587751" y="2816352"/>
+            <a:ext cx="2926080" cy="274320"/>
+          </a:xfrm>
+          <a:prstGeom prst="rect">
+            <a:avLst/>
+          </a:prstGeom>
+          <a:noFill/>
+        </p:spPr>
+        <p:txBody>
+          <a:bodyPr wrap="square" anchor="t" lIns="0" rIns="0" tIns="0" bIns="0">
+            <a:spAutoFit/>
+          </a:bodyPr>
+          <a:lstStyle/>
+          <a:p>
+            <a:pPr algn="ctr">
+              <a:lnSpc>
+                <a:spcPct val="100000"/>
+              </a:lnSpc>
+            </a:pPr>
+            <a:r>
+              <a:rPr sz="1000" b="0">
+                <a:solidFill>
+                  <a:srgbClr val="0F1A2B"/>
+                </a:solidFill>
+                <a:latin typeface="Calibri"/>
+              </a:rPr>
+              <a:t>deliver(eventId, holders)</a:t>
+            </a:r>
+          </a:p>
+        </p:txBody>
+      </p:sp>
+      <p:sp>
+        <p:nvSpPr>
+          <p:cNvPr id="31" name="TextBox 30"/>
+          <p:cNvSpPr txBox="1"/>
+          <p:nvPr/>
+        </p:nvSpPr>
+        <p:spPr>
+          <a:xfrm>
+            <a:off x="4288536" y="3337560"/>
+            <a:ext cx="1554480" cy="274320"/>
+          </a:xfrm>
+          <a:prstGeom prst="rect">
+            <a:avLst/>
+          </a:prstGeom>
+          <a:noFill/>
+        </p:spPr>
+        <p:txBody>
+          <a:bodyPr wrap="square" anchor="t" lIns="0" rIns="0" tIns="0" bIns="0">
+            <a:spAutoFit/>
+          </a:bodyPr>
+          <a:lstStyle/>
+          <a:p>
+            <a:pPr algn="ctr">
+              <a:lnSpc>
+                <a:spcPct val="100000"/>
+              </a:lnSpc>
+            </a:pPr>
+            <a:r>
+              <a:rPr sz="900" b="0">
+                <a:solidFill>
+                  <a:srgbClr val="5A6778"/>
+                </a:solidFill>
+                <a:latin typeface="Calibri"/>
+              </a:rPr>
+              <a:t>idempotency: eventId unpaid?</a:t>
+            </a:r>
+          </a:p>
+        </p:txBody>
+      </p:sp>
+      <p:cxnSp>
+        <p:nvCxnSpPr>
+          <p:cNvPr id="32" name="Connector 31"/>
+          <p:cNvCxnSpPr/>
+          <p:nvPr/>
+        </p:nvCxnSpPr>
+        <p:spPr>
+          <a:xfrm>
+            <a:off x="5065775" y="3794760"/>
+            <a:ext cx="2029969" cy="0"/>
+          </a:xfrm>
+          <a:prstGeom prst="bentConnector3">
+            <a:avLst/>
+          </a:prstGeom>
+          <a:ln w="17780">
+            <a:solidFill>
+              <a:srgbClr val="2D6CDF"/>
+            </a:solidFill>
+            <a:headEnd type="triangle" w="med" len="med"/>
+          </a:ln>
+        </p:spPr>
+        <p:style>
+          <a:lnRef idx="2">
+            <a:schemeClr val="accent1"/>
+          </a:lnRef>
+          <a:fillRef idx="0">
+            <a:schemeClr val="accent1"/>
+          </a:fillRef>
+          <a:effectRef idx="1">
+            <a:schemeClr val="accent1"/>
+          </a:effectRef>
+          <a:fontRef idx="minor">
+            <a:schemeClr val="tx1"/>
+          </a:fontRef>
+        </p:style>
+      </p:cxnSp>
+      <p:sp>
+        <p:nvSpPr>
+          <p:cNvPr id="33" name="TextBox 32"/>
+          <p:cNvSpPr txBox="1"/>
+          <p:nvPr/>
+        </p:nvSpPr>
+        <p:spPr>
+          <a:xfrm>
+            <a:off x="4617719" y="3502152"/>
+            <a:ext cx="2926080" cy="274320"/>
+          </a:xfrm>
+          <a:prstGeom prst="rect">
+            <a:avLst/>
+          </a:prstGeom>
+          <a:noFill/>
+        </p:spPr>
+        <p:txBody>
+          <a:bodyPr wrap="square" anchor="t" lIns="0" rIns="0" tIns="0" bIns="0">
+            <a:spAutoFit/>
+          </a:bodyPr>
+          <a:lstStyle/>
+          <a:p>
+            <a:pPr algn="ctr">
+              <a:lnSpc>
+                <a:spcPct val="100000"/>
+              </a:lnSpc>
+            </a:pPr>
+            <a:r>
+              <a:rPr sz="1000" b="0">
+                <a:solidFill>
+                  <a:srgbClr val="2D6CDF"/>
+                </a:solidFill>
+                <a:latin typeface="Calibri"/>
+              </a:rPr>
+              <a:t>computeCoupon / par per holder</a:t>
+            </a:r>
+          </a:p>
+        </p:txBody>
+      </p:sp>
+      <p:cxnSp>
+        <p:nvCxnSpPr>
+          <p:cNvPr id="34" name="Connector 33"/>
+          <p:cNvCxnSpPr/>
+          <p:nvPr/>
+        </p:nvCxnSpPr>
+        <p:spPr>
+          <a:xfrm>
+            <a:off x="7095744" y="4206240"/>
+            <a:ext cx="2029967" cy="0"/>
+          </a:xfrm>
+          <a:prstGeom prst="bentConnector3">
+            <a:avLst/>
+          </a:prstGeom>
+          <a:ln w="17780">
+            <a:solidFill>
+              <a:srgbClr val="2D6CDF"/>
+            </a:solidFill>
+            <a:headEnd type="triangle" w="med" len="med"/>
+          </a:ln>
+        </p:spPr>
+        <p:style>
+          <a:lnRef idx="2">
+            <a:schemeClr val="accent1"/>
+          </a:lnRef>
+          <a:fillRef idx="0">
+            <a:schemeClr val="accent1"/>
+          </a:fillRef>
+          <a:effectRef idx="1">
+            <a:schemeClr val="accent1"/>
+          </a:effectRef>
+          <a:fontRef idx="minor">
+            <a:schemeClr val="tx1"/>
+          </a:fontRef>
+        </p:style>
+      </p:cxnSp>
+      <p:sp>
+        <p:nvSpPr>
+          <p:cNvPr id="35" name="TextBox 34"/>
+          <p:cNvSpPr txBox="1"/>
+          <p:nvPr/>
+        </p:nvSpPr>
+        <p:spPr>
+          <a:xfrm>
+            <a:off x="6647688" y="3913631"/>
+            <a:ext cx="2926080" cy="274320"/>
+          </a:xfrm>
+          <a:prstGeom prst="rect">
+            <a:avLst/>
+          </a:prstGeom>
+          <a:noFill/>
+        </p:spPr>
+        <p:txBody>
+          <a:bodyPr wrap="square" anchor="t" lIns="0" rIns="0" tIns="0" bIns="0">
+            <a:spAutoFit/>
+          </a:bodyPr>
+          <a:lstStyle/>
+          <a:p>
+            <a:pPr algn="ctr">
+              <a:lnSpc>
+                <a:spcPct val="100000"/>
+              </a:lnSpc>
+            </a:pPr>
+            <a:r>
+              <a:rPr sz="1000" b="0">
+                <a:solidFill>
+                  <a:srgbClr val="2D6CDF"/>
+                </a:solidFill>
+                <a:latin typeface="Calibri"/>
+              </a:rPr>
+              <a:t>pacs.008 instant credit</a:t>
+            </a:r>
+          </a:p>
+        </p:txBody>
+      </p:sp>
+      <p:cxnSp>
+        <p:nvCxnSpPr>
+          <p:cNvPr id="36" name="Connector 35"/>
+          <p:cNvCxnSpPr/>
+          <p:nvPr/>
+        </p:nvCxnSpPr>
+        <p:spPr>
+          <a:xfrm>
+            <a:off x="9125711" y="4617720"/>
+            <a:ext cx="2029968" cy="0"/>
+          </a:xfrm>
+          <a:prstGeom prst="bentConnector3">
+            <a:avLst/>
+          </a:prstGeom>
+          <a:ln w="17780">
+            <a:solidFill>
+              <a:srgbClr val="C8922B"/>
+            </a:solidFill>
+            <a:headEnd type="triangle" w="med" len="med"/>
+          </a:ln>
+        </p:spPr>
+        <p:style>
+          <a:lnRef idx="2">
+            <a:schemeClr val="accent1"/>
+          </a:lnRef>
+          <a:fillRef idx="0">
+            <a:schemeClr val="accent1"/>
+          </a:fillRef>
+          <a:effectRef idx="1">
+            <a:schemeClr val="accent1"/>
+          </a:effectRef>
+          <a:fontRef idx="minor">
+            <a:schemeClr val="tx1"/>
+          </a:fontRef>
+        </p:style>
+      </p:cxnSp>
+      <p:sp>
+        <p:nvSpPr>
+          <p:cNvPr id="37" name="TextBox 36"/>
+          <p:cNvSpPr txBox="1"/>
+          <p:nvPr/>
+        </p:nvSpPr>
+        <p:spPr>
+          <a:xfrm>
+            <a:off x="8677655" y="4325112"/>
+            <a:ext cx="2926080" cy="274320"/>
+          </a:xfrm>
+          <a:prstGeom prst="rect">
+            <a:avLst/>
+          </a:prstGeom>
+          <a:noFill/>
+        </p:spPr>
+        <p:txBody>
+          <a:bodyPr wrap="square" anchor="t" lIns="0" rIns="0" tIns="0" bIns="0">
+            <a:spAutoFit/>
+          </a:bodyPr>
+          <a:lstStyle/>
+          <a:p>
+            <a:pPr algn="ctr">
+              <a:lnSpc>
+                <a:spcPct val="100000"/>
+              </a:lnSpc>
+            </a:pPr>
+            <a:r>
+              <a:rPr sz="1000" b="0">
+                <a:solidFill>
+                  <a:srgbClr val="C8922B"/>
+                </a:solidFill>
+                <a:latin typeface="Calibri"/>
+              </a:rPr>
+              <a:t>coupon / redemption par received</a:t>
+            </a:r>
+          </a:p>
+        </p:txBody>
+      </p:sp>
+      <p:cxnSp>
+        <p:nvCxnSpPr>
+          <p:cNvPr id="38" name="Connector 37"/>
+          <p:cNvCxnSpPr/>
+          <p:nvPr/>
+        </p:nvCxnSpPr>
+        <p:spPr>
+          <a:xfrm>
+            <a:off x="5065775" y="5029200"/>
+            <a:ext cx="4059936" cy="0"/>
+          </a:xfrm>
+          <a:prstGeom prst="bentConnector3">
+            <a:avLst/>
+          </a:prstGeom>
+          <a:ln w="17780">
+            <a:prstDash val="dash"/>
+            <a:solidFill>
+              <a:srgbClr val="119DA4"/>
+            </a:solidFill>
+            <a:tailEnd type="triangle" w="med" len="med"/>
+          </a:ln>
+        </p:spPr>
+        <p:style>
+          <a:lnRef idx="2">
+            <a:schemeClr val="accent1"/>
+          </a:lnRef>
+          <a:fillRef idx="0">
+            <a:schemeClr val="accent1"/>
+          </a:fillRef>
+          <a:effectRef idx="1">
+            <a:schemeClr val="accent1"/>
+          </a:effectRef>
+          <a:fontRef idx="minor">
+            <a:schemeClr val="tx1"/>
+          </a:fontRef>
+        </p:style>
+      </p:cxnSp>
+      <p:sp>
+        <p:nvSpPr>
+          <p:cNvPr id="39" name="TextBox 38"/>
+          <p:cNvSpPr txBox="1"/>
+          <p:nvPr/>
+        </p:nvSpPr>
+        <p:spPr>
+          <a:xfrm>
+            <a:off x="5632703" y="4736592"/>
+            <a:ext cx="2926080" cy="274320"/>
+          </a:xfrm>
+          <a:prstGeom prst="rect">
+            <a:avLst/>
+          </a:prstGeom>
+          <a:noFill/>
+        </p:spPr>
+        <p:txBody>
+          <a:bodyPr wrap="square" anchor="t" lIns="0" rIns="0" tIns="0" bIns="0">
+            <a:spAutoFit/>
+          </a:bodyPr>
+          <a:lstStyle/>
+          <a:p>
+            <a:pPr algn="ctr">
+              <a:lnSpc>
+                <a:spcPct val="100000"/>
+              </a:lnSpc>
+            </a:pPr>
+            <a:r>
+              <a:rPr sz="1000" b="0">
+                <a:solidFill>
+                  <a:srgbClr val="119DA4"/>
+                </a:solidFill>
+                <a:latin typeface="Calibri"/>
+              </a:rPr>
+              <a:t>pacs.002 payout finality</a:t>
+            </a:r>
+          </a:p>
+        </p:txBody>
+      </p:sp>
+      <p:sp>
+        <p:nvSpPr>
+          <p:cNvPr id="40" name="TextBox 39"/>
+          <p:cNvSpPr txBox="1"/>
+          <p:nvPr/>
+        </p:nvSpPr>
+        <p:spPr>
+          <a:xfrm>
+            <a:off x="4288536" y="5138928"/>
+            <a:ext cx="1554480" cy="274320"/>
+          </a:xfrm>
+          <a:prstGeom prst="rect">
+            <a:avLst/>
+          </a:prstGeom>
+          <a:noFill/>
+        </p:spPr>
+        <p:txBody>
+          <a:bodyPr wrap="square" anchor="t" lIns="0" rIns="0" tIns="0" bIns="0">
+            <a:spAutoFit/>
+          </a:bodyPr>
+          <a:lstStyle/>
+          <a:p>
+            <a:pPr algn="ctr">
+              <a:lnSpc>
+                <a:spcPct val="100000"/>
+              </a:lnSpc>
+            </a:pPr>
+            <a:r>
+              <a:rPr sz="900" b="0">
+                <a:solidFill>
+                  <a:srgbClr val="5A6778"/>
+                </a:solidFill>
+                <a:latin typeface="Calibri"/>
+              </a:rPr>
+              <a:t>mark eventId settled</a:t>
+            </a:r>
+          </a:p>
+        </p:txBody>
+      </p:sp>
+      <p:sp>
+        <p:nvSpPr>
+          <p:cNvPr id="41" name="Rounded Rectangle 40"/>
+          <p:cNvSpPr/>
+          <p:nvPr/>
+        </p:nvSpPr>
+        <p:spPr>
+          <a:xfrm>
+            <a:off x="822960" y="6053328"/>
+            <a:ext cx="10543032" cy="566928"/>
+          </a:xfrm>
+          <a:prstGeom prst="roundRect">
+            <a:avLst/>
+          </a:prstGeom>
+          <a:solidFill>
+            <a:srgbClr val="EBF6F6"/>
+          </a:solidFill>
+          <a:ln w="12700">
+            <a:solidFill>
+              <a:srgbClr val="D9DFE7"/>
+            </a:solidFill>
+          </a:ln>
+          <a:effectLst/>
+        </p:spPr>
+        <p:style>
+          <a:lnRef idx="1">
+            <a:schemeClr val="accent1"/>
+          </a:lnRef>
+          <a:fillRef idx="3">
+            <a:schemeClr val="accent1"/>
+          </a:fillRef>
+          <a:effectRef idx="2">
+            <a:schemeClr val="accent1"/>
+          </a:effectRef>
+          <a:fontRef idx="minor">
+            <a:schemeClr val="lt1"/>
+          </a:fontRef>
+        </p:style>
+        <p:txBody>
+          <a:bodyPr rtlCol="0" anchor="ctr"/>
+          <a:lstStyle/>
+          <a:p>
+            <a:pPr algn="ctr"/>
+          </a:p>
+        </p:txBody>
+      </p:sp>
+      <p:sp>
+        <p:nvSpPr>
+          <p:cNvPr id="42" name="TextBox 41"/>
+          <p:cNvSpPr txBox="1"/>
+          <p:nvPr/>
+        </p:nvSpPr>
+        <p:spPr>
+          <a:xfrm>
+            <a:off x="1005840" y="6126480"/>
+            <a:ext cx="10241280" cy="420624"/>
+          </a:xfrm>
+          <a:prstGeom prst="rect">
+            <a:avLst/>
+          </a:prstGeom>
+          <a:noFill/>
+        </p:spPr>
+        <p:txBody>
+          <a:bodyPr wrap="square" anchor="ctr" lIns="0" rIns="0" tIns="0" bIns="0">
+            <a:spAutoFit/>
+          </a:bodyPr>
+          <a:lstStyle/>
+          <a:p>
+            <a:pPr algn="l">
+              <a:lnSpc>
+                <a:spcPct val="105000"/>
+              </a:lnSpc>
+            </a:pPr>
+            <a:r>
+              <a:rPr sz="1150" b="1">
+                <a:solidFill>
+                  <a:srgbClr val="142A4A"/>
+                </a:solidFill>
+                <a:latin typeface="Calibri"/>
+              </a:rPr>
+              <a:t>Burn precedes payout (never reverse). Coupon uses the snapshot holder set, not live balance.</a:t>
+            </a:r>
+          </a:p>
+          <a:p>
+            <a:pPr algn="l">
+              <a:lnSpc>
+                <a:spcPct val="105000"/>
+              </a:lnSpc>
+            </a:pPr>
+            <a:r>
+              <a:rPr sz="1100" b="0">
+                <a:solidFill>
+                  <a:srgbClr val="5A6778"/>
+                </a:solidFill>
+                <a:latin typeface="Calibri"/>
+              </a:rPr>
+              <a:t>Physical settlement: burn on-chain + off-chain custodian delivery — no value ever moves on-chain.</a:t>
+            </a:r>
+          </a:p>
+        </p:txBody>
+      </p:sp>
+    </p:spTree>
+  </p:cSld>
+  <p:clrMapOvr>
+    <a:masterClrMapping/>
+  </p:clrMapOvr>
+</p:sld>
+</file>
+
+<file path=ppt/slides/slide13.xml><?xml version="1.0" encoding="utf-8"?>
+<p:sld xmlns:a="http://schemas.openxmlformats.org/drawingml/2006/main" xmlns:p="http://schemas.openxmlformats.org/presentationml/2006/main" xmlns:r="http://schemas.openxmlformats.org/officeDocument/2006/relationships">
+  <p:cSld>
+    <p:spTree>
+      <p:nvGrpSpPr>
+        <p:cNvPr id="1" name=""/>
+        <p:cNvGrpSpPr/>
+        <p:nvPr/>
+      </p:nvGrpSpPr>
+      <p:grpSpPr/>
+      <p:sp>
+        <p:nvSpPr>
+          <p:cNvPr id="2" name="Rectangle 1"/>
+          <p:cNvSpPr/>
+          <p:nvPr/>
+        </p:nvSpPr>
+        <p:spPr>
+          <a:xfrm>
+            <a:off x="0" y="0"/>
+            <a:ext cx="12191695" cy="6858000"/>
+          </a:xfrm>
+          <a:prstGeom prst="rect">
+            <a:avLst/>
+          </a:prstGeom>
+          <a:solidFill>
+            <a:srgbClr val="F6F8FB"/>
+          </a:solidFill>
+          <a:ln>
+            <a:noFill/>
+          </a:ln>
+          <a:effectLst/>
+        </p:spPr>
+        <p:style>
+          <a:lnRef idx="1">
+            <a:schemeClr val="accent1"/>
+          </a:lnRef>
+          <a:fillRef idx="3">
+            <a:schemeClr val="accent1"/>
+          </a:fillRef>
+          <a:effectRef idx="2">
+            <a:schemeClr val="accent1"/>
+          </a:effectRef>
+          <a:fontRef idx="minor">
+            <a:schemeClr val="lt1"/>
+          </a:fontRef>
+        </p:style>
+        <p:txBody>
+          <a:bodyPr rtlCol="0" anchor="ctr"/>
+          <a:lstStyle/>
+          <a:p>
+            <a:pPr algn="ctr"/>
+          </a:p>
+        </p:txBody>
+      </p:sp>
+      <p:sp>
+        <p:nvSpPr>
+          <p:cNvPr id="3" name="Rectangle 2"/>
+          <p:cNvSpPr/>
+          <p:nvPr/>
+        </p:nvSpPr>
+        <p:spPr>
+          <a:xfrm>
+            <a:off x="822960" y="585216"/>
+            <a:ext cx="50292" cy="310896"/>
+          </a:xfrm>
+          <a:prstGeom prst="rect">
+            <a:avLst/>
+          </a:prstGeom>
+          <a:solidFill>
+            <a:srgbClr val="C8922B"/>
+          </a:solidFill>
+          <a:ln>
+            <a:noFill/>
+          </a:ln>
+          <a:effectLst/>
+        </p:spPr>
+        <p:style>
+          <a:lnRef idx="1">
+            <a:schemeClr val="accent1"/>
+          </a:lnRef>
+          <a:fillRef idx="3">
+            <a:schemeClr val="accent1"/>
+          </a:fillRef>
+          <a:effectRef idx="2">
+            <a:schemeClr val="accent1"/>
+          </a:effectRef>
+          <a:fontRef idx="minor">
+            <a:schemeClr val="lt1"/>
+          </a:fontRef>
+        </p:style>
+        <p:txBody>
+          <a:bodyPr rtlCol="0" anchor="ctr"/>
+          <a:lstStyle/>
+          <a:p>
+            <a:pPr algn="ctr"/>
+          </a:p>
+        </p:txBody>
+      </p:sp>
+      <p:sp>
+        <p:nvSpPr>
+          <p:cNvPr id="4" name="TextBox 3"/>
+          <p:cNvSpPr txBox="1"/>
+          <p:nvPr/>
+        </p:nvSpPr>
+        <p:spPr>
+          <a:xfrm>
+            <a:off x="987552" y="566928"/>
+            <a:ext cx="8229600" cy="365760"/>
+          </a:xfrm>
+          <a:prstGeom prst="rect">
+            <a:avLst/>
+          </a:prstGeom>
+          <a:noFill/>
+        </p:spPr>
+        <p:txBody>
+          <a:bodyPr wrap="square" anchor="t" lIns="0" rIns="0" tIns="0" bIns="0">
+            <a:spAutoFit/>
+          </a:bodyPr>
+          <a:lstStyle/>
+          <a:p>
+            <a:pPr algn="l">
+              <a:lnSpc>
+                <a:spcPct val="100000"/>
+              </a:lnSpc>
+            </a:pPr>
+            <a:r>
+              <a:rPr sz="1300" b="1">
+                <a:solidFill>
+                  <a:srgbClr val="C8922B"/>
+                </a:solidFill>
+                <a:latin typeface="Calibri"/>
+              </a:rPr>
+              <a:t>SYNC + DIVERGENCE ALARM</a:t>
+            </a:r>
+          </a:p>
+        </p:txBody>
+      </p:sp>
+      <p:sp>
+        <p:nvSpPr>
+          <p:cNvPr id="5" name="TextBox 4"/>
+          <p:cNvSpPr txBox="1"/>
+          <p:nvPr/>
+        </p:nvSpPr>
+        <p:spPr>
+          <a:xfrm>
+            <a:off x="822960" y="868680"/>
+            <a:ext cx="10607040" cy="822960"/>
+          </a:xfrm>
+          <a:prstGeom prst="rect">
+            <a:avLst/>
+          </a:prstGeom>
+          <a:noFill/>
+        </p:spPr>
+        <p:txBody>
+          <a:bodyPr wrap="square" anchor="t" lIns="0" rIns="0" tIns="0" bIns="0">
+            <a:spAutoFit/>
+          </a:bodyPr>
+          <a:lstStyle/>
+          <a:p>
+            <a:pPr algn="l">
+              <a:lnSpc>
+                <a:spcPct val="100000"/>
+              </a:lnSpc>
+            </a:pPr>
+            <a:r>
+              <a:rPr sz="3000" b="1">
+                <a:solidFill>
+                  <a:srgbClr val="0F1A2B"/>
+                </a:solidFill>
+                <a:latin typeface="Calibri"/>
+              </a:rPr>
+              <a:t>Variant-B reconciler — chain ↔ transfer-agent book</a:t>
+            </a:r>
+          </a:p>
+        </p:txBody>
+      </p:sp>
+      <p:sp>
+        <p:nvSpPr>
+          <p:cNvPr id="6" name="Rectangle 5"/>
+          <p:cNvSpPr/>
+          <p:nvPr/>
+        </p:nvSpPr>
+        <p:spPr>
+          <a:xfrm>
+            <a:off x="822960" y="1572768"/>
+            <a:ext cx="10543032" cy="18288"/>
+          </a:xfrm>
+          <a:prstGeom prst="rect">
+            <a:avLst/>
+          </a:prstGeom>
+          <a:solidFill>
+            <a:srgbClr val="D9DFE7"/>
+          </a:solidFill>
+          <a:ln>
+            <a:noFill/>
+          </a:ln>
+          <a:effectLst/>
+        </p:spPr>
+        <p:style>
+          <a:lnRef idx="1">
+            <a:schemeClr val="accent1"/>
+          </a:lnRef>
+          <a:fillRef idx="3">
+            <a:schemeClr val="accent1"/>
+          </a:fillRef>
+          <a:effectRef idx="2">
+            <a:schemeClr val="accent1"/>
+          </a:effectRef>
+          <a:fontRef idx="minor">
+            <a:schemeClr val="lt1"/>
+          </a:fontRef>
+        </p:style>
+        <p:txBody>
+          <a:bodyPr rtlCol="0" anchor="ctr"/>
+          <a:lstStyle/>
+          <a:p>
+            <a:pPr algn="ctr"/>
+          </a:p>
+        </p:txBody>
+      </p:sp>
+      <p:sp>
+        <p:nvSpPr>
+          <p:cNvPr id="7" name="TextBox 6"/>
+          <p:cNvSpPr txBox="1"/>
+          <p:nvPr/>
+        </p:nvSpPr>
+        <p:spPr>
+          <a:xfrm>
+            <a:off x="11247120" y="6419088"/>
+            <a:ext cx="822960" cy="274320"/>
+          </a:xfrm>
+          <a:prstGeom prst="rect">
+            <a:avLst/>
+          </a:prstGeom>
+          <a:noFill/>
+        </p:spPr>
+        <p:txBody>
+          <a:bodyPr wrap="square" anchor="t" lIns="0" rIns="0" tIns="0" bIns="0">
+            <a:spAutoFit/>
+          </a:bodyPr>
+          <a:lstStyle/>
+          <a:p>
+            <a:pPr algn="r">
+              <a:lnSpc>
+                <a:spcPct val="100000"/>
+              </a:lnSpc>
+            </a:pPr>
+            <a:r>
+              <a:rPr sz="1100" b="0">
+                <a:solidFill>
+                  <a:srgbClr val="5A6778"/>
+                </a:solidFill>
+                <a:latin typeface="Calibri"/>
+              </a:rPr>
+              <a:t>13</a:t>
+            </a:r>
+          </a:p>
+        </p:txBody>
+      </p:sp>
+      <p:sp>
+        <p:nvSpPr>
+          <p:cNvPr id="8" name="Rounded Rectangle 7"/>
+          <p:cNvSpPr/>
+          <p:nvPr/>
+        </p:nvSpPr>
+        <p:spPr>
+          <a:xfrm>
+            <a:off x="822960" y="1965960"/>
+            <a:ext cx="2743200" cy="914400"/>
+          </a:xfrm>
+          <a:prstGeom prst="roundRect">
+            <a:avLst/>
+          </a:prstGeom>
+          <a:solidFill>
+            <a:srgbClr val="EBF6F6"/>
+          </a:solidFill>
+          <a:ln w="17780">
+            <a:solidFill>
+              <a:srgbClr val="119DA4"/>
+            </a:solidFill>
+          </a:ln>
+          <a:effectLst/>
+        </p:spPr>
+        <p:style>
+          <a:lnRef idx="1">
+            <a:schemeClr val="accent1"/>
+          </a:lnRef>
+          <a:fillRef idx="3">
+            <a:schemeClr val="accent1"/>
+          </a:fillRef>
+          <a:effectRef idx="2">
+            <a:schemeClr val="accent1"/>
+          </a:effectRef>
+          <a:fontRef idx="minor">
+            <a:schemeClr val="lt1"/>
+          </a:fontRef>
+        </p:style>
+        <p:txBody>
+          <a:bodyPr rtlCol="0" anchor="ctr"/>
+          <a:lstStyle/>
+          <a:p>
+            <a:pPr algn="ctr"/>
+          </a:p>
+        </p:txBody>
+      </p:sp>
+      <p:sp>
+        <p:nvSpPr>
+          <p:cNvPr id="9" name="TextBox 8"/>
+          <p:cNvSpPr txBox="1"/>
+          <p:nvPr/>
+        </p:nvSpPr>
+        <p:spPr>
+          <a:xfrm>
+            <a:off x="960120" y="2084831"/>
+            <a:ext cx="2468880" cy="731520"/>
+          </a:xfrm>
+          <a:prstGeom prst="rect">
+            <a:avLst/>
+          </a:prstGeom>
+          <a:noFill/>
+        </p:spPr>
+        <p:txBody>
+          <a:bodyPr wrap="square" anchor="ctr" lIns="0" rIns="0" tIns="0" bIns="0">
+            <a:spAutoFit/>
+          </a:bodyPr>
+          <a:lstStyle/>
+          <a:p>
+            <a:pPr algn="l">
+              <a:lnSpc>
+                <a:spcPct val="100000"/>
+              </a:lnSpc>
+            </a:pPr>
+            <a:r>
+              <a:rPr sz="1350" b="1">
+                <a:solidFill>
+                  <a:srgbClr val="0F1A2B"/>
+                </a:solidFill>
+                <a:latin typeface="Calibri"/>
+              </a:rPr>
+              <a:t>Chain holders</a:t>
+            </a:r>
+          </a:p>
+          <a:p>
+            <a:pPr algn="l">
+              <a:lnSpc>
+                <a:spcPct val="100000"/>
+              </a:lnSpc>
+            </a:pPr>
+            <a:r>
+              <a:rPr sz="1050" b="0">
+                <a:solidFill>
+                  <a:srgbClr val="5A6778"/>
+                </a:solidFill>
+                <a:latin typeface="Calibri"/>
+              </a:rPr>
+              <a:t>CMTAT balances @ finalized block</a:t>
+            </a:r>
+          </a:p>
+          <a:p>
+            <a:pPr algn="l">
+              <a:lnSpc>
+                <a:spcPct val="100000"/>
+              </a:lnSpc>
+            </a:pPr>
+            <a:r>
+              <a:rPr sz="1000" b="1">
+                <a:solidFill>
+                  <a:srgbClr val="119DA4"/>
+                </a:solidFill>
+                <a:latin typeface="Calibri"/>
+              </a:rPr>
+              <a:t>operational truth</a:t>
+            </a:r>
+          </a:p>
+        </p:txBody>
+      </p:sp>
+      <p:sp>
+        <p:nvSpPr>
+          <p:cNvPr id="10" name="Rounded Rectangle 9"/>
+          <p:cNvSpPr/>
+          <p:nvPr/>
+        </p:nvSpPr>
+        <p:spPr>
+          <a:xfrm>
+            <a:off x="822960" y="3154680"/>
+            <a:ext cx="2743200" cy="914400"/>
+          </a:xfrm>
+          <a:prstGeom prst="roundRect">
+            <a:avLst/>
+          </a:prstGeom>
+          <a:solidFill>
+            <a:srgbClr val="F1ECF8"/>
+          </a:solidFill>
+          <a:ln w="17780">
+            <a:solidFill>
+              <a:srgbClr val="7A4FA8"/>
+            </a:solidFill>
+          </a:ln>
+          <a:effectLst/>
+        </p:spPr>
+        <p:style>
+          <a:lnRef idx="1">
+            <a:schemeClr val="accent1"/>
+          </a:lnRef>
+          <a:fillRef idx="3">
+            <a:schemeClr val="accent1"/>
+          </a:fillRef>
+          <a:effectRef idx="2">
+            <a:schemeClr val="accent1"/>
+          </a:effectRef>
+          <a:fontRef idx="minor">
+            <a:schemeClr val="lt1"/>
+          </a:fontRef>
+        </p:style>
+        <p:txBody>
+          <a:bodyPr rtlCol="0" anchor="ctr"/>
+          <a:lstStyle/>
+          <a:p>
+            <a:pPr algn="ctr"/>
+          </a:p>
+        </p:txBody>
+      </p:sp>
+      <p:sp>
+        <p:nvSpPr>
+          <p:cNvPr id="11" name="TextBox 10"/>
+          <p:cNvSpPr txBox="1"/>
+          <p:nvPr/>
+        </p:nvSpPr>
+        <p:spPr>
+          <a:xfrm>
+            <a:off x="960120" y="3273552"/>
+            <a:ext cx="2468880" cy="731520"/>
+          </a:xfrm>
+          <a:prstGeom prst="rect">
+            <a:avLst/>
+          </a:prstGeom>
+          <a:noFill/>
+        </p:spPr>
+        <p:txBody>
+          <a:bodyPr wrap="square" anchor="ctr" lIns="0" rIns="0" tIns="0" bIns="0">
+            <a:spAutoFit/>
+          </a:bodyPr>
+          <a:lstStyle/>
+          <a:p>
+            <a:pPr algn="l">
+              <a:lnSpc>
+                <a:spcPct val="100000"/>
+              </a:lnSpc>
+            </a:pPr>
+            <a:r>
+              <a:rPr sz="1350" b="1">
+                <a:solidFill>
+                  <a:srgbClr val="0F1A2B"/>
+                </a:solidFill>
+                <a:latin typeface="Calibri"/>
+              </a:rPr>
+              <a:t>TA book</a:t>
+            </a:r>
+          </a:p>
+          <a:p>
+            <a:pPr algn="l">
+              <a:lnSpc>
+                <a:spcPct val="100000"/>
+              </a:lnSpc>
+            </a:pPr>
+            <a:r>
+              <a:rPr sz="1050" b="0">
+                <a:solidFill>
+                  <a:srgbClr val="5A6778"/>
+                </a:solidFill>
+                <a:latin typeface="Calibri"/>
+              </a:rPr>
+              <a:t>transfer-agent register</a:t>
+            </a:r>
+          </a:p>
+          <a:p>
+            <a:pPr algn="l">
+              <a:lnSpc>
+                <a:spcPct val="100000"/>
+              </a:lnSpc>
+            </a:pPr>
+            <a:r>
+              <a:rPr sz="1000" b="1">
+                <a:solidFill>
+                  <a:srgbClr val="7A4FA8"/>
+                </a:solidFill>
+                <a:latin typeface="Calibri"/>
+              </a:rPr>
+              <a:t>LEGAL truth</a:t>
+            </a:r>
+          </a:p>
+        </p:txBody>
+      </p:sp>
+      <p:sp>
+        <p:nvSpPr>
+          <p:cNvPr id="12" name="Rounded Rectangle 11"/>
+          <p:cNvSpPr/>
+          <p:nvPr/>
+        </p:nvSpPr>
+        <p:spPr>
+          <a:xfrm>
+            <a:off x="4160520" y="2423160"/>
+            <a:ext cx="2468880" cy="1234440"/>
+          </a:xfrm>
+          <a:prstGeom prst="roundRect">
+            <a:avLst/>
+          </a:prstGeom>
+          <a:solidFill>
+            <a:srgbClr val="142A4A"/>
+          </a:solidFill>
+          <a:ln>
+            <a:noFill/>
+          </a:ln>
+          <a:effectLst/>
+        </p:spPr>
+        <p:style>
+          <a:lnRef idx="1">
+            <a:schemeClr val="accent1"/>
+          </a:lnRef>
+          <a:fillRef idx="3">
+            <a:schemeClr val="accent1"/>
+          </a:fillRef>
+          <a:effectRef idx="2">
+            <a:schemeClr val="accent1"/>
+          </a:effectRef>
+          <a:fontRef idx="minor">
+            <a:schemeClr val="lt1"/>
+          </a:fontRef>
+        </p:style>
+        <p:txBody>
+          <a:bodyPr rtlCol="0" anchor="ctr"/>
+          <a:lstStyle/>
+          <a:p>
+            <a:pPr algn="ctr"/>
+          </a:p>
+        </p:txBody>
+      </p:sp>
+      <p:sp>
+        <p:nvSpPr>
+          <p:cNvPr id="13" name="TextBox 12"/>
+          <p:cNvSpPr txBox="1"/>
+          <p:nvPr/>
+        </p:nvSpPr>
+        <p:spPr>
+          <a:xfrm>
+            <a:off x="4206240" y="2542032"/>
+            <a:ext cx="2377440" cy="1005840"/>
+          </a:xfrm>
+          <a:prstGeom prst="rect">
+            <a:avLst/>
+          </a:prstGeom>
+          <a:noFill/>
+        </p:spPr>
+        <p:txBody>
+          <a:bodyPr wrap="square" anchor="ctr" lIns="0" rIns="0" tIns="0" bIns="0">
+            <a:spAutoFit/>
+          </a:bodyPr>
+          <a:lstStyle/>
+          <a:p>
+            <a:pPr algn="ctr">
+              <a:lnSpc>
+                <a:spcPct val="105000"/>
+              </a:lnSpc>
+            </a:pPr>
+            <a:r>
+              <a:rPr sz="1500" b="1">
+                <a:solidFill>
+                  <a:srgbClr val="FFFFFF"/>
+                </a:solidFill>
+                <a:latin typeface="Calibri"/>
+              </a:rPr>
+              <a:t>Reconciler</a:t>
+            </a:r>
+          </a:p>
+          <a:p>
+            <a:pPr algn="ctr">
+              <a:lnSpc>
+                <a:spcPct val="105000"/>
+              </a:lnSpc>
+            </a:pPr>
+            <a:r>
+              <a:rPr sz="1050" b="0">
+                <a:solidFill>
+                  <a:srgbClr val="BFD2F0"/>
+                </a:solidFill>
+                <a:latin typeface="Calibri"/>
+              </a:rPr>
+              <a:t>holder-by-holder equality</a:t>
+            </a:r>
+          </a:p>
+          <a:p>
+            <a:pPr algn="ctr">
+              <a:lnSpc>
+                <a:spcPct val="105000"/>
+              </a:lnSpc>
+            </a:pPr>
+            <a:r>
+              <a:rPr sz="1050" b="0">
+                <a:solidFill>
+                  <a:srgbClr val="BFD2F0"/>
+                </a:solidFill>
+                <a:latin typeface="Calibri"/>
+              </a:rPr>
+              <a:t>+ supply invariant</a:t>
+            </a:r>
+          </a:p>
+        </p:txBody>
+      </p:sp>
+      <p:cxnSp>
+        <p:nvCxnSpPr>
+          <p:cNvPr id="14" name="Connector 13"/>
+          <p:cNvCxnSpPr/>
+          <p:nvPr/>
+        </p:nvCxnSpPr>
+        <p:spPr>
+          <a:xfrm>
+            <a:off x="3566160" y="2423160"/>
+            <a:ext cx="594360" cy="365760"/>
+          </a:xfrm>
+          <a:prstGeom prst="bentConnector3">
+            <a:avLst/>
+          </a:prstGeom>
+          <a:ln w="20320">
+            <a:solidFill>
+              <a:srgbClr val="119DA4"/>
+            </a:solidFill>
+            <a:headEnd type="triangle" w="med" len="med"/>
+          </a:ln>
+        </p:spPr>
+        <p:style>
+          <a:lnRef idx="2">
+            <a:schemeClr val="accent1"/>
+          </a:lnRef>
+          <a:fillRef idx="0">
+            <a:schemeClr val="accent1"/>
+          </a:fillRef>
+          <a:effectRef idx="1">
+            <a:schemeClr val="accent1"/>
+          </a:effectRef>
+          <a:fontRef idx="minor">
+            <a:schemeClr val="tx1"/>
+          </a:fontRef>
+        </p:style>
+      </p:cxnSp>
+      <p:cxnSp>
+        <p:nvCxnSpPr>
+          <p:cNvPr id="15" name="Connector 14"/>
+          <p:cNvCxnSpPr/>
+          <p:nvPr/>
+        </p:nvCxnSpPr>
+        <p:spPr>
+          <a:xfrm flipV="1">
+            <a:off x="3566160" y="3246120"/>
+            <a:ext cx="594360" cy="365760"/>
+          </a:xfrm>
+          <a:prstGeom prst="bentConnector3">
+            <a:avLst/>
+          </a:prstGeom>
+          <a:ln w="20320">
+            <a:solidFill>
+              <a:srgbClr val="7A4FA8"/>
+            </a:solidFill>
+            <a:headEnd type="triangle" w="med" len="med"/>
+          </a:ln>
+        </p:spPr>
+        <p:style>
+          <a:lnRef idx="2">
+            <a:schemeClr val="accent1"/>
+          </a:lnRef>
+          <a:fillRef idx="0">
+            <a:schemeClr val="accent1"/>
+          </a:fillRef>
+          <a:effectRef idx="1">
+            <a:schemeClr val="accent1"/>
+          </a:effectRef>
+          <a:fontRef idx="minor">
+            <a:schemeClr val="tx1"/>
+          </a:fontRef>
+        </p:style>
+      </p:cxnSp>
+      <p:sp>
+        <p:nvSpPr>
+          <p:cNvPr id="16" name="Rounded Rectangle 15"/>
+          <p:cNvSpPr/>
+          <p:nvPr/>
+        </p:nvSpPr>
+        <p:spPr>
+          <a:xfrm>
+            <a:off x="7223760" y="2011680"/>
+            <a:ext cx="4114800" cy="822960"/>
+          </a:xfrm>
+          <a:prstGeom prst="roundRect">
+            <a:avLst/>
+          </a:prstGeom>
+          <a:solidFill>
+            <a:srgbClr val="ECF7EF"/>
+          </a:solidFill>
+          <a:ln w="17780">
+            <a:solidFill>
+              <a:srgbClr val="2E8B57"/>
+            </a:solidFill>
+          </a:ln>
+          <a:effectLst/>
+        </p:spPr>
+        <p:style>
+          <a:lnRef idx="1">
+            <a:schemeClr val="accent1"/>
+          </a:lnRef>
+          <a:fillRef idx="3">
+            <a:schemeClr val="accent1"/>
+          </a:fillRef>
+          <a:effectRef idx="2">
+            <a:schemeClr val="accent1"/>
+          </a:effectRef>
+          <a:fontRef idx="minor">
+            <a:schemeClr val="lt1"/>
+          </a:fontRef>
+        </p:style>
+        <p:txBody>
+          <a:bodyPr rtlCol="0" anchor="ctr"/>
+          <a:lstStyle/>
+          <a:p>
+            <a:pPr algn="ctr"/>
+          </a:p>
+        </p:txBody>
+      </p:sp>
+      <p:sp>
+        <p:nvSpPr>
+          <p:cNvPr id="17" name="TextBox 16"/>
+          <p:cNvSpPr txBox="1"/>
+          <p:nvPr/>
+        </p:nvSpPr>
+        <p:spPr>
+          <a:xfrm>
+            <a:off x="7360920" y="2121408"/>
+            <a:ext cx="3840480" cy="603504"/>
+          </a:xfrm>
+          <a:prstGeom prst="rect">
+            <a:avLst/>
+          </a:prstGeom>
+          <a:noFill/>
+        </p:spPr>
+        <p:txBody>
+          <a:bodyPr wrap="square" anchor="ctr" lIns="0" rIns="0" tIns="0" bIns="0">
+            <a:spAutoFit/>
+          </a:bodyPr>
+          <a:lstStyle/>
+          <a:p>
+            <a:pPr algn="l">
+              <a:lnSpc>
+                <a:spcPct val="100000"/>
+              </a:lnSpc>
+            </a:pPr>
+            <a:r>
+              <a:rPr sz="1300" b="1">
+                <a:solidFill>
+                  <a:srgbClr val="2E8B57"/>
+                </a:solidFill>
+                <a:latin typeface="Calibri"/>
+              </a:rPr>
+              <a:t>● IN_SYNC</a:t>
+            </a:r>
+            <a:r>
+              <a:rPr sz="1150" b="0">
+                <a:solidFill>
+                  <a:srgbClr val="0F1A2B"/>
+                </a:solidFill>
+                <a:latin typeface="Calibri"/>
+              </a:rPr>
+              <a:t>  → record clean, allow payouts</a:t>
+            </a:r>
+          </a:p>
+        </p:txBody>
+      </p:sp>
+      <p:sp>
+        <p:nvSpPr>
+          <p:cNvPr id="18" name="Rounded Rectangle 17"/>
+          <p:cNvSpPr/>
+          <p:nvPr/>
+        </p:nvSpPr>
+        <p:spPr>
+          <a:xfrm>
+            <a:off x="7223760" y="2971800"/>
+            <a:ext cx="4114800" cy="1188720"/>
+          </a:xfrm>
+          <a:prstGeom prst="roundRect">
+            <a:avLst/>
+          </a:prstGeom>
+          <a:solidFill>
+            <a:srgbClr val="FBEEEE"/>
+          </a:solidFill>
+          <a:ln w="17780">
+            <a:solidFill>
+              <a:srgbClr val="C03A3A"/>
+            </a:solidFill>
+          </a:ln>
+          <a:effectLst/>
+        </p:spPr>
+        <p:style>
+          <a:lnRef idx="1">
+            <a:schemeClr val="accent1"/>
+          </a:lnRef>
+          <a:fillRef idx="3">
+            <a:schemeClr val="accent1"/>
+          </a:fillRef>
+          <a:effectRef idx="2">
+            <a:schemeClr val="accent1"/>
+          </a:effectRef>
+          <a:fontRef idx="minor">
+            <a:schemeClr val="lt1"/>
+          </a:fontRef>
+        </p:style>
+        <p:txBody>
+          <a:bodyPr rtlCol="0" anchor="ctr"/>
+          <a:lstStyle/>
+          <a:p>
+            <a:pPr algn="ctr"/>
+          </a:p>
+        </p:txBody>
+      </p:sp>
+      <p:sp>
+        <p:nvSpPr>
+          <p:cNvPr id="19" name="TextBox 18"/>
+          <p:cNvSpPr txBox="1"/>
+          <p:nvPr/>
+        </p:nvSpPr>
+        <p:spPr>
+          <a:xfrm>
+            <a:off x="7360920" y="3072384"/>
+            <a:ext cx="3840480" cy="1005840"/>
+          </a:xfrm>
+          <a:prstGeom prst="rect">
+            <a:avLst/>
+          </a:prstGeom>
+          <a:noFill/>
+        </p:spPr>
+        <p:txBody>
+          <a:bodyPr wrap="square" anchor="ctr" lIns="0" rIns="0" tIns="0" bIns="0">
+            <a:spAutoFit/>
+          </a:bodyPr>
+          <a:lstStyle/>
+          <a:p>
+            <a:pPr algn="l">
+              <a:lnSpc>
+                <a:spcPct val="102000"/>
+              </a:lnSpc>
+            </a:pPr>
+            <a:r>
+              <a:rPr sz="1300" b="1">
+                <a:solidFill>
+                  <a:srgbClr val="C03A3A"/>
+                </a:solidFill>
+                <a:latin typeface="Calibri"/>
+              </a:rPr>
+              <a:t>● DIVERGENT</a:t>
+            </a:r>
+          </a:p>
+          <a:p>
+            <a:pPr algn="l">
+              <a:lnSpc>
+                <a:spcPct val="102000"/>
+              </a:lnSpc>
+            </a:pPr>
+            <a:r>
+              <a:rPr sz="1100" b="0">
+                <a:solidFill>
+                  <a:srgbClr val="0F1A2B"/>
+                </a:solidFill>
+                <a:latin typeface="Calibri"/>
+              </a:rPr>
+              <a:t>CMTAT pause() → alarm ops → block payouts.</a:t>
+            </a:r>
+          </a:p>
+          <a:p>
+            <a:pPr algn="l">
+              <a:lnSpc>
+                <a:spcPct val="102000"/>
+              </a:lnSpc>
+            </a:pPr>
+            <a:r>
+              <a:rPr sz="1050" b="0">
+                <a:solidFill>
+                  <a:srgbClr val="5A6778"/>
+                </a:solidFill>
+                <a:latin typeface="Calibri"/>
+              </a:rPr>
+              <a:t>Never auto-fix: TA book wins per governance;</a:t>
+            </a:r>
+          </a:p>
+          <a:p>
+            <a:pPr algn="l">
+              <a:lnSpc>
+                <a:spcPct val="102000"/>
+              </a:lnSpc>
+            </a:pPr>
+            <a:r>
+              <a:rPr sz="1050" b="0">
+                <a:solidFill>
+                  <a:srgbClr val="5A6778"/>
+                </a:solidFill>
+                <a:latin typeface="Calibri"/>
+              </a:rPr>
+              <a:t>chain corrected under documented control.</a:t>
+            </a:r>
+          </a:p>
+        </p:txBody>
+      </p:sp>
+      <p:cxnSp>
+        <p:nvCxnSpPr>
+          <p:cNvPr id="20" name="Connector 19"/>
+          <p:cNvCxnSpPr/>
+          <p:nvPr/>
+        </p:nvCxnSpPr>
+        <p:spPr>
+          <a:xfrm flipV="1">
+            <a:off x="6629400" y="2423160"/>
+            <a:ext cx="594360" cy="365760"/>
+          </a:xfrm>
+          <a:prstGeom prst="bentConnector3">
+            <a:avLst/>
+          </a:prstGeom>
+          <a:ln w="20320">
+            <a:solidFill>
+              <a:srgbClr val="2E8B57"/>
+            </a:solidFill>
+            <a:headEnd type="triangle" w="med" len="med"/>
+          </a:ln>
+        </p:spPr>
+        <p:style>
+          <a:lnRef idx="2">
+            <a:schemeClr val="accent1"/>
+          </a:lnRef>
+          <a:fillRef idx="0">
+            <a:schemeClr val="accent1"/>
+          </a:fillRef>
+          <a:effectRef idx="1">
+            <a:schemeClr val="accent1"/>
+          </a:effectRef>
+          <a:fontRef idx="minor">
+            <a:schemeClr val="tx1"/>
+          </a:fontRef>
+        </p:style>
+      </p:cxnSp>
+      <p:cxnSp>
+        <p:nvCxnSpPr>
+          <p:cNvPr id="21" name="Connector 20"/>
+          <p:cNvCxnSpPr/>
+          <p:nvPr/>
+        </p:nvCxnSpPr>
+        <p:spPr>
+          <a:xfrm>
+            <a:off x="6629400" y="3246120"/>
+            <a:ext cx="594360" cy="320040"/>
+          </a:xfrm>
+          <a:prstGeom prst="bentConnector3">
+            <a:avLst/>
+          </a:prstGeom>
+          <a:ln w="20320">
+            <a:solidFill>
+              <a:srgbClr val="C03A3A"/>
+            </a:solidFill>
+            <a:headEnd type="triangle" w="med" len="med"/>
+          </a:ln>
+        </p:spPr>
+        <p:style>
+          <a:lnRef idx="2">
+            <a:schemeClr val="accent1"/>
+          </a:lnRef>
+          <a:fillRef idx="0">
+            <a:schemeClr val="accent1"/>
+          </a:fillRef>
+          <a:effectRef idx="1">
+            <a:schemeClr val="accent1"/>
+          </a:effectRef>
+          <a:fontRef idx="minor">
+            <a:schemeClr val="tx1"/>
+          </a:fontRef>
+        </p:style>
+      </p:cxnSp>
+      <p:sp>
+        <p:nvSpPr>
+          <p:cNvPr id="22" name="Rounded Rectangle 21"/>
+          <p:cNvSpPr/>
+          <p:nvPr/>
+        </p:nvSpPr>
+        <p:spPr>
+          <a:xfrm>
+            <a:off x="822960" y="4617720"/>
+            <a:ext cx="10543032" cy="1600200"/>
+          </a:xfrm>
+          <a:prstGeom prst="roundRect">
+            <a:avLst/>
+          </a:prstGeom>
+          <a:solidFill>
+            <a:srgbClr val="0A121F"/>
+          </a:solidFill>
+          <a:ln w="12700">
+            <a:solidFill>
+              <a:srgbClr val="142A4A"/>
+            </a:solidFill>
+          </a:ln>
+          <a:effectLst/>
+        </p:spPr>
+        <p:style>
+          <a:lnRef idx="1">
+            <a:schemeClr val="accent1"/>
+          </a:lnRef>
+          <a:fillRef idx="3">
+            <a:schemeClr val="accent1"/>
+          </a:fillRef>
+          <a:effectRef idx="2">
+            <a:schemeClr val="accent1"/>
+          </a:effectRef>
+          <a:fontRef idx="minor">
+            <a:schemeClr val="lt1"/>
+          </a:fontRef>
+        </p:style>
+        <p:txBody>
+          <a:bodyPr rtlCol="0" anchor="ctr"/>
+          <a:lstStyle/>
+          <a:p>
+            <a:pPr algn="ctr"/>
+          </a:p>
+        </p:txBody>
+      </p:sp>
+      <p:sp>
+        <p:nvSpPr>
+          <p:cNvPr id="23" name="TextBox 22"/>
+          <p:cNvSpPr txBox="1"/>
+          <p:nvPr/>
+        </p:nvSpPr>
+        <p:spPr>
+          <a:xfrm>
+            <a:off x="1005840" y="4736592"/>
+            <a:ext cx="10149840" cy="1371600"/>
+          </a:xfrm>
+          <a:prstGeom prst="rect">
+            <a:avLst/>
+          </a:prstGeom>
+          <a:noFill/>
+        </p:spPr>
+        <p:txBody>
+          <a:bodyPr wrap="square">
+            <a:spAutoFit/>
+          </a:bodyPr>
+          <a:lstStyle/>
+          <a:p>
+            <a:pPr>
+              <a:lnSpc>
+                <a:spcPct val="130000"/>
+              </a:lnSpc>
+            </a:pPr>
+            <a:r>
+              <a:rPr sz="1150">
+                <a:solidFill>
+                  <a:srgbClr val="D7E1F0"/>
+                </a:solidFill>
+                <a:latin typeface="Consolas"/>
+              </a:rPr>
+              <a:t>for (const h of holders)  if (chain[h] !== book[h])  diffs.push({h, chain[h], book[h]});</a:t>
+            </a:r>
+          </a:p>
+          <a:p>
+            <a:pPr>
+              <a:lnSpc>
+                <a:spcPct val="130000"/>
+              </a:lnSpc>
+            </a:pPr>
+            <a:r>
+              <a:rPr sz="1150">
+                <a:solidFill>
+                  <a:srgbClr val="C8922B"/>
+                </a:solidFill>
+                <a:latin typeface="Consolas"/>
+              </a:rPr>
+              <a:t>if (chainTotal !== bookTotal || diffs.length)  { firefly.pause(); alarm.critical(diffs); }  // contain, don't fix</a:t>
+            </a:r>
+          </a:p>
+          <a:p>
+            <a:pPr>
+              <a:lnSpc>
+                <a:spcPct val="130000"/>
+              </a:lnSpc>
+            </a:pPr>
+            <a:r>
+              <a:rPr sz="1150">
+                <a:solidFill>
+                  <a:srgbClr val="6BC58E"/>
+                </a:solidFill>
+                <a:latin typeface="Consolas"/>
+              </a:rPr>
+              <a:t>anchorReconciliation(block, bookMerkleRoot, inSync);   // tamper-evident proof, book stays off-chain, no PII</a:t>
+            </a:r>
+          </a:p>
+        </p:txBody>
+      </p:sp>
+      <p:sp>
+        <p:nvSpPr>
+          <p:cNvPr id="24" name="TextBox 23"/>
+          <p:cNvSpPr txBox="1"/>
+          <p:nvPr/>
+        </p:nvSpPr>
+        <p:spPr>
+          <a:xfrm>
+            <a:off x="1005840" y="5989320"/>
+            <a:ext cx="10058400" cy="274320"/>
+          </a:xfrm>
+          <a:prstGeom prst="rect">
+            <a:avLst/>
+          </a:prstGeom>
+          <a:noFill/>
+        </p:spPr>
+        <p:txBody>
+          <a:bodyPr wrap="square" anchor="t" lIns="0" rIns="0" tIns="0" bIns="0">
+            <a:spAutoFit/>
+          </a:bodyPr>
+          <a:lstStyle/>
+          <a:p>
+            <a:pPr algn="l">
+              <a:lnSpc>
+                <a:spcPct val="100000"/>
+              </a:lnSpc>
+            </a:pPr>
+            <a:r>
+              <a:rPr sz="1050" b="0">
+                <a:solidFill>
+                  <a:srgbClr val="9AADC8"/>
+                </a:solidFill>
+                <a:latin typeface="Calibri"/>
+              </a:rPr>
+              <a:t>Triggered on every finalized token-event batch + heartbeat → drift caught in minutes, not at month-end.</a:t>
+            </a:r>
+          </a:p>
+        </p:txBody>
+      </p:sp>
+    </p:spTree>
+  </p:cSld>
+  <p:clrMapOvr>
+    <a:masterClrMapping/>
+  </p:clrMapOvr>
+</p:sld>
+</file>
+
+<file path=ppt/slides/slide14.xml><?xml version="1.0" encoding="utf-8"?>
+<p:sld xmlns:a="http://schemas.openxmlformats.org/drawingml/2006/main" xmlns:p="http://schemas.openxmlformats.org/presentationml/2006/main" xmlns:r="http://schemas.openxmlformats.org/officeDocument/2006/relationships">
+  <p:cSld>
+    <p:spTree>
+      <p:nvGrpSpPr>
+        <p:cNvPr id="1" name=""/>
+        <p:cNvGrpSpPr/>
+        <p:nvPr/>
+      </p:nvGrpSpPr>
+      <p:grpSpPr/>
+      <p:sp>
+        <p:nvSpPr>
+          <p:cNvPr id="2" name="Rectangle 1"/>
+          <p:cNvSpPr/>
+          <p:nvPr/>
+        </p:nvSpPr>
+        <p:spPr>
+          <a:xfrm>
+            <a:off x="0" y="0"/>
+            <a:ext cx="12191695" cy="6858000"/>
+          </a:xfrm>
+          <a:prstGeom prst="rect">
+            <a:avLst/>
+          </a:prstGeom>
+          <a:solidFill>
+            <a:srgbClr val="F6F8FB"/>
+          </a:solidFill>
+          <a:ln>
+            <a:noFill/>
+          </a:ln>
+          <a:effectLst/>
+        </p:spPr>
+        <p:style>
+          <a:lnRef idx="1">
+            <a:schemeClr val="accent1"/>
+          </a:lnRef>
+          <a:fillRef idx="3">
+            <a:schemeClr val="accent1"/>
+          </a:fillRef>
+          <a:effectRef idx="2">
+            <a:schemeClr val="accent1"/>
+          </a:effectRef>
+          <a:fontRef idx="minor">
+            <a:schemeClr val="lt1"/>
+          </a:fontRef>
+        </p:style>
+        <p:txBody>
+          <a:bodyPr rtlCol="0" anchor="ctr"/>
+          <a:lstStyle/>
+          <a:p>
+            <a:pPr algn="ctr"/>
+          </a:p>
+        </p:txBody>
+      </p:sp>
+      <p:sp>
+        <p:nvSpPr>
+          <p:cNvPr id="3" name="Rectangle 2"/>
+          <p:cNvSpPr/>
+          <p:nvPr/>
+        </p:nvSpPr>
+        <p:spPr>
+          <a:xfrm>
+            <a:off x="822960" y="585216"/>
+            <a:ext cx="50292" cy="310896"/>
+          </a:xfrm>
+          <a:prstGeom prst="rect">
+            <a:avLst/>
+          </a:prstGeom>
+          <a:solidFill>
+            <a:srgbClr val="C8922B"/>
+          </a:solidFill>
+          <a:ln>
+            <a:noFill/>
+          </a:ln>
+          <a:effectLst/>
+        </p:spPr>
+        <p:style>
+          <a:lnRef idx="1">
+            <a:schemeClr val="accent1"/>
+          </a:lnRef>
+          <a:fillRef idx="3">
+            <a:schemeClr val="accent1"/>
+          </a:fillRef>
+          <a:effectRef idx="2">
+            <a:schemeClr val="accent1"/>
+          </a:effectRef>
+          <a:fontRef idx="minor">
+            <a:schemeClr val="lt1"/>
+          </a:fontRef>
+        </p:style>
+        <p:txBody>
+          <a:bodyPr rtlCol="0" anchor="ctr"/>
+          <a:lstStyle/>
+          <a:p>
+            <a:pPr algn="ctr"/>
+          </a:p>
+        </p:txBody>
+      </p:sp>
+      <p:sp>
+        <p:nvSpPr>
+          <p:cNvPr id="4" name="TextBox 3"/>
+          <p:cNvSpPr txBox="1"/>
+          <p:nvPr/>
+        </p:nvSpPr>
+        <p:spPr>
+          <a:xfrm>
+            <a:off x="987552" y="566928"/>
+            <a:ext cx="8229600" cy="365760"/>
+          </a:xfrm>
+          <a:prstGeom prst="rect">
+            <a:avLst/>
+          </a:prstGeom>
+          <a:noFill/>
+        </p:spPr>
+        <p:txBody>
+          <a:bodyPr wrap="square" anchor="t" lIns="0" rIns="0" tIns="0" bIns="0">
+            <a:spAutoFit/>
+          </a:bodyPr>
+          <a:lstStyle/>
+          <a:p>
+            <a:pPr algn="l">
+              <a:lnSpc>
+                <a:spcPct val="100000"/>
+              </a:lnSpc>
+            </a:pPr>
+            <a:r>
+              <a:rPr sz="1300" b="1">
+                <a:solidFill>
+                  <a:srgbClr val="C8922B"/>
+                </a:solidFill>
+                <a:latin typeface="Calibri"/>
+              </a:rPr>
+              <a:t>PICK ONE PER ISSUANCE</a:t>
+            </a:r>
+          </a:p>
+        </p:txBody>
+      </p:sp>
+      <p:sp>
+        <p:nvSpPr>
+          <p:cNvPr id="5" name="TextBox 4"/>
+          <p:cNvSpPr txBox="1"/>
+          <p:nvPr/>
+        </p:nvSpPr>
+        <p:spPr>
+          <a:xfrm>
+            <a:off x="822960" y="868680"/>
+            <a:ext cx="10607040" cy="822960"/>
+          </a:xfrm>
+          <a:prstGeom prst="rect">
+            <a:avLst/>
+          </a:prstGeom>
+          <a:noFill/>
+        </p:spPr>
+        <p:txBody>
+          <a:bodyPr wrap="square" anchor="t" lIns="0" rIns="0" tIns="0" bIns="0">
+            <a:spAutoFit/>
+          </a:bodyPr>
+          <a:lstStyle/>
+          <a:p>
+            <a:pPr algn="l">
+              <a:lnSpc>
+                <a:spcPct val="100000"/>
+              </a:lnSpc>
+            </a:pPr>
+            <a:r>
+              <a:rPr sz="3000" b="1">
+                <a:solidFill>
+                  <a:srgbClr val="0F1A2B"/>
+                </a:solidFill>
+                <a:latin typeface="Calibri"/>
+              </a:rPr>
+              <a:t>Design fork — is the token the register, or just the message?</a:t>
+            </a:r>
+          </a:p>
+        </p:txBody>
+      </p:sp>
+      <p:sp>
+        <p:nvSpPr>
+          <p:cNvPr id="6" name="Rectangle 5"/>
+          <p:cNvSpPr/>
+          <p:nvPr/>
+        </p:nvSpPr>
+        <p:spPr>
+          <a:xfrm>
+            <a:off x="822960" y="1572768"/>
+            <a:ext cx="10543032" cy="18288"/>
+          </a:xfrm>
+          <a:prstGeom prst="rect">
+            <a:avLst/>
+          </a:prstGeom>
+          <a:solidFill>
+            <a:srgbClr val="D9DFE7"/>
+          </a:solidFill>
+          <a:ln>
+            <a:noFill/>
+          </a:ln>
+          <a:effectLst/>
+        </p:spPr>
+        <p:style>
+          <a:lnRef idx="1">
+            <a:schemeClr val="accent1"/>
+          </a:lnRef>
+          <a:fillRef idx="3">
+            <a:schemeClr val="accent1"/>
+          </a:fillRef>
+          <a:effectRef idx="2">
+            <a:schemeClr val="accent1"/>
+          </a:effectRef>
+          <a:fontRef idx="minor">
+            <a:schemeClr val="lt1"/>
+          </a:fontRef>
+        </p:style>
+        <p:txBody>
+          <a:bodyPr rtlCol="0" anchor="ctr"/>
+          <a:lstStyle/>
+          <a:p>
+            <a:pPr algn="ctr"/>
+          </a:p>
+        </p:txBody>
+      </p:sp>
+      <p:sp>
+        <p:nvSpPr>
+          <p:cNvPr id="7" name="TextBox 6"/>
+          <p:cNvSpPr txBox="1"/>
+          <p:nvPr/>
+        </p:nvSpPr>
+        <p:spPr>
+          <a:xfrm>
+            <a:off x="11247120" y="6419088"/>
+            <a:ext cx="822960" cy="274320"/>
+          </a:xfrm>
+          <a:prstGeom prst="rect">
+            <a:avLst/>
+          </a:prstGeom>
+          <a:noFill/>
+        </p:spPr>
+        <p:txBody>
+          <a:bodyPr wrap="square" anchor="t" lIns="0" rIns="0" tIns="0" bIns="0">
+            <a:spAutoFit/>
+          </a:bodyPr>
+          <a:lstStyle/>
+          <a:p>
+            <a:pPr algn="r">
+              <a:lnSpc>
+                <a:spcPct val="100000"/>
+              </a:lnSpc>
+            </a:pPr>
+            <a:r>
+              <a:rPr sz="1100" b="0">
+                <a:solidFill>
+                  <a:srgbClr val="5A6778"/>
+                </a:solidFill>
+                <a:latin typeface="Calibri"/>
+              </a:rPr>
+              <a:t>14</a:t>
             </a:r>
           </a:p>
         </p:txBody>
@@ -7397,7 +10246,1795 @@
 </p:sld>
 </file>
 
-<file path=ppt/slides/slide13.xml><?xml version="1.0" encoding="utf-8"?>
+<file path=ppt/slides/slide15.xml><?xml version="1.0" encoding="utf-8"?>
+<p:sld xmlns:a="http://schemas.openxmlformats.org/drawingml/2006/main" xmlns:p="http://schemas.openxmlformats.org/presentationml/2006/main" xmlns:r="http://schemas.openxmlformats.org/officeDocument/2006/relationships">
+  <p:cSld>
+    <p:spTree>
+      <p:nvGrpSpPr>
+        <p:cNvPr id="1" name=""/>
+        <p:cNvGrpSpPr/>
+        <p:nvPr/>
+      </p:nvGrpSpPr>
+      <p:grpSpPr/>
+      <p:sp>
+        <p:nvSpPr>
+          <p:cNvPr id="2" name="Rectangle 1"/>
+          <p:cNvSpPr/>
+          <p:nvPr/>
+        </p:nvSpPr>
+        <p:spPr>
+          <a:xfrm>
+            <a:off x="0" y="0"/>
+            <a:ext cx="12191695" cy="6858000"/>
+          </a:xfrm>
+          <a:prstGeom prst="rect">
+            <a:avLst/>
+          </a:prstGeom>
+          <a:solidFill>
+            <a:srgbClr val="F6F8FB"/>
+          </a:solidFill>
+          <a:ln>
+            <a:noFill/>
+          </a:ln>
+          <a:effectLst/>
+        </p:spPr>
+        <p:style>
+          <a:lnRef idx="1">
+            <a:schemeClr val="accent1"/>
+          </a:lnRef>
+          <a:fillRef idx="3">
+            <a:schemeClr val="accent1"/>
+          </a:fillRef>
+          <a:effectRef idx="2">
+            <a:schemeClr val="accent1"/>
+          </a:effectRef>
+          <a:fontRef idx="minor">
+            <a:schemeClr val="lt1"/>
+          </a:fontRef>
+        </p:style>
+        <p:txBody>
+          <a:bodyPr rtlCol="0" anchor="ctr"/>
+          <a:lstStyle/>
+          <a:p>
+            <a:pPr algn="ctr"/>
+          </a:p>
+        </p:txBody>
+      </p:sp>
+      <p:sp>
+        <p:nvSpPr>
+          <p:cNvPr id="3" name="Rectangle 2"/>
+          <p:cNvSpPr/>
+          <p:nvPr/>
+        </p:nvSpPr>
+        <p:spPr>
+          <a:xfrm>
+            <a:off x="822960" y="585216"/>
+            <a:ext cx="50292" cy="310896"/>
+          </a:xfrm>
+          <a:prstGeom prst="rect">
+            <a:avLst/>
+          </a:prstGeom>
+          <a:solidFill>
+            <a:srgbClr val="C8922B"/>
+          </a:solidFill>
+          <a:ln>
+            <a:noFill/>
+          </a:ln>
+          <a:effectLst/>
+        </p:spPr>
+        <p:style>
+          <a:lnRef idx="1">
+            <a:schemeClr val="accent1"/>
+          </a:lnRef>
+          <a:fillRef idx="3">
+            <a:schemeClr val="accent1"/>
+          </a:fillRef>
+          <a:effectRef idx="2">
+            <a:schemeClr val="accent1"/>
+          </a:effectRef>
+          <a:fontRef idx="minor">
+            <a:schemeClr val="lt1"/>
+          </a:fontRef>
+        </p:style>
+        <p:txBody>
+          <a:bodyPr rtlCol="0" anchor="ctr"/>
+          <a:lstStyle/>
+          <a:p>
+            <a:pPr algn="ctr"/>
+          </a:p>
+        </p:txBody>
+      </p:sp>
+      <p:sp>
+        <p:nvSpPr>
+          <p:cNvPr id="4" name="TextBox 3"/>
+          <p:cNvSpPr txBox="1"/>
+          <p:nvPr/>
+        </p:nvSpPr>
+        <p:spPr>
+          <a:xfrm>
+            <a:off x="987552" y="566928"/>
+            <a:ext cx="8229600" cy="365760"/>
+          </a:xfrm>
+          <a:prstGeom prst="rect">
+            <a:avLst/>
+          </a:prstGeom>
+          <a:noFill/>
+        </p:spPr>
+        <p:txBody>
+          <a:bodyPr wrap="square" anchor="t" lIns="0" rIns="0" tIns="0" bIns="0">
+            <a:spAutoFit/>
+          </a:bodyPr>
+          <a:lstStyle/>
+          <a:p>
+            <a:pPr algn="l">
+              <a:lnSpc>
+                <a:spcPct val="100000"/>
+              </a:lnSpc>
+            </a:pPr>
+            <a:r>
+              <a:rPr sz="1300" b="1">
+                <a:solidFill>
+                  <a:srgbClr val="C8922B"/>
+                </a:solidFill>
+                <a:latin typeface="Calibri"/>
+              </a:rPr>
+              <a:t>NO UNILATERAL CALLS</a:t>
+            </a:r>
+          </a:p>
+        </p:txBody>
+      </p:sp>
+      <p:sp>
+        <p:nvSpPr>
+          <p:cNvPr id="5" name="TextBox 4"/>
+          <p:cNvSpPr txBox="1"/>
+          <p:nvPr/>
+        </p:nvSpPr>
+        <p:spPr>
+          <a:xfrm>
+            <a:off x="822960" y="868680"/>
+            <a:ext cx="10607040" cy="822960"/>
+          </a:xfrm>
+          <a:prstGeom prst="rect">
+            <a:avLst/>
+          </a:prstGeom>
+          <a:noFill/>
+        </p:spPr>
+        <p:txBody>
+          <a:bodyPr wrap="square" anchor="t" lIns="0" rIns="0" tIns="0" bIns="0">
+            <a:spAutoFit/>
+          </a:bodyPr>
+          <a:lstStyle/>
+          <a:p>
+            <a:pPr algn="l">
+              <a:lnSpc>
+                <a:spcPct val="100000"/>
+              </a:lnSpc>
+            </a:pPr>
+            <a:r>
+              <a:rPr sz="3000" b="1">
+                <a:solidFill>
+                  <a:srgbClr val="0F1A2B"/>
+                </a:solidFill>
+                <a:latin typeface="Calibri"/>
+              </a:rPr>
+              <a:t>Governance — a specialist committee ranks &amp; signs off</a:t>
+            </a:r>
+          </a:p>
+        </p:txBody>
+      </p:sp>
+      <p:sp>
+        <p:nvSpPr>
+          <p:cNvPr id="6" name="Rectangle 5"/>
+          <p:cNvSpPr/>
+          <p:nvPr/>
+        </p:nvSpPr>
+        <p:spPr>
+          <a:xfrm>
+            <a:off x="822960" y="1572768"/>
+            <a:ext cx="10543032" cy="18288"/>
+          </a:xfrm>
+          <a:prstGeom prst="rect">
+            <a:avLst/>
+          </a:prstGeom>
+          <a:solidFill>
+            <a:srgbClr val="D9DFE7"/>
+          </a:solidFill>
+          <a:ln>
+            <a:noFill/>
+          </a:ln>
+          <a:effectLst/>
+        </p:spPr>
+        <p:style>
+          <a:lnRef idx="1">
+            <a:schemeClr val="accent1"/>
+          </a:lnRef>
+          <a:fillRef idx="3">
+            <a:schemeClr val="accent1"/>
+          </a:fillRef>
+          <a:effectRef idx="2">
+            <a:schemeClr val="accent1"/>
+          </a:effectRef>
+          <a:fontRef idx="minor">
+            <a:schemeClr val="lt1"/>
+          </a:fontRef>
+        </p:style>
+        <p:txBody>
+          <a:bodyPr rtlCol="0" anchor="ctr"/>
+          <a:lstStyle/>
+          <a:p>
+            <a:pPr algn="ctr"/>
+          </a:p>
+        </p:txBody>
+      </p:sp>
+      <p:sp>
+        <p:nvSpPr>
+          <p:cNvPr id="7" name="TextBox 6"/>
+          <p:cNvSpPr txBox="1"/>
+          <p:nvPr/>
+        </p:nvSpPr>
+        <p:spPr>
+          <a:xfrm>
+            <a:off x="11247120" y="6419088"/>
+            <a:ext cx="822960" cy="274320"/>
+          </a:xfrm>
+          <a:prstGeom prst="rect">
+            <a:avLst/>
+          </a:prstGeom>
+          <a:noFill/>
+        </p:spPr>
+        <p:txBody>
+          <a:bodyPr wrap="square" anchor="t" lIns="0" rIns="0" tIns="0" bIns="0">
+            <a:spAutoFit/>
+          </a:bodyPr>
+          <a:lstStyle/>
+          <a:p>
+            <a:pPr algn="r">
+              <a:lnSpc>
+                <a:spcPct val="100000"/>
+              </a:lnSpc>
+            </a:pPr>
+            <a:r>
+              <a:rPr sz="1100" b="0">
+                <a:solidFill>
+                  <a:srgbClr val="5A6778"/>
+                </a:solidFill>
+                <a:latin typeface="Calibri"/>
+              </a:rPr>
+              <a:t>15</a:t>
+            </a:r>
+          </a:p>
+        </p:txBody>
+      </p:sp>
+      <p:sp>
+        <p:nvSpPr>
+          <p:cNvPr id="8" name="TextBox 7"/>
+          <p:cNvSpPr txBox="1"/>
+          <p:nvPr/>
+        </p:nvSpPr>
+        <p:spPr>
+          <a:xfrm>
+            <a:off x="822960" y="1691640"/>
+            <a:ext cx="10515600" cy="365760"/>
+          </a:xfrm>
+          <a:prstGeom prst="rect">
+            <a:avLst/>
+          </a:prstGeom>
+          <a:noFill/>
+        </p:spPr>
+        <p:txBody>
+          <a:bodyPr wrap="square" anchor="t" lIns="0" rIns="0" tIns="0" bIns="0">
+            <a:spAutoFit/>
+          </a:bodyPr>
+          <a:lstStyle/>
+          <a:p>
+            <a:pPr algn="l">
+              <a:lnSpc>
+                <a:spcPct val="100000"/>
+              </a:lnSpc>
+            </a:pPr>
+            <a:r>
+              <a:rPr sz="1300" b="0">
+                <a:solidFill>
+                  <a:srgbClr val="5A6778"/>
+                </a:solidFill>
+                <a:latin typeface="Calibri"/>
+              </a:rPr>
+              <a:t>Every ranked decision — coordination model, register-vs-message fork, jurisdiction go/no-go, each RCN — is a committee decision, gated on-chain.</a:t>
+            </a:r>
+          </a:p>
+        </p:txBody>
+      </p:sp>
+      <p:sp>
+        <p:nvSpPr>
+          <p:cNvPr id="9" name="Rounded Rectangle 8"/>
+          <p:cNvSpPr/>
+          <p:nvPr/>
+        </p:nvSpPr>
+        <p:spPr>
+          <a:xfrm>
+            <a:off x="822960" y="2286000"/>
+            <a:ext cx="3337560" cy="777240"/>
+          </a:xfrm>
+          <a:prstGeom prst="roundRect">
+            <a:avLst/>
+          </a:prstGeom>
+          <a:solidFill>
+            <a:srgbClr val="FFFFFF"/>
+          </a:solidFill>
+          <a:ln w="12700">
+            <a:solidFill>
+              <a:srgbClr val="D9DFE7"/>
+            </a:solidFill>
+          </a:ln>
+          <a:effectLst/>
+        </p:spPr>
+        <p:style>
+          <a:lnRef idx="1">
+            <a:schemeClr val="accent1"/>
+          </a:lnRef>
+          <a:fillRef idx="3">
+            <a:schemeClr val="accent1"/>
+          </a:fillRef>
+          <a:effectRef idx="2">
+            <a:schemeClr val="accent1"/>
+          </a:effectRef>
+          <a:fontRef idx="minor">
+            <a:schemeClr val="lt1"/>
+          </a:fontRef>
+        </p:style>
+        <p:txBody>
+          <a:bodyPr rtlCol="0" anchor="ctr"/>
+          <a:lstStyle/>
+          <a:p>
+            <a:pPr algn="ctr"/>
+          </a:p>
+        </p:txBody>
+      </p:sp>
+      <p:sp>
+        <p:nvSpPr>
+          <p:cNvPr id="10" name="Rectangle 9"/>
+          <p:cNvSpPr/>
+          <p:nvPr/>
+        </p:nvSpPr>
+        <p:spPr>
+          <a:xfrm>
+            <a:off x="822960" y="2286000"/>
+            <a:ext cx="91440" cy="777240"/>
+          </a:xfrm>
+          <a:prstGeom prst="rect">
+            <a:avLst/>
+          </a:prstGeom>
+          <a:solidFill>
+            <a:srgbClr val="2D6CDF"/>
+          </a:solidFill>
+          <a:ln>
+            <a:noFill/>
+          </a:ln>
+          <a:effectLst/>
+        </p:spPr>
+        <p:style>
+          <a:lnRef idx="1">
+            <a:schemeClr val="accent1"/>
+          </a:lnRef>
+          <a:fillRef idx="3">
+            <a:schemeClr val="accent1"/>
+          </a:fillRef>
+          <a:effectRef idx="2">
+            <a:schemeClr val="accent1"/>
+          </a:effectRef>
+          <a:fontRef idx="minor">
+            <a:schemeClr val="lt1"/>
+          </a:fontRef>
+        </p:style>
+        <p:txBody>
+          <a:bodyPr rtlCol="0" anchor="ctr"/>
+          <a:lstStyle/>
+          <a:p>
+            <a:pPr algn="ctr"/>
+          </a:p>
+        </p:txBody>
+      </p:sp>
+      <p:sp>
+        <p:nvSpPr>
+          <p:cNvPr id="11" name="TextBox 10"/>
+          <p:cNvSpPr txBox="1"/>
+          <p:nvPr/>
+        </p:nvSpPr>
+        <p:spPr>
+          <a:xfrm>
+            <a:off x="1024128" y="2377440"/>
+            <a:ext cx="3063240" cy="603504"/>
+          </a:xfrm>
+          <a:prstGeom prst="rect">
+            <a:avLst/>
+          </a:prstGeom>
+          <a:noFill/>
+        </p:spPr>
+        <p:txBody>
+          <a:bodyPr wrap="square" anchor="ctr" lIns="0" rIns="0" tIns="0" bIns="0">
+            <a:spAutoFit/>
+          </a:bodyPr>
+          <a:lstStyle/>
+          <a:p>
+            <a:pPr algn="l">
+              <a:lnSpc>
+                <a:spcPct val="100000"/>
+              </a:lnSpc>
+            </a:pPr>
+            <a:r>
+              <a:rPr sz="1300" b="1">
+                <a:solidFill>
+                  <a:srgbClr val="0F1A2B"/>
+                </a:solidFill>
+                <a:latin typeface="Calibri"/>
+              </a:rPr>
+              <a:t>DLT / contract eng.</a:t>
+            </a:r>
+          </a:p>
+          <a:p>
+            <a:pPr algn="l">
+              <a:lnSpc>
+                <a:spcPct val="100000"/>
+              </a:lnSpc>
+            </a:pPr>
+            <a:r>
+              <a:rPr sz="1050" b="0">
+                <a:solidFill>
+                  <a:srgbClr val="5A6778"/>
+                </a:solidFill>
+                <a:latin typeface="Calibri"/>
+              </a:rPr>
+              <a:t>contract &amp; key-mgmt model</a:t>
+            </a:r>
+          </a:p>
+        </p:txBody>
+      </p:sp>
+      <p:sp>
+        <p:nvSpPr>
+          <p:cNvPr id="12" name="Rounded Rectangle 11"/>
+          <p:cNvSpPr/>
+          <p:nvPr/>
+        </p:nvSpPr>
+        <p:spPr>
+          <a:xfrm>
+            <a:off x="4361688" y="2286000"/>
+            <a:ext cx="3337560" cy="777240"/>
+          </a:xfrm>
+          <a:prstGeom prst="roundRect">
+            <a:avLst/>
+          </a:prstGeom>
+          <a:solidFill>
+            <a:srgbClr val="FFFFFF"/>
+          </a:solidFill>
+          <a:ln w="12700">
+            <a:solidFill>
+              <a:srgbClr val="D9DFE7"/>
+            </a:solidFill>
+          </a:ln>
+          <a:effectLst/>
+        </p:spPr>
+        <p:style>
+          <a:lnRef idx="1">
+            <a:schemeClr val="accent1"/>
+          </a:lnRef>
+          <a:fillRef idx="3">
+            <a:schemeClr val="accent1"/>
+          </a:fillRef>
+          <a:effectRef idx="2">
+            <a:schemeClr val="accent1"/>
+          </a:effectRef>
+          <a:fontRef idx="minor">
+            <a:schemeClr val="lt1"/>
+          </a:fontRef>
+        </p:style>
+        <p:txBody>
+          <a:bodyPr rtlCol="0" anchor="ctr"/>
+          <a:lstStyle/>
+          <a:p>
+            <a:pPr algn="ctr"/>
+          </a:p>
+        </p:txBody>
+      </p:sp>
+      <p:sp>
+        <p:nvSpPr>
+          <p:cNvPr id="13" name="Rectangle 12"/>
+          <p:cNvSpPr/>
+          <p:nvPr/>
+        </p:nvSpPr>
+        <p:spPr>
+          <a:xfrm>
+            <a:off x="4361688" y="2286000"/>
+            <a:ext cx="91440" cy="777240"/>
+          </a:xfrm>
+          <a:prstGeom prst="rect">
+            <a:avLst/>
+          </a:prstGeom>
+          <a:solidFill>
+            <a:srgbClr val="2D6CDF"/>
+          </a:solidFill>
+          <a:ln>
+            <a:noFill/>
+          </a:ln>
+          <a:effectLst/>
+        </p:spPr>
+        <p:style>
+          <a:lnRef idx="1">
+            <a:schemeClr val="accent1"/>
+          </a:lnRef>
+          <a:fillRef idx="3">
+            <a:schemeClr val="accent1"/>
+          </a:fillRef>
+          <a:effectRef idx="2">
+            <a:schemeClr val="accent1"/>
+          </a:effectRef>
+          <a:fontRef idx="minor">
+            <a:schemeClr val="lt1"/>
+          </a:fontRef>
+        </p:style>
+        <p:txBody>
+          <a:bodyPr rtlCol="0" anchor="ctr"/>
+          <a:lstStyle/>
+          <a:p>
+            <a:pPr algn="ctr"/>
+          </a:p>
+        </p:txBody>
+      </p:sp>
+      <p:sp>
+        <p:nvSpPr>
+          <p:cNvPr id="14" name="TextBox 13"/>
+          <p:cNvSpPr txBox="1"/>
+          <p:nvPr/>
+        </p:nvSpPr>
+        <p:spPr>
+          <a:xfrm>
+            <a:off x="4562856" y="2377440"/>
+            <a:ext cx="3063240" cy="603504"/>
+          </a:xfrm>
+          <a:prstGeom prst="rect">
+            <a:avLst/>
+          </a:prstGeom>
+          <a:noFill/>
+        </p:spPr>
+        <p:txBody>
+          <a:bodyPr wrap="square" anchor="ctr" lIns="0" rIns="0" tIns="0" bIns="0">
+            <a:spAutoFit/>
+          </a:bodyPr>
+          <a:lstStyle/>
+          <a:p>
+            <a:pPr algn="l">
+              <a:lnSpc>
+                <a:spcPct val="100000"/>
+              </a:lnSpc>
+            </a:pPr>
+            <a:r>
+              <a:rPr sz="1300" b="1">
+                <a:solidFill>
+                  <a:srgbClr val="0F1A2B"/>
+                </a:solidFill>
+                <a:latin typeface="Calibri"/>
+              </a:rPr>
+              <a:t>FireFly architecture</a:t>
+            </a:r>
+          </a:p>
+          <a:p>
+            <a:pPr algn="l">
+              <a:lnSpc>
+                <a:spcPct val="100000"/>
+              </a:lnSpc>
+            </a:pPr>
+            <a:r>
+              <a:rPr sz="1050" b="0">
+                <a:solidFill>
+                  <a:srgbClr val="5A6778"/>
+                </a:solidFill>
+                <a:latin typeface="Calibri"/>
+              </a:rPr>
+              <a:t>messaging &amp; reconciliation</a:t>
+            </a:r>
+          </a:p>
+        </p:txBody>
+      </p:sp>
+      <p:sp>
+        <p:nvSpPr>
+          <p:cNvPr id="15" name="Rounded Rectangle 14"/>
+          <p:cNvSpPr/>
+          <p:nvPr/>
+        </p:nvSpPr>
+        <p:spPr>
+          <a:xfrm>
+            <a:off x="7900416" y="2286000"/>
+            <a:ext cx="3337560" cy="777240"/>
+          </a:xfrm>
+          <a:prstGeom prst="roundRect">
+            <a:avLst/>
+          </a:prstGeom>
+          <a:solidFill>
+            <a:srgbClr val="FFFFFF"/>
+          </a:solidFill>
+          <a:ln w="12700">
+            <a:solidFill>
+              <a:srgbClr val="D9DFE7"/>
+            </a:solidFill>
+          </a:ln>
+          <a:effectLst/>
+        </p:spPr>
+        <p:style>
+          <a:lnRef idx="1">
+            <a:schemeClr val="accent1"/>
+          </a:lnRef>
+          <a:fillRef idx="3">
+            <a:schemeClr val="accent1"/>
+          </a:fillRef>
+          <a:effectRef idx="2">
+            <a:schemeClr val="accent1"/>
+          </a:effectRef>
+          <a:fontRef idx="minor">
+            <a:schemeClr val="lt1"/>
+          </a:fontRef>
+        </p:style>
+        <p:txBody>
+          <a:bodyPr rtlCol="0" anchor="ctr"/>
+          <a:lstStyle/>
+          <a:p>
+            <a:pPr algn="ctr"/>
+          </a:p>
+        </p:txBody>
+      </p:sp>
+      <p:sp>
+        <p:nvSpPr>
+          <p:cNvPr id="16" name="Rectangle 15"/>
+          <p:cNvSpPr/>
+          <p:nvPr/>
+        </p:nvSpPr>
+        <p:spPr>
+          <a:xfrm>
+            <a:off x="7900416" y="2286000"/>
+            <a:ext cx="91440" cy="777240"/>
+          </a:xfrm>
+          <a:prstGeom prst="rect">
+            <a:avLst/>
+          </a:prstGeom>
+          <a:solidFill>
+            <a:srgbClr val="119DA4"/>
+          </a:solidFill>
+          <a:ln>
+            <a:noFill/>
+          </a:ln>
+          <a:effectLst/>
+        </p:spPr>
+        <p:style>
+          <a:lnRef idx="1">
+            <a:schemeClr val="accent1"/>
+          </a:lnRef>
+          <a:fillRef idx="3">
+            <a:schemeClr val="accent1"/>
+          </a:fillRef>
+          <a:effectRef idx="2">
+            <a:schemeClr val="accent1"/>
+          </a:effectRef>
+          <a:fontRef idx="minor">
+            <a:schemeClr val="lt1"/>
+          </a:fontRef>
+        </p:style>
+        <p:txBody>
+          <a:bodyPr rtlCol="0" anchor="ctr"/>
+          <a:lstStyle/>
+          <a:p>
+            <a:pPr algn="ctr"/>
+          </a:p>
+        </p:txBody>
+      </p:sp>
+      <p:sp>
+        <p:nvSpPr>
+          <p:cNvPr id="17" name="TextBox 16"/>
+          <p:cNvSpPr txBox="1"/>
+          <p:nvPr/>
+        </p:nvSpPr>
+        <p:spPr>
+          <a:xfrm>
+            <a:off x="8101584" y="2377440"/>
+            <a:ext cx="3063240" cy="603504"/>
+          </a:xfrm>
+          <a:prstGeom prst="rect">
+            <a:avLst/>
+          </a:prstGeom>
+          <a:noFill/>
+        </p:spPr>
+        <p:txBody>
+          <a:bodyPr wrap="square" anchor="ctr" lIns="0" rIns="0" tIns="0" bIns="0">
+            <a:spAutoFit/>
+          </a:bodyPr>
+          <a:lstStyle/>
+          <a:p>
+            <a:pPr algn="l">
+              <a:lnSpc>
+                <a:spcPct val="100000"/>
+              </a:lnSpc>
+            </a:pPr>
+            <a:r>
+              <a:rPr sz="1300" b="1">
+                <a:solidFill>
+                  <a:srgbClr val="0F1A2B"/>
+                </a:solidFill>
+                <a:latin typeface="Calibri"/>
+              </a:rPr>
+              <a:t>Payments &amp; settlement</a:t>
+            </a:r>
+          </a:p>
+          <a:p>
+            <a:pPr algn="l">
+              <a:lnSpc>
+                <a:spcPct val="100000"/>
+              </a:lnSpc>
+            </a:pPr>
+            <a:r>
+              <a:rPr sz="1050" b="0">
+                <a:solidFill>
+                  <a:srgbClr val="5A6778"/>
+                </a:solidFill>
+                <a:latin typeface="Calibri"/>
+              </a:rPr>
+              <a:t>rail, escrow, §4 model rank</a:t>
+            </a:r>
+          </a:p>
+        </p:txBody>
+      </p:sp>
+      <p:sp>
+        <p:nvSpPr>
+          <p:cNvPr id="18" name="Rounded Rectangle 17"/>
+          <p:cNvSpPr/>
+          <p:nvPr/>
+        </p:nvSpPr>
+        <p:spPr>
+          <a:xfrm>
+            <a:off x="822960" y="3200400"/>
+            <a:ext cx="3337560" cy="777240"/>
+          </a:xfrm>
+          <a:prstGeom prst="roundRect">
+            <a:avLst/>
+          </a:prstGeom>
+          <a:solidFill>
+            <a:srgbClr val="FFFFFF"/>
+          </a:solidFill>
+          <a:ln w="12700">
+            <a:solidFill>
+              <a:srgbClr val="D9DFE7"/>
+            </a:solidFill>
+          </a:ln>
+          <a:effectLst/>
+        </p:spPr>
+        <p:style>
+          <a:lnRef idx="1">
+            <a:schemeClr val="accent1"/>
+          </a:lnRef>
+          <a:fillRef idx="3">
+            <a:schemeClr val="accent1"/>
+          </a:fillRef>
+          <a:effectRef idx="2">
+            <a:schemeClr val="accent1"/>
+          </a:effectRef>
+          <a:fontRef idx="minor">
+            <a:schemeClr val="lt1"/>
+          </a:fontRef>
+        </p:style>
+        <p:txBody>
+          <a:bodyPr rtlCol="0" anchor="ctr"/>
+          <a:lstStyle/>
+          <a:p>
+            <a:pPr algn="ctr"/>
+          </a:p>
+        </p:txBody>
+      </p:sp>
+      <p:sp>
+        <p:nvSpPr>
+          <p:cNvPr id="19" name="Rectangle 18"/>
+          <p:cNvSpPr/>
+          <p:nvPr/>
+        </p:nvSpPr>
+        <p:spPr>
+          <a:xfrm>
+            <a:off x="822960" y="3200400"/>
+            <a:ext cx="91440" cy="777240"/>
+          </a:xfrm>
+          <a:prstGeom prst="rect">
+            <a:avLst/>
+          </a:prstGeom>
+          <a:solidFill>
+            <a:srgbClr val="7A4FA8"/>
+          </a:solidFill>
+          <a:ln>
+            <a:noFill/>
+          </a:ln>
+          <a:effectLst/>
+        </p:spPr>
+        <p:style>
+          <a:lnRef idx="1">
+            <a:schemeClr val="accent1"/>
+          </a:lnRef>
+          <a:fillRef idx="3">
+            <a:schemeClr val="accent1"/>
+          </a:fillRef>
+          <a:effectRef idx="2">
+            <a:schemeClr val="accent1"/>
+          </a:effectRef>
+          <a:fontRef idx="minor">
+            <a:schemeClr val="lt1"/>
+          </a:fontRef>
+        </p:style>
+        <p:txBody>
+          <a:bodyPr rtlCol="0" anchor="ctr"/>
+          <a:lstStyle/>
+          <a:p>
+            <a:pPr algn="ctr"/>
+          </a:p>
+        </p:txBody>
+      </p:sp>
+      <p:sp>
+        <p:nvSpPr>
+          <p:cNvPr id="20" name="TextBox 19"/>
+          <p:cNvSpPr txBox="1"/>
+          <p:nvPr/>
+        </p:nvSpPr>
+        <p:spPr>
+          <a:xfrm>
+            <a:off x="1024128" y="3291840"/>
+            <a:ext cx="3063240" cy="603504"/>
+          </a:xfrm>
+          <a:prstGeom prst="rect">
+            <a:avLst/>
+          </a:prstGeom>
+          <a:noFill/>
+        </p:spPr>
+        <p:txBody>
+          <a:bodyPr wrap="square" anchor="ctr" lIns="0" rIns="0" tIns="0" bIns="0">
+            <a:spAutoFit/>
+          </a:bodyPr>
+          <a:lstStyle/>
+          <a:p>
+            <a:pPr algn="l">
+              <a:lnSpc>
+                <a:spcPct val="100000"/>
+              </a:lnSpc>
+            </a:pPr>
+            <a:r>
+              <a:rPr sz="1300" b="1">
+                <a:solidFill>
+                  <a:srgbClr val="0F1A2B"/>
+                </a:solidFill>
+                <a:latin typeface="Calibri"/>
+              </a:rPr>
+              <a:t>Securities law</a:t>
+            </a:r>
+          </a:p>
+          <a:p>
+            <a:pPr algn="l">
+              <a:lnSpc>
+                <a:spcPct val="100000"/>
+              </a:lnSpc>
+            </a:pPr>
+            <a:r>
+              <a:rPr sz="1050" b="0">
+                <a:solidFill>
+                  <a:srgbClr val="5A6778"/>
+                </a:solidFill>
+                <a:latin typeface="Calibri"/>
+              </a:rPr>
+              <a:t>classification, §11 fork</a:t>
+            </a:r>
+          </a:p>
+        </p:txBody>
+      </p:sp>
+      <p:sp>
+        <p:nvSpPr>
+          <p:cNvPr id="21" name="Rounded Rectangle 20"/>
+          <p:cNvSpPr/>
+          <p:nvPr/>
+        </p:nvSpPr>
+        <p:spPr>
+          <a:xfrm>
+            <a:off x="4361688" y="3200400"/>
+            <a:ext cx="3337560" cy="777240"/>
+          </a:xfrm>
+          <a:prstGeom prst="roundRect">
+            <a:avLst/>
+          </a:prstGeom>
+          <a:solidFill>
+            <a:srgbClr val="FFFFFF"/>
+          </a:solidFill>
+          <a:ln w="12700">
+            <a:solidFill>
+              <a:srgbClr val="D9DFE7"/>
+            </a:solidFill>
+          </a:ln>
+          <a:effectLst/>
+        </p:spPr>
+        <p:style>
+          <a:lnRef idx="1">
+            <a:schemeClr val="accent1"/>
+          </a:lnRef>
+          <a:fillRef idx="3">
+            <a:schemeClr val="accent1"/>
+          </a:fillRef>
+          <a:effectRef idx="2">
+            <a:schemeClr val="accent1"/>
+          </a:effectRef>
+          <a:fontRef idx="minor">
+            <a:schemeClr val="lt1"/>
+          </a:fontRef>
+        </p:style>
+        <p:txBody>
+          <a:bodyPr rtlCol="0" anchor="ctr"/>
+          <a:lstStyle/>
+          <a:p>
+            <a:pPr algn="ctr"/>
+          </a:p>
+        </p:txBody>
+      </p:sp>
+      <p:sp>
+        <p:nvSpPr>
+          <p:cNvPr id="22" name="Rectangle 21"/>
+          <p:cNvSpPr/>
+          <p:nvPr/>
+        </p:nvSpPr>
+        <p:spPr>
+          <a:xfrm>
+            <a:off x="4361688" y="3200400"/>
+            <a:ext cx="91440" cy="777240"/>
+          </a:xfrm>
+          <a:prstGeom prst="rect">
+            <a:avLst/>
+          </a:prstGeom>
+          <a:solidFill>
+            <a:srgbClr val="7A4FA8"/>
+          </a:solidFill>
+          <a:ln>
+            <a:noFill/>
+          </a:ln>
+          <a:effectLst/>
+        </p:spPr>
+        <p:style>
+          <a:lnRef idx="1">
+            <a:schemeClr val="accent1"/>
+          </a:lnRef>
+          <a:fillRef idx="3">
+            <a:schemeClr val="accent1"/>
+          </a:fillRef>
+          <a:effectRef idx="2">
+            <a:schemeClr val="accent1"/>
+          </a:effectRef>
+          <a:fontRef idx="minor">
+            <a:schemeClr val="lt1"/>
+          </a:fontRef>
+        </p:style>
+        <p:txBody>
+          <a:bodyPr rtlCol="0" anchor="ctr"/>
+          <a:lstStyle/>
+          <a:p>
+            <a:pPr algn="ctr"/>
+          </a:p>
+        </p:txBody>
+      </p:sp>
+      <p:sp>
+        <p:nvSpPr>
+          <p:cNvPr id="23" name="TextBox 22"/>
+          <p:cNvSpPr txBox="1"/>
+          <p:nvPr/>
+        </p:nvSpPr>
+        <p:spPr>
+          <a:xfrm>
+            <a:off x="4562856" y="3291840"/>
+            <a:ext cx="3063240" cy="603504"/>
+          </a:xfrm>
+          <a:prstGeom prst="rect">
+            <a:avLst/>
+          </a:prstGeom>
+          <a:noFill/>
+        </p:spPr>
+        <p:txBody>
+          <a:bodyPr wrap="square" anchor="ctr" lIns="0" rIns="0" tIns="0" bIns="0">
+            <a:spAutoFit/>
+          </a:bodyPr>
+          <a:lstStyle/>
+          <a:p>
+            <a:pPr algn="l">
+              <a:lnSpc>
+                <a:spcPct val="100000"/>
+              </a:lnSpc>
+            </a:pPr>
+            <a:r>
+              <a:rPr sz="1300" b="1">
+                <a:solidFill>
+                  <a:srgbClr val="0F1A2B"/>
+                </a:solidFill>
+                <a:latin typeface="Calibri"/>
+              </a:rPr>
+              <a:t>AML / compliance</a:t>
+            </a:r>
+          </a:p>
+          <a:p>
+            <a:pPr algn="l">
+              <a:lnSpc>
+                <a:spcPct val="100000"/>
+              </a:lnSpc>
+            </a:pPr>
+            <a:r>
+              <a:rPr sz="1050" b="0">
+                <a:solidFill>
+                  <a:srgbClr val="5A6778"/>
+                </a:solidFill>
+                <a:latin typeface="Calibri"/>
+              </a:rPr>
+              <a:t>Travel Rule, §6 jurisdictions</a:t>
+            </a:r>
+          </a:p>
+        </p:txBody>
+      </p:sp>
+      <p:sp>
+        <p:nvSpPr>
+          <p:cNvPr id="24" name="Rounded Rectangle 23"/>
+          <p:cNvSpPr/>
+          <p:nvPr/>
+        </p:nvSpPr>
+        <p:spPr>
+          <a:xfrm>
+            <a:off x="7900416" y="3200400"/>
+            <a:ext cx="3337560" cy="777240"/>
+          </a:xfrm>
+          <a:prstGeom prst="roundRect">
+            <a:avLst/>
+          </a:prstGeom>
+          <a:solidFill>
+            <a:srgbClr val="FFFFFF"/>
+          </a:solidFill>
+          <a:ln w="12700">
+            <a:solidFill>
+              <a:srgbClr val="D9DFE7"/>
+            </a:solidFill>
+          </a:ln>
+          <a:effectLst/>
+        </p:spPr>
+        <p:style>
+          <a:lnRef idx="1">
+            <a:schemeClr val="accent1"/>
+          </a:lnRef>
+          <a:fillRef idx="3">
+            <a:schemeClr val="accent1"/>
+          </a:fillRef>
+          <a:effectRef idx="2">
+            <a:schemeClr val="accent1"/>
+          </a:effectRef>
+          <a:fontRef idx="minor">
+            <a:schemeClr val="lt1"/>
+          </a:fontRef>
+        </p:style>
+        <p:txBody>
+          <a:bodyPr rtlCol="0" anchor="ctr"/>
+          <a:lstStyle/>
+          <a:p>
+            <a:pPr algn="ctr"/>
+          </a:p>
+        </p:txBody>
+      </p:sp>
+      <p:sp>
+        <p:nvSpPr>
+          <p:cNvPr id="25" name="Rectangle 24"/>
+          <p:cNvSpPr/>
+          <p:nvPr/>
+        </p:nvSpPr>
+        <p:spPr>
+          <a:xfrm>
+            <a:off x="7900416" y="3200400"/>
+            <a:ext cx="91440" cy="777240"/>
+          </a:xfrm>
+          <a:prstGeom prst="rect">
+            <a:avLst/>
+          </a:prstGeom>
+          <a:solidFill>
+            <a:srgbClr val="C8922B"/>
+          </a:solidFill>
+          <a:ln>
+            <a:noFill/>
+          </a:ln>
+          <a:effectLst/>
+        </p:spPr>
+        <p:style>
+          <a:lnRef idx="1">
+            <a:schemeClr val="accent1"/>
+          </a:lnRef>
+          <a:fillRef idx="3">
+            <a:schemeClr val="accent1"/>
+          </a:fillRef>
+          <a:effectRef idx="2">
+            <a:schemeClr val="accent1"/>
+          </a:effectRef>
+          <a:fontRef idx="minor">
+            <a:schemeClr val="lt1"/>
+          </a:fontRef>
+        </p:style>
+        <p:txBody>
+          <a:bodyPr rtlCol="0" anchor="ctr"/>
+          <a:lstStyle/>
+          <a:p>
+            <a:pPr algn="ctr"/>
+          </a:p>
+        </p:txBody>
+      </p:sp>
+      <p:sp>
+        <p:nvSpPr>
+          <p:cNvPr id="26" name="TextBox 25"/>
+          <p:cNvSpPr txBox="1"/>
+          <p:nvPr/>
+        </p:nvSpPr>
+        <p:spPr>
+          <a:xfrm>
+            <a:off x="8101584" y="3291840"/>
+            <a:ext cx="3063240" cy="603504"/>
+          </a:xfrm>
+          <a:prstGeom prst="rect">
+            <a:avLst/>
+          </a:prstGeom>
+          <a:noFill/>
+        </p:spPr>
+        <p:txBody>
+          <a:bodyPr wrap="square" anchor="ctr" lIns="0" rIns="0" tIns="0" bIns="0">
+            <a:spAutoFit/>
+          </a:bodyPr>
+          <a:lstStyle/>
+          <a:p>
+            <a:pPr algn="l">
+              <a:lnSpc>
+                <a:spcPct val="100000"/>
+              </a:lnSpc>
+            </a:pPr>
+            <a:r>
+              <a:rPr sz="1300" b="1">
+                <a:solidFill>
+                  <a:srgbClr val="0F1A2B"/>
+                </a:solidFill>
+                <a:latin typeface="Calibri"/>
+              </a:rPr>
+              <a:t>Market / credit risk</a:t>
+            </a:r>
+          </a:p>
+          <a:p>
+            <a:pPr algn="l">
+              <a:lnSpc>
+                <a:spcPct val="100000"/>
+              </a:lnSpc>
+            </a:pPr>
+            <a:r>
+              <a:rPr sz="1050" b="0">
+                <a:solidFill>
+                  <a:srgbClr val="5A6778"/>
+                </a:solidFill>
+                <a:latin typeface="Calibri"/>
+              </a:rPr>
+              <a:t>barrier, issuer &amp; concentration</a:t>
+            </a:r>
+          </a:p>
+        </p:txBody>
+      </p:sp>
+      <p:sp>
+        <p:nvSpPr>
+          <p:cNvPr id="27" name="TextBox 26"/>
+          <p:cNvSpPr txBox="1"/>
+          <p:nvPr/>
+        </p:nvSpPr>
+        <p:spPr>
+          <a:xfrm>
+            <a:off x="822960" y="4251960"/>
+            <a:ext cx="10515600" cy="320040"/>
+          </a:xfrm>
+          <a:prstGeom prst="rect">
+            <a:avLst/>
+          </a:prstGeom>
+          <a:noFill/>
+        </p:spPr>
+        <p:txBody>
+          <a:bodyPr wrap="square" anchor="t" lIns="0" rIns="0" tIns="0" bIns="0">
+            <a:spAutoFit/>
+          </a:bodyPr>
+          <a:lstStyle/>
+          <a:p>
+            <a:pPr algn="l">
+              <a:lnSpc>
+                <a:spcPct val="100000"/>
+              </a:lnSpc>
+            </a:pPr>
+            <a:r>
+              <a:rPr sz="1150" b="1">
+                <a:solidFill>
+                  <a:srgbClr val="142A4A"/>
+                </a:solidFill>
+                <a:latin typeface="Calibri"/>
+              </a:rPr>
+              <a:t>Quorum: legal + compliance + risk + one technical seat. Internal audit sits non-voting. Rankings minuted; dissents recorded.</a:t>
+            </a:r>
+          </a:p>
+        </p:txBody>
+      </p:sp>
+      <p:sp>
+        <p:nvSpPr>
+          <p:cNvPr id="28" name="Rounded Rectangle 27"/>
+          <p:cNvSpPr/>
+          <p:nvPr/>
+        </p:nvSpPr>
+        <p:spPr>
+          <a:xfrm>
+            <a:off x="822960" y="4709160"/>
+            <a:ext cx="10543032" cy="1508760"/>
+          </a:xfrm>
+          <a:prstGeom prst="roundRect">
+            <a:avLst/>
+          </a:prstGeom>
+          <a:solidFill>
+            <a:srgbClr val="0A121F"/>
+          </a:solidFill>
+          <a:ln w="12700">
+            <a:solidFill>
+              <a:srgbClr val="142A4A"/>
+            </a:solidFill>
+          </a:ln>
+          <a:effectLst/>
+        </p:spPr>
+        <p:style>
+          <a:lnRef idx="1">
+            <a:schemeClr val="accent1"/>
+          </a:lnRef>
+          <a:fillRef idx="3">
+            <a:schemeClr val="accent1"/>
+          </a:fillRef>
+          <a:effectRef idx="2">
+            <a:schemeClr val="accent1"/>
+          </a:effectRef>
+          <a:fontRef idx="minor">
+            <a:schemeClr val="lt1"/>
+          </a:fontRef>
+        </p:style>
+        <p:txBody>
+          <a:bodyPr rtlCol="0" anchor="ctr"/>
+          <a:lstStyle/>
+          <a:p>
+            <a:pPr algn="ctr"/>
+          </a:p>
+        </p:txBody>
+      </p:sp>
+      <p:sp>
+        <p:nvSpPr>
+          <p:cNvPr id="29" name="TextBox 28"/>
+          <p:cNvSpPr txBox="1"/>
+          <p:nvPr/>
+        </p:nvSpPr>
+        <p:spPr>
+          <a:xfrm>
+            <a:off x="1051560" y="4828032"/>
+            <a:ext cx="10149840" cy="365760"/>
+          </a:xfrm>
+          <a:prstGeom prst="rect">
+            <a:avLst/>
+          </a:prstGeom>
+          <a:noFill/>
+        </p:spPr>
+        <p:txBody>
+          <a:bodyPr wrap="square" anchor="t" lIns="0" rIns="0" tIns="0" bIns="0">
+            <a:spAutoFit/>
+          </a:bodyPr>
+          <a:lstStyle/>
+          <a:p>
+            <a:pPr algn="l">
+              <a:lnSpc>
+                <a:spcPct val="100000"/>
+              </a:lnSpc>
+            </a:pPr>
+            <a:r>
+              <a:rPr sz="1400" b="1">
+                <a:solidFill>
+                  <a:srgbClr val="C8922B"/>
+                </a:solidFill>
+                <a:latin typeface="Calibri"/>
+              </a:rPr>
+              <a:t>Decision → on-chain gate  (approval is a mint precondition, not a PDF)</a:t>
+            </a:r>
+          </a:p>
+        </p:txBody>
+      </p:sp>
+      <p:sp>
+        <p:nvSpPr>
+          <p:cNvPr id="30" name="Rounded Rectangle 29"/>
+          <p:cNvSpPr/>
+          <p:nvPr/>
+        </p:nvSpPr>
+        <p:spPr>
+          <a:xfrm>
+            <a:off x="1051560" y="5349240"/>
+            <a:ext cx="2468880" cy="640080"/>
+          </a:xfrm>
+          <a:prstGeom prst="roundRect">
+            <a:avLst/>
+          </a:prstGeom>
+          <a:solidFill>
+            <a:srgbClr val="142A4A"/>
+          </a:solidFill>
+          <a:ln>
+            <a:noFill/>
+          </a:ln>
+          <a:effectLst/>
+        </p:spPr>
+        <p:style>
+          <a:lnRef idx="1">
+            <a:schemeClr val="accent1"/>
+          </a:lnRef>
+          <a:fillRef idx="3">
+            <a:schemeClr val="accent1"/>
+          </a:fillRef>
+          <a:effectRef idx="2">
+            <a:schemeClr val="accent1"/>
+          </a:effectRef>
+          <a:fontRef idx="minor">
+            <a:schemeClr val="lt1"/>
+          </a:fontRef>
+        </p:style>
+        <p:txBody>
+          <a:bodyPr rtlCol="0" anchor="ctr"/>
+          <a:lstStyle/>
+          <a:p>
+            <a:pPr algn="ctr"/>
+          </a:p>
+        </p:txBody>
+      </p:sp>
+      <p:sp>
+        <p:nvSpPr>
+          <p:cNvPr id="31" name="TextBox 30"/>
+          <p:cNvSpPr txBox="1"/>
+          <p:nvPr/>
+        </p:nvSpPr>
+        <p:spPr>
+          <a:xfrm>
+            <a:off x="1143000" y="5394960"/>
+            <a:ext cx="2286000" cy="548640"/>
+          </a:xfrm>
+          <a:prstGeom prst="rect">
+            <a:avLst/>
+          </a:prstGeom>
+          <a:noFill/>
+        </p:spPr>
+        <p:txBody>
+          <a:bodyPr wrap="square" anchor="ctr" lIns="0" rIns="0" tIns="0" bIns="0">
+            <a:spAutoFit/>
+          </a:bodyPr>
+          <a:lstStyle/>
+          <a:p>
+            <a:pPr algn="ctr">
+              <a:lnSpc>
+                <a:spcPct val="95000"/>
+              </a:lnSpc>
+            </a:pPr>
+            <a:r>
+              <a:rPr sz="1100" b="1">
+                <a:solidFill>
+                  <a:srgbClr val="FFFFFF"/>
+                </a:solidFill>
+                <a:latin typeface="Calibri"/>
+              </a:rPr>
+              <a:t>Committee sign-off</a:t>
+            </a:r>
+          </a:p>
+        </p:txBody>
+      </p:sp>
+      <p:sp>
+        <p:nvSpPr>
+          <p:cNvPr id="32" name="TextBox 31"/>
+          <p:cNvSpPr txBox="1"/>
+          <p:nvPr/>
+        </p:nvSpPr>
+        <p:spPr>
+          <a:xfrm>
+            <a:off x="3465576" y="5413248"/>
+            <a:ext cx="365760" cy="457200"/>
+          </a:xfrm>
+          <a:prstGeom prst="rect">
+            <a:avLst/>
+          </a:prstGeom>
+          <a:noFill/>
+        </p:spPr>
+        <p:txBody>
+          <a:bodyPr wrap="square" anchor="t" lIns="0" rIns="0" tIns="0" bIns="0">
+            <a:spAutoFit/>
+          </a:bodyPr>
+          <a:lstStyle/>
+          <a:p>
+            <a:pPr algn="l">
+              <a:lnSpc>
+                <a:spcPct val="100000"/>
+              </a:lnSpc>
+            </a:pPr>
+            <a:r>
+              <a:rPr sz="1800" b="1">
+                <a:solidFill>
+                  <a:srgbClr val="C8922B"/>
+                </a:solidFill>
+                <a:latin typeface="Calibri"/>
+              </a:rPr>
+              <a:t>→</a:t>
+            </a:r>
+          </a:p>
+        </p:txBody>
+      </p:sp>
+      <p:sp>
+        <p:nvSpPr>
+          <p:cNvPr id="33" name="Rounded Rectangle 32"/>
+          <p:cNvSpPr/>
+          <p:nvPr/>
+        </p:nvSpPr>
+        <p:spPr>
+          <a:xfrm>
+            <a:off x="3639312" y="5349240"/>
+            <a:ext cx="2468880" cy="640080"/>
+          </a:xfrm>
+          <a:prstGeom prst="roundRect">
+            <a:avLst/>
+          </a:prstGeom>
+          <a:solidFill>
+            <a:srgbClr val="142A4A"/>
+          </a:solidFill>
+          <a:ln>
+            <a:noFill/>
+          </a:ln>
+          <a:effectLst/>
+        </p:spPr>
+        <p:style>
+          <a:lnRef idx="1">
+            <a:schemeClr val="accent1"/>
+          </a:lnRef>
+          <a:fillRef idx="3">
+            <a:schemeClr val="accent1"/>
+          </a:fillRef>
+          <a:effectRef idx="2">
+            <a:schemeClr val="accent1"/>
+          </a:effectRef>
+          <a:fontRef idx="minor">
+            <a:schemeClr val="lt1"/>
+          </a:fontRef>
+        </p:style>
+        <p:txBody>
+          <a:bodyPr rtlCol="0" anchor="ctr"/>
+          <a:lstStyle/>
+          <a:p>
+            <a:pPr algn="ctr"/>
+          </a:p>
+        </p:txBody>
+      </p:sp>
+      <p:sp>
+        <p:nvSpPr>
+          <p:cNvPr id="34" name="TextBox 33"/>
+          <p:cNvSpPr txBox="1"/>
+          <p:nvPr/>
+        </p:nvSpPr>
+        <p:spPr>
+          <a:xfrm>
+            <a:off x="3730752" y="5394960"/>
+            <a:ext cx="2286000" cy="548640"/>
+          </a:xfrm>
+          <a:prstGeom prst="rect">
+            <a:avLst/>
+          </a:prstGeom>
+          <a:noFill/>
+        </p:spPr>
+        <p:txBody>
+          <a:bodyPr wrap="square" anchor="ctr" lIns="0" rIns="0" tIns="0" bIns="0">
+            <a:spAutoFit/>
+          </a:bodyPr>
+          <a:lstStyle/>
+          <a:p>
+            <a:pPr algn="ctr">
+              <a:lnSpc>
+                <a:spcPct val="95000"/>
+              </a:lnSpc>
+            </a:pPr>
+            <a:r>
+              <a:rPr sz="1100" b="1">
+                <a:solidFill>
+                  <a:srgbClr val="FFFFFF"/>
+                </a:solidFill>
+                <a:latin typeface="Calibri"/>
+              </a:rPr>
+              <a:t>recordCommitteeApproval(productId)</a:t>
+            </a:r>
+          </a:p>
+        </p:txBody>
+      </p:sp>
+      <p:sp>
+        <p:nvSpPr>
+          <p:cNvPr id="35" name="TextBox 34"/>
+          <p:cNvSpPr txBox="1"/>
+          <p:nvPr/>
+        </p:nvSpPr>
+        <p:spPr>
+          <a:xfrm>
+            <a:off x="6053328" y="5413248"/>
+            <a:ext cx="365760" cy="457200"/>
+          </a:xfrm>
+          <a:prstGeom prst="rect">
+            <a:avLst/>
+          </a:prstGeom>
+          <a:noFill/>
+        </p:spPr>
+        <p:txBody>
+          <a:bodyPr wrap="square" anchor="t" lIns="0" rIns="0" tIns="0" bIns="0">
+            <a:spAutoFit/>
+          </a:bodyPr>
+          <a:lstStyle/>
+          <a:p>
+            <a:pPr algn="l">
+              <a:lnSpc>
+                <a:spcPct val="100000"/>
+              </a:lnSpc>
+            </a:pPr>
+            <a:r>
+              <a:rPr sz="1800" b="1">
+                <a:solidFill>
+                  <a:srgbClr val="C8922B"/>
+                </a:solidFill>
+                <a:latin typeface="Calibri"/>
+              </a:rPr>
+              <a:t>→</a:t>
+            </a:r>
+          </a:p>
+        </p:txBody>
+      </p:sp>
+      <p:sp>
+        <p:nvSpPr>
+          <p:cNvPr id="36" name="Rounded Rectangle 35"/>
+          <p:cNvSpPr/>
+          <p:nvPr/>
+        </p:nvSpPr>
+        <p:spPr>
+          <a:xfrm>
+            <a:off x="6227064" y="5349240"/>
+            <a:ext cx="2468880" cy="640080"/>
+          </a:xfrm>
+          <a:prstGeom prst="roundRect">
+            <a:avLst/>
+          </a:prstGeom>
+          <a:solidFill>
+            <a:srgbClr val="142A4A"/>
+          </a:solidFill>
+          <a:ln>
+            <a:noFill/>
+          </a:ln>
+          <a:effectLst/>
+        </p:spPr>
+        <p:style>
+          <a:lnRef idx="1">
+            <a:schemeClr val="accent1"/>
+          </a:lnRef>
+          <a:fillRef idx="3">
+            <a:schemeClr val="accent1"/>
+          </a:fillRef>
+          <a:effectRef idx="2">
+            <a:schemeClr val="accent1"/>
+          </a:effectRef>
+          <a:fontRef idx="minor">
+            <a:schemeClr val="lt1"/>
+          </a:fontRef>
+        </p:style>
+        <p:txBody>
+          <a:bodyPr rtlCol="0" anchor="ctr"/>
+          <a:lstStyle/>
+          <a:p>
+            <a:pPr algn="ctr"/>
+          </a:p>
+        </p:txBody>
+      </p:sp>
+      <p:sp>
+        <p:nvSpPr>
+          <p:cNvPr id="37" name="TextBox 36"/>
+          <p:cNvSpPr txBox="1"/>
+          <p:nvPr/>
+        </p:nvSpPr>
+        <p:spPr>
+          <a:xfrm>
+            <a:off x="6318504" y="5394960"/>
+            <a:ext cx="2286000" cy="548640"/>
+          </a:xfrm>
+          <a:prstGeom prst="rect">
+            <a:avLst/>
+          </a:prstGeom>
+          <a:noFill/>
+        </p:spPr>
+        <p:txBody>
+          <a:bodyPr wrap="square" anchor="ctr" lIns="0" rIns="0" tIns="0" bIns="0">
+            <a:spAutoFit/>
+          </a:bodyPr>
+          <a:lstStyle/>
+          <a:p>
+            <a:pPr algn="ctr">
+              <a:lnSpc>
+                <a:spcPct val="95000"/>
+              </a:lnSpc>
+            </a:pPr>
+            <a:r>
+              <a:rPr sz="1100" b="1">
+                <a:solidFill>
+                  <a:srgbClr val="FFFFFF"/>
+                </a:solidFill>
+                <a:latin typeface="Calibri"/>
+              </a:rPr>
+              <a:t>require(committeeApproved) → mint</a:t>
+            </a:r>
+          </a:p>
+        </p:txBody>
+      </p:sp>
+      <p:sp>
+        <p:nvSpPr>
+          <p:cNvPr id="38" name="TextBox 37"/>
+          <p:cNvSpPr txBox="1"/>
+          <p:nvPr/>
+        </p:nvSpPr>
+        <p:spPr>
+          <a:xfrm>
+            <a:off x="8641080" y="5413248"/>
+            <a:ext cx="365760" cy="457200"/>
+          </a:xfrm>
+          <a:prstGeom prst="rect">
+            <a:avLst/>
+          </a:prstGeom>
+          <a:noFill/>
+        </p:spPr>
+        <p:txBody>
+          <a:bodyPr wrap="square" anchor="t" lIns="0" rIns="0" tIns="0" bIns="0">
+            <a:spAutoFit/>
+          </a:bodyPr>
+          <a:lstStyle/>
+          <a:p>
+            <a:pPr algn="l">
+              <a:lnSpc>
+                <a:spcPct val="100000"/>
+              </a:lnSpc>
+            </a:pPr>
+            <a:r>
+              <a:rPr sz="1800" b="1">
+                <a:solidFill>
+                  <a:srgbClr val="C8922B"/>
+                </a:solidFill>
+                <a:latin typeface="Calibri"/>
+              </a:rPr>
+              <a:t>→</a:t>
+            </a:r>
+          </a:p>
+        </p:txBody>
+      </p:sp>
+      <p:sp>
+        <p:nvSpPr>
+          <p:cNvPr id="39" name="Rounded Rectangle 38"/>
+          <p:cNvSpPr/>
+          <p:nvPr/>
+        </p:nvSpPr>
+        <p:spPr>
+          <a:xfrm>
+            <a:off x="8814816" y="5349240"/>
+            <a:ext cx="2468880" cy="640080"/>
+          </a:xfrm>
+          <a:prstGeom prst="roundRect">
+            <a:avLst/>
+          </a:prstGeom>
+          <a:solidFill>
+            <a:srgbClr val="142A4A"/>
+          </a:solidFill>
+          <a:ln>
+            <a:noFill/>
+          </a:ln>
+          <a:effectLst/>
+        </p:spPr>
+        <p:style>
+          <a:lnRef idx="1">
+            <a:schemeClr val="accent1"/>
+          </a:lnRef>
+          <a:fillRef idx="3">
+            <a:schemeClr val="accent1"/>
+          </a:fillRef>
+          <a:effectRef idx="2">
+            <a:schemeClr val="accent1"/>
+          </a:effectRef>
+          <a:fontRef idx="minor">
+            <a:schemeClr val="lt1"/>
+          </a:fontRef>
+        </p:style>
+        <p:txBody>
+          <a:bodyPr rtlCol="0" anchor="ctr"/>
+          <a:lstStyle/>
+          <a:p>
+            <a:pPr algn="ctr"/>
+          </a:p>
+        </p:txBody>
+      </p:sp>
+      <p:sp>
+        <p:nvSpPr>
+          <p:cNvPr id="40" name="TextBox 39"/>
+          <p:cNvSpPr txBox="1"/>
+          <p:nvPr/>
+        </p:nvSpPr>
+        <p:spPr>
+          <a:xfrm>
+            <a:off x="8906256" y="5394960"/>
+            <a:ext cx="2286000" cy="548640"/>
+          </a:xfrm>
+          <a:prstGeom prst="rect">
+            <a:avLst/>
+          </a:prstGeom>
+          <a:noFill/>
+        </p:spPr>
+        <p:txBody>
+          <a:bodyPr wrap="square" anchor="ctr" lIns="0" rIns="0" tIns="0" bIns="0">
+            <a:spAutoFit/>
+          </a:bodyPr>
+          <a:lstStyle/>
+          <a:p>
+            <a:pPr algn="ctr">
+              <a:lnSpc>
+                <a:spcPct val="95000"/>
+              </a:lnSpc>
+            </a:pPr>
+            <a:r>
+              <a:rPr sz="1100" b="1">
+                <a:solidFill>
+                  <a:srgbClr val="FFFFFF"/>
+                </a:solidFill>
+                <a:latin typeface="Calibri"/>
+              </a:rPr>
+              <a:t>cash released</a:t>
+            </a:r>
+          </a:p>
+        </p:txBody>
+      </p:sp>
+      <p:sp>
+        <p:nvSpPr>
+          <p:cNvPr id="41" name="TextBox 40"/>
+          <p:cNvSpPr txBox="1"/>
+          <p:nvPr/>
+        </p:nvSpPr>
+        <p:spPr>
+          <a:xfrm>
+            <a:off x="1051560" y="6053328"/>
+            <a:ext cx="10149840" cy="274320"/>
+          </a:xfrm>
+          <a:prstGeom prst="rect">
+            <a:avLst/>
+          </a:prstGeom>
+          <a:noFill/>
+        </p:spPr>
+        <p:txBody>
+          <a:bodyPr wrap="square" anchor="t" lIns="0" rIns="0" tIns="0" bIns="0">
+            <a:spAutoFit/>
+          </a:bodyPr>
+          <a:lstStyle/>
+          <a:p>
+            <a:pPr algn="l">
+              <a:lnSpc>
+                <a:spcPct val="100000"/>
+              </a:lnSpc>
+            </a:pPr>
+            <a:r>
+              <a:rPr sz="1100" b="0">
+                <a:solidFill>
+                  <a:srgbClr val="9AADC8"/>
+                </a:solidFill>
+                <a:latin typeface="Calibri"/>
+              </a:rPr>
+              <a:t>No committee sign-off  →  no product record  →  no mint  →  no cash. Authority bound end-to-end.</a:t>
+            </a:r>
+          </a:p>
+        </p:txBody>
+      </p:sp>
+    </p:spTree>
+  </p:cSld>
+  <p:clrMapOvr>
+    <a:masterClrMapping/>
+  </p:clrMapOvr>
+</p:sld>
+</file>
+
+<file path=ppt/slides/slide16.xml><?xml version="1.0" encoding="utf-8"?>
 <p:sld xmlns:a="http://schemas.openxmlformats.org/drawingml/2006/main" xmlns:p="http://schemas.openxmlformats.org/presentationml/2006/main" xmlns:r="http://schemas.openxmlformats.org/officeDocument/2006/relationships">
   <p:cSld>
     <p:spTree>

</xml_diff>

<commit_message>
Polish pass: repo navigation, LICENSE, deck geometry fix
- README: TOC with anchor links, deck-download link, at-a-glance flow line
- LICENSE.md: CC-BY-4.0 docs + MPL-2.0 code (matches CMTAT)
- Deck: fix jurisdiction-matrix footer overflowing slide bottom (rh 0.82->0.735)

Co-Authored-By: Claude Opus 4.8 (1M context) <noreply@anthropic.com>
</commit_message>
<xml_diff>
--- a/RCN-CMTAT-FireFly-Gateway.pptx
+++ b/RCN-CMTAT-FireFly-Gateway.pptx
@@ -21037,8 +21037,8 @@
         </p:nvSpPr>
         <p:spPr>
           <a:xfrm>
-            <a:off x="822960" y="1874519"/>
-            <a:ext cx="1737360" cy="749808"/>
+            <a:off x="822960" y="1828800"/>
+            <a:ext cx="1737360" cy="672084"/>
           </a:xfrm>
           <a:prstGeom prst="rect">
             <a:avLst/>
@@ -21081,8 +21081,8 @@
         </p:nvSpPr>
         <p:spPr>
           <a:xfrm>
-            <a:off x="2560320" y="1874519"/>
-            <a:ext cx="1761134" cy="749808"/>
+            <a:off x="2560320" y="1828800"/>
+            <a:ext cx="1761134" cy="672084"/>
           </a:xfrm>
           <a:prstGeom prst="rect">
             <a:avLst/>
@@ -21125,7 +21125,7 @@
         </p:nvSpPr>
         <p:spPr>
           <a:xfrm>
-            <a:off x="2560320" y="2002536"/>
+            <a:off x="2560320" y="1956816"/>
             <a:ext cx="1761134" cy="502920"/>
           </a:xfrm>
           <a:prstGeom prst="rect">
@@ -21164,8 +21164,8 @@
         </p:nvSpPr>
         <p:spPr>
           <a:xfrm>
-            <a:off x="4321454" y="1874519"/>
-            <a:ext cx="1761134" cy="749808"/>
+            <a:off x="4321454" y="1828800"/>
+            <a:ext cx="1761134" cy="672084"/>
           </a:xfrm>
           <a:prstGeom prst="rect">
             <a:avLst/>
@@ -21208,7 +21208,7 @@
         </p:nvSpPr>
         <p:spPr>
           <a:xfrm>
-            <a:off x="4321454" y="2002536"/>
+            <a:off x="4321454" y="1956816"/>
             <a:ext cx="1761134" cy="502920"/>
           </a:xfrm>
           <a:prstGeom prst="rect">
@@ -21247,8 +21247,8 @@
         </p:nvSpPr>
         <p:spPr>
           <a:xfrm>
-            <a:off x="6082588" y="1874519"/>
-            <a:ext cx="1761134" cy="749808"/>
+            <a:off x="6082588" y="1828800"/>
+            <a:ext cx="1761134" cy="672084"/>
           </a:xfrm>
           <a:prstGeom prst="rect">
             <a:avLst/>
@@ -21291,7 +21291,7 @@
         </p:nvSpPr>
         <p:spPr>
           <a:xfrm>
-            <a:off x="6082588" y="2002536"/>
+            <a:off x="6082588" y="1956816"/>
             <a:ext cx="1761134" cy="502920"/>
           </a:xfrm>
           <a:prstGeom prst="rect">
@@ -21330,8 +21330,8 @@
         </p:nvSpPr>
         <p:spPr>
           <a:xfrm>
-            <a:off x="7843723" y="1874519"/>
-            <a:ext cx="1761134" cy="749808"/>
+            <a:off x="7843723" y="1828800"/>
+            <a:ext cx="1761134" cy="672084"/>
           </a:xfrm>
           <a:prstGeom prst="rect">
             <a:avLst/>
@@ -21374,7 +21374,7 @@
         </p:nvSpPr>
         <p:spPr>
           <a:xfrm>
-            <a:off x="7843723" y="2002536"/>
+            <a:off x="7843723" y="1956816"/>
             <a:ext cx="1761134" cy="502920"/>
           </a:xfrm>
           <a:prstGeom prst="rect">
@@ -21413,8 +21413,8 @@
         </p:nvSpPr>
         <p:spPr>
           <a:xfrm>
-            <a:off x="9604857" y="1874519"/>
-            <a:ext cx="1761134" cy="749808"/>
+            <a:off x="9604857" y="1828800"/>
+            <a:ext cx="1761134" cy="672084"/>
           </a:xfrm>
           <a:prstGeom prst="rect">
             <a:avLst/>
@@ -21457,7 +21457,7 @@
         </p:nvSpPr>
         <p:spPr>
           <a:xfrm>
-            <a:off x="9604857" y="2002536"/>
+            <a:off x="9604857" y="1956816"/>
             <a:ext cx="1761134" cy="502920"/>
           </a:xfrm>
           <a:prstGeom prst="rect">
@@ -21496,8 +21496,8 @@
         </p:nvSpPr>
         <p:spPr>
           <a:xfrm>
-            <a:off x="822960" y="2624327"/>
-            <a:ext cx="1737360" cy="749808"/>
+            <a:off x="822960" y="2500884"/>
+            <a:ext cx="1737360" cy="672084"/>
           </a:xfrm>
           <a:prstGeom prst="rect">
             <a:avLst/>
@@ -21540,8 +21540,8 @@
         </p:nvSpPr>
         <p:spPr>
           <a:xfrm>
-            <a:off x="914400" y="2715768"/>
-            <a:ext cx="1554480" cy="566927"/>
+            <a:off x="914400" y="2592324"/>
+            <a:ext cx="1554480" cy="489203"/>
           </a:xfrm>
           <a:prstGeom prst="rect">
             <a:avLst/>
@@ -21579,8 +21579,8 @@
         </p:nvSpPr>
         <p:spPr>
           <a:xfrm>
-            <a:off x="2560320" y="2624327"/>
-            <a:ext cx="1761134" cy="749808"/>
+            <a:off x="2560320" y="2500884"/>
+            <a:ext cx="1761134" cy="672084"/>
           </a:xfrm>
           <a:prstGeom prst="roundRect">
             <a:avLst/>
@@ -21625,8 +21625,8 @@
         </p:nvSpPr>
         <p:spPr>
           <a:xfrm>
-            <a:off x="2615184" y="2697479"/>
-            <a:ext cx="1651406" cy="603503"/>
+            <a:off x="2615184" y="2574036"/>
+            <a:ext cx="1651406" cy="525780"/>
           </a:xfrm>
           <a:prstGeom prst="rect">
             <a:avLst/>
@@ -21664,8 +21664,8 @@
         </p:nvSpPr>
         <p:spPr>
           <a:xfrm>
-            <a:off x="4321454" y="2624327"/>
-            <a:ext cx="1761134" cy="749808"/>
+            <a:off x="4321454" y="2500884"/>
+            <a:ext cx="1761134" cy="672084"/>
           </a:xfrm>
           <a:prstGeom prst="roundRect">
             <a:avLst/>
@@ -21710,8 +21710,8 @@
         </p:nvSpPr>
         <p:spPr>
           <a:xfrm>
-            <a:off x="4376318" y="2697479"/>
-            <a:ext cx="1651406" cy="603503"/>
+            <a:off x="4376318" y="2574036"/>
+            <a:ext cx="1651406" cy="525780"/>
           </a:xfrm>
           <a:prstGeom prst="rect">
             <a:avLst/>
@@ -21749,8 +21749,8 @@
         </p:nvSpPr>
         <p:spPr>
           <a:xfrm>
-            <a:off x="6082588" y="2624327"/>
-            <a:ext cx="1761134" cy="749808"/>
+            <a:off x="6082588" y="2500884"/>
+            <a:ext cx="1761134" cy="672084"/>
           </a:xfrm>
           <a:prstGeom prst="roundRect">
             <a:avLst/>
@@ -21795,8 +21795,8 @@
         </p:nvSpPr>
         <p:spPr>
           <a:xfrm>
-            <a:off x="6137452" y="2697479"/>
-            <a:ext cx="1651406" cy="603503"/>
+            <a:off x="6137452" y="2574036"/>
+            <a:ext cx="1651406" cy="525780"/>
           </a:xfrm>
           <a:prstGeom prst="rect">
             <a:avLst/>
@@ -21834,8 +21834,8 @@
         </p:nvSpPr>
         <p:spPr>
           <a:xfrm>
-            <a:off x="7843723" y="2624327"/>
-            <a:ext cx="1761134" cy="749808"/>
+            <a:off x="7843723" y="2500884"/>
+            <a:ext cx="1761134" cy="672084"/>
           </a:xfrm>
           <a:prstGeom prst="roundRect">
             <a:avLst/>
@@ -21880,8 +21880,8 @@
         </p:nvSpPr>
         <p:spPr>
           <a:xfrm>
-            <a:off x="7898587" y="2697479"/>
-            <a:ext cx="1651406" cy="603503"/>
+            <a:off x="7898587" y="2574036"/>
+            <a:ext cx="1651406" cy="525780"/>
           </a:xfrm>
           <a:prstGeom prst="rect">
             <a:avLst/>
@@ -21919,8 +21919,8 @@
         </p:nvSpPr>
         <p:spPr>
           <a:xfrm>
-            <a:off x="9604857" y="2624327"/>
-            <a:ext cx="1761134" cy="749808"/>
+            <a:off x="9604857" y="2500884"/>
+            <a:ext cx="1761134" cy="672084"/>
           </a:xfrm>
           <a:prstGeom prst="roundRect">
             <a:avLst/>
@@ -21965,8 +21965,8 @@
         </p:nvSpPr>
         <p:spPr>
           <a:xfrm>
-            <a:off x="9659721" y="2697479"/>
-            <a:ext cx="1651406" cy="603503"/>
+            <a:off x="9659721" y="2574036"/>
+            <a:ext cx="1651406" cy="525780"/>
           </a:xfrm>
           <a:prstGeom prst="rect">
             <a:avLst/>
@@ -22004,8 +22004,8 @@
         </p:nvSpPr>
         <p:spPr>
           <a:xfrm>
-            <a:off x="822960" y="3374135"/>
-            <a:ext cx="1737360" cy="749808"/>
+            <a:off x="822960" y="3172968"/>
+            <a:ext cx="1737360" cy="672084"/>
           </a:xfrm>
           <a:prstGeom prst="rect">
             <a:avLst/>
@@ -22048,8 +22048,8 @@
         </p:nvSpPr>
         <p:spPr>
           <a:xfrm>
-            <a:off x="914400" y="3465575"/>
-            <a:ext cx="1554480" cy="566927"/>
+            <a:off x="914400" y="3264408"/>
+            <a:ext cx="1554480" cy="489203"/>
           </a:xfrm>
           <a:prstGeom prst="rect">
             <a:avLst/>
@@ -22087,8 +22087,8 @@
         </p:nvSpPr>
         <p:spPr>
           <a:xfrm>
-            <a:off x="2560320" y="3374135"/>
-            <a:ext cx="1761134" cy="749808"/>
+            <a:off x="2560320" y="3172968"/>
+            <a:ext cx="1761134" cy="672084"/>
           </a:xfrm>
           <a:prstGeom prst="roundRect">
             <a:avLst/>
@@ -22133,8 +22133,8 @@
         </p:nvSpPr>
         <p:spPr>
           <a:xfrm>
-            <a:off x="2615184" y="3447287"/>
-            <a:ext cx="1651406" cy="603503"/>
+            <a:off x="2615184" y="3246120"/>
+            <a:ext cx="1651406" cy="525780"/>
           </a:xfrm>
           <a:prstGeom prst="rect">
             <a:avLst/>
@@ -22172,8 +22172,8 @@
         </p:nvSpPr>
         <p:spPr>
           <a:xfrm>
-            <a:off x="4321454" y="3374135"/>
-            <a:ext cx="1761134" cy="749808"/>
+            <a:off x="4321454" y="3172968"/>
+            <a:ext cx="1761134" cy="672084"/>
           </a:xfrm>
           <a:prstGeom prst="roundRect">
             <a:avLst/>
@@ -22218,8 +22218,8 @@
         </p:nvSpPr>
         <p:spPr>
           <a:xfrm>
-            <a:off x="4376318" y="3447287"/>
-            <a:ext cx="1651406" cy="603503"/>
+            <a:off x="4376318" y="3246120"/>
+            <a:ext cx="1651406" cy="525780"/>
           </a:xfrm>
           <a:prstGeom prst="rect">
             <a:avLst/>
@@ -22257,8 +22257,8 @@
         </p:nvSpPr>
         <p:spPr>
           <a:xfrm>
-            <a:off x="6082588" y="3374135"/>
-            <a:ext cx="1761134" cy="749808"/>
+            <a:off x="6082588" y="3172968"/>
+            <a:ext cx="1761134" cy="672084"/>
           </a:xfrm>
           <a:prstGeom prst="roundRect">
             <a:avLst/>
@@ -22303,8 +22303,8 @@
         </p:nvSpPr>
         <p:spPr>
           <a:xfrm>
-            <a:off x="6137452" y="3447287"/>
-            <a:ext cx="1651406" cy="603503"/>
+            <a:off x="6137452" y="3246120"/>
+            <a:ext cx="1651406" cy="525780"/>
           </a:xfrm>
           <a:prstGeom prst="rect">
             <a:avLst/>
@@ -22342,8 +22342,8 @@
         </p:nvSpPr>
         <p:spPr>
           <a:xfrm>
-            <a:off x="7843723" y="3374135"/>
-            <a:ext cx="1761134" cy="749808"/>
+            <a:off x="7843723" y="3172968"/>
+            <a:ext cx="1761134" cy="672084"/>
           </a:xfrm>
           <a:prstGeom prst="roundRect">
             <a:avLst/>
@@ -22388,8 +22388,8 @@
         </p:nvSpPr>
         <p:spPr>
           <a:xfrm>
-            <a:off x="7898587" y="3447287"/>
-            <a:ext cx="1651406" cy="603503"/>
+            <a:off x="7898587" y="3246120"/>
+            <a:ext cx="1651406" cy="525780"/>
           </a:xfrm>
           <a:prstGeom prst="rect">
             <a:avLst/>
@@ -22427,8 +22427,8 @@
         </p:nvSpPr>
         <p:spPr>
           <a:xfrm>
-            <a:off x="9604857" y="3374135"/>
-            <a:ext cx="1761134" cy="749808"/>
+            <a:off x="9604857" y="3172968"/>
+            <a:ext cx="1761134" cy="672084"/>
           </a:xfrm>
           <a:prstGeom prst="roundRect">
             <a:avLst/>
@@ -22473,8 +22473,8 @@
         </p:nvSpPr>
         <p:spPr>
           <a:xfrm>
-            <a:off x="9659721" y="3447287"/>
-            <a:ext cx="1651406" cy="603503"/>
+            <a:off x="9659721" y="3246120"/>
+            <a:ext cx="1651406" cy="525780"/>
           </a:xfrm>
           <a:prstGeom prst="rect">
             <a:avLst/>
@@ -22512,8 +22512,8 @@
         </p:nvSpPr>
         <p:spPr>
           <a:xfrm>
-            <a:off x="822960" y="4123944"/>
-            <a:ext cx="1737360" cy="749808"/>
+            <a:off x="822960" y="3845052"/>
+            <a:ext cx="1737360" cy="672084"/>
           </a:xfrm>
           <a:prstGeom prst="rect">
             <a:avLst/>
@@ -22556,8 +22556,8 @@
         </p:nvSpPr>
         <p:spPr>
           <a:xfrm>
-            <a:off x="914400" y="4215383"/>
-            <a:ext cx="1554480" cy="566927"/>
+            <a:off x="914400" y="3936491"/>
+            <a:ext cx="1554480" cy="489203"/>
           </a:xfrm>
           <a:prstGeom prst="rect">
             <a:avLst/>
@@ -22595,8 +22595,8 @@
         </p:nvSpPr>
         <p:spPr>
           <a:xfrm>
-            <a:off x="2560320" y="4123944"/>
-            <a:ext cx="1761134" cy="749808"/>
+            <a:off x="2560320" y="3845052"/>
+            <a:ext cx="1761134" cy="672084"/>
           </a:xfrm>
           <a:prstGeom prst="roundRect">
             <a:avLst/>
@@ -22641,8 +22641,8 @@
         </p:nvSpPr>
         <p:spPr>
           <a:xfrm>
-            <a:off x="2615184" y="4197096"/>
-            <a:ext cx="1651406" cy="603503"/>
+            <a:off x="2615184" y="3918204"/>
+            <a:ext cx="1651406" cy="525780"/>
           </a:xfrm>
           <a:prstGeom prst="rect">
             <a:avLst/>
@@ -22680,8 +22680,8 @@
         </p:nvSpPr>
         <p:spPr>
           <a:xfrm>
-            <a:off x="4321454" y="4123944"/>
-            <a:ext cx="1761134" cy="749808"/>
+            <a:off x="4321454" y="3845052"/>
+            <a:ext cx="1761134" cy="672084"/>
           </a:xfrm>
           <a:prstGeom prst="roundRect">
             <a:avLst/>
@@ -22726,8 +22726,8 @@
         </p:nvSpPr>
         <p:spPr>
           <a:xfrm>
-            <a:off x="4376318" y="4197096"/>
-            <a:ext cx="1651406" cy="603503"/>
+            <a:off x="4376318" y="3918204"/>
+            <a:ext cx="1651406" cy="525780"/>
           </a:xfrm>
           <a:prstGeom prst="rect">
             <a:avLst/>
@@ -22765,8 +22765,8 @@
         </p:nvSpPr>
         <p:spPr>
           <a:xfrm>
-            <a:off x="6082588" y="4123944"/>
-            <a:ext cx="1761134" cy="749808"/>
+            <a:off x="6082588" y="3845052"/>
+            <a:ext cx="1761134" cy="672084"/>
           </a:xfrm>
           <a:prstGeom prst="roundRect">
             <a:avLst/>
@@ -22811,8 +22811,8 @@
         </p:nvSpPr>
         <p:spPr>
           <a:xfrm>
-            <a:off x="6137452" y="4197096"/>
-            <a:ext cx="1651406" cy="603503"/>
+            <a:off x="6137452" y="3918204"/>
+            <a:ext cx="1651406" cy="525780"/>
           </a:xfrm>
           <a:prstGeom prst="rect">
             <a:avLst/>
@@ -22850,8 +22850,8 @@
         </p:nvSpPr>
         <p:spPr>
           <a:xfrm>
-            <a:off x="7843723" y="4123944"/>
-            <a:ext cx="1761134" cy="749808"/>
+            <a:off x="7843723" y="3845052"/>
+            <a:ext cx="1761134" cy="672084"/>
           </a:xfrm>
           <a:prstGeom prst="roundRect">
             <a:avLst/>
@@ -22896,8 +22896,8 @@
         </p:nvSpPr>
         <p:spPr>
           <a:xfrm>
-            <a:off x="7898587" y="4197096"/>
-            <a:ext cx="1651406" cy="603503"/>
+            <a:off x="7898587" y="3918204"/>
+            <a:ext cx="1651406" cy="525780"/>
           </a:xfrm>
           <a:prstGeom prst="rect">
             <a:avLst/>
@@ -22935,8 +22935,8 @@
         </p:nvSpPr>
         <p:spPr>
           <a:xfrm>
-            <a:off x="9604857" y="4123944"/>
-            <a:ext cx="1761134" cy="749808"/>
+            <a:off x="9604857" y="3845052"/>
+            <a:ext cx="1761134" cy="672084"/>
           </a:xfrm>
           <a:prstGeom prst="roundRect">
             <a:avLst/>
@@ -22981,8 +22981,8 @@
         </p:nvSpPr>
         <p:spPr>
           <a:xfrm>
-            <a:off x="9659721" y="4197096"/>
-            <a:ext cx="1651406" cy="603503"/>
+            <a:off x="9659721" y="3918204"/>
+            <a:ext cx="1651406" cy="525780"/>
           </a:xfrm>
           <a:prstGeom prst="rect">
             <a:avLst/>
@@ -23020,8 +23020,8 @@
         </p:nvSpPr>
         <p:spPr>
           <a:xfrm>
-            <a:off x="822960" y="4873752"/>
-            <a:ext cx="1737360" cy="749808"/>
+            <a:off x="822960" y="4517136"/>
+            <a:ext cx="1737360" cy="672084"/>
           </a:xfrm>
           <a:prstGeom prst="rect">
             <a:avLst/>
@@ -23064,8 +23064,8 @@
         </p:nvSpPr>
         <p:spPr>
           <a:xfrm>
-            <a:off x="914400" y="4965192"/>
-            <a:ext cx="1554480" cy="566927"/>
+            <a:off x="914400" y="4608576"/>
+            <a:ext cx="1554480" cy="489203"/>
           </a:xfrm>
           <a:prstGeom prst="rect">
             <a:avLst/>
@@ -23103,8 +23103,8 @@
         </p:nvSpPr>
         <p:spPr>
           <a:xfrm>
-            <a:off x="2560320" y="4873752"/>
-            <a:ext cx="1761134" cy="749808"/>
+            <a:off x="2560320" y="4517136"/>
+            <a:ext cx="1761134" cy="672084"/>
           </a:xfrm>
           <a:prstGeom prst="roundRect">
             <a:avLst/>
@@ -23149,8 +23149,8 @@
         </p:nvSpPr>
         <p:spPr>
           <a:xfrm>
-            <a:off x="2615184" y="4946904"/>
-            <a:ext cx="1651406" cy="603503"/>
+            <a:off x="2615184" y="4590288"/>
+            <a:ext cx="1651406" cy="525780"/>
           </a:xfrm>
           <a:prstGeom prst="rect">
             <a:avLst/>
@@ -23188,8 +23188,8 @@
         </p:nvSpPr>
         <p:spPr>
           <a:xfrm>
-            <a:off x="4321454" y="4873752"/>
-            <a:ext cx="1761134" cy="749808"/>
+            <a:off x="4321454" y="4517136"/>
+            <a:ext cx="1761134" cy="672084"/>
           </a:xfrm>
           <a:prstGeom prst="roundRect">
             <a:avLst/>
@@ -23234,8 +23234,8 @@
         </p:nvSpPr>
         <p:spPr>
           <a:xfrm>
-            <a:off x="4376318" y="4946904"/>
-            <a:ext cx="1651406" cy="603503"/>
+            <a:off x="4376318" y="4590288"/>
+            <a:ext cx="1651406" cy="525780"/>
           </a:xfrm>
           <a:prstGeom prst="rect">
             <a:avLst/>
@@ -23273,8 +23273,8 @@
         </p:nvSpPr>
         <p:spPr>
           <a:xfrm>
-            <a:off x="6082588" y="4873752"/>
-            <a:ext cx="1761134" cy="749808"/>
+            <a:off x="6082588" y="4517136"/>
+            <a:ext cx="1761134" cy="672084"/>
           </a:xfrm>
           <a:prstGeom prst="roundRect">
             <a:avLst/>
@@ -23319,8 +23319,8 @@
         </p:nvSpPr>
         <p:spPr>
           <a:xfrm>
-            <a:off x="6137452" y="4946904"/>
-            <a:ext cx="1651406" cy="603503"/>
+            <a:off x="6137452" y="4590288"/>
+            <a:ext cx="1651406" cy="525780"/>
           </a:xfrm>
           <a:prstGeom prst="rect">
             <a:avLst/>
@@ -23358,8 +23358,8 @@
         </p:nvSpPr>
         <p:spPr>
           <a:xfrm>
-            <a:off x="7843723" y="4873752"/>
-            <a:ext cx="1761134" cy="749808"/>
+            <a:off x="7843723" y="4517136"/>
+            <a:ext cx="1761134" cy="672084"/>
           </a:xfrm>
           <a:prstGeom prst="roundRect">
             <a:avLst/>
@@ -23404,8 +23404,8 @@
         </p:nvSpPr>
         <p:spPr>
           <a:xfrm>
-            <a:off x="7898587" y="4946904"/>
-            <a:ext cx="1651406" cy="603503"/>
+            <a:off x="7898587" y="4590288"/>
+            <a:ext cx="1651406" cy="525780"/>
           </a:xfrm>
           <a:prstGeom prst="rect">
             <a:avLst/>
@@ -23443,8 +23443,8 @@
         </p:nvSpPr>
         <p:spPr>
           <a:xfrm>
-            <a:off x="9604857" y="4873752"/>
-            <a:ext cx="1761134" cy="749808"/>
+            <a:off x="9604857" y="4517136"/>
+            <a:ext cx="1761134" cy="672084"/>
           </a:xfrm>
           <a:prstGeom prst="roundRect">
             <a:avLst/>
@@ -23489,8 +23489,8 @@
         </p:nvSpPr>
         <p:spPr>
           <a:xfrm>
-            <a:off x="9659721" y="4946904"/>
-            <a:ext cx="1651406" cy="603503"/>
+            <a:off x="9659721" y="4590288"/>
+            <a:ext cx="1651406" cy="525780"/>
           </a:xfrm>
           <a:prstGeom prst="rect">
             <a:avLst/>
@@ -23528,8 +23528,8 @@
         </p:nvSpPr>
         <p:spPr>
           <a:xfrm>
-            <a:off x="822960" y="5623560"/>
-            <a:ext cx="1737360" cy="749808"/>
+            <a:off x="822960" y="5189220"/>
+            <a:ext cx="1737360" cy="672084"/>
           </a:xfrm>
           <a:prstGeom prst="rect">
             <a:avLst/>
@@ -23572,8 +23572,8 @@
         </p:nvSpPr>
         <p:spPr>
           <a:xfrm>
-            <a:off x="914400" y="5715000"/>
-            <a:ext cx="1554480" cy="566927"/>
+            <a:off x="914400" y="5280660"/>
+            <a:ext cx="1554480" cy="489203"/>
           </a:xfrm>
           <a:prstGeom prst="rect">
             <a:avLst/>
@@ -23611,8 +23611,8 @@
         </p:nvSpPr>
         <p:spPr>
           <a:xfrm>
-            <a:off x="2560320" y="5623560"/>
-            <a:ext cx="1761134" cy="749808"/>
+            <a:off x="2560320" y="5189220"/>
+            <a:ext cx="1761134" cy="672084"/>
           </a:xfrm>
           <a:prstGeom prst="roundRect">
             <a:avLst/>
@@ -23657,8 +23657,8 @@
         </p:nvSpPr>
         <p:spPr>
           <a:xfrm>
-            <a:off x="2615184" y="5696712"/>
-            <a:ext cx="1651406" cy="603503"/>
+            <a:off x="2615184" y="5262372"/>
+            <a:ext cx="1651406" cy="525780"/>
           </a:xfrm>
           <a:prstGeom prst="rect">
             <a:avLst/>
@@ -23696,8 +23696,8 @@
         </p:nvSpPr>
         <p:spPr>
           <a:xfrm>
-            <a:off x="4321454" y="5623560"/>
-            <a:ext cx="1761134" cy="749808"/>
+            <a:off x="4321454" y="5189220"/>
+            <a:ext cx="1761134" cy="672084"/>
           </a:xfrm>
           <a:prstGeom prst="roundRect">
             <a:avLst/>
@@ -23742,8 +23742,8 @@
         </p:nvSpPr>
         <p:spPr>
           <a:xfrm>
-            <a:off x="4376318" y="5696712"/>
-            <a:ext cx="1651406" cy="603503"/>
+            <a:off x="4376318" y="5262372"/>
+            <a:ext cx="1651406" cy="525780"/>
           </a:xfrm>
           <a:prstGeom prst="rect">
             <a:avLst/>
@@ -23781,8 +23781,8 @@
         </p:nvSpPr>
         <p:spPr>
           <a:xfrm>
-            <a:off x="6082588" y="5623560"/>
-            <a:ext cx="1761134" cy="749808"/>
+            <a:off x="6082588" y="5189220"/>
+            <a:ext cx="1761134" cy="672084"/>
           </a:xfrm>
           <a:prstGeom prst="roundRect">
             <a:avLst/>
@@ -23827,8 +23827,8 @@
         </p:nvSpPr>
         <p:spPr>
           <a:xfrm>
-            <a:off x="6137452" y="5696712"/>
-            <a:ext cx="1651406" cy="603503"/>
+            <a:off x="6137452" y="5262372"/>
+            <a:ext cx="1651406" cy="525780"/>
           </a:xfrm>
           <a:prstGeom prst="rect">
             <a:avLst/>
@@ -23866,8 +23866,8 @@
         </p:nvSpPr>
         <p:spPr>
           <a:xfrm>
-            <a:off x="7843723" y="5623560"/>
-            <a:ext cx="1761134" cy="749808"/>
+            <a:off x="7843723" y="5189220"/>
+            <a:ext cx="1761134" cy="672084"/>
           </a:xfrm>
           <a:prstGeom prst="roundRect">
             <a:avLst/>
@@ -23912,8 +23912,8 @@
         </p:nvSpPr>
         <p:spPr>
           <a:xfrm>
-            <a:off x="7898587" y="5696712"/>
-            <a:ext cx="1651406" cy="603503"/>
+            <a:off x="7898587" y="5262372"/>
+            <a:ext cx="1651406" cy="525780"/>
           </a:xfrm>
           <a:prstGeom prst="rect">
             <a:avLst/>
@@ -23951,8 +23951,8 @@
         </p:nvSpPr>
         <p:spPr>
           <a:xfrm>
-            <a:off x="9604857" y="5623560"/>
-            <a:ext cx="1761134" cy="749808"/>
+            <a:off x="9604857" y="5189220"/>
+            <a:ext cx="1761134" cy="672084"/>
           </a:xfrm>
           <a:prstGeom prst="roundRect">
             <a:avLst/>
@@ -23997,8 +23997,8 @@
         </p:nvSpPr>
         <p:spPr>
           <a:xfrm>
-            <a:off x="9659721" y="5696712"/>
-            <a:ext cx="1651406" cy="603503"/>
+            <a:off x="9659721" y="5262372"/>
+            <a:ext cx="1651406" cy="525780"/>
           </a:xfrm>
           <a:prstGeom prst="rect">
             <a:avLst/>
@@ -24036,7 +24036,7 @@
         </p:nvSpPr>
         <p:spPr>
           <a:xfrm>
-            <a:off x="822960" y="6483096"/>
+            <a:off x="822960" y="5971032"/>
             <a:ext cx="10515600" cy="457200"/>
           </a:xfrm>
           <a:prstGeom prst="rect">

</xml_diff>

<commit_message>
Deck: add speaker notes to all 16 slides; repo topics
Co-Authored-By: Claude Opus 4.8 (1M context) <noreply@anthropic.com>
</commit_message>
<xml_diff>
--- a/RCN-CMTAT-FireFly-Gateway.pptx
+++ b/RCN-CMTAT-FireFly-Gateway.pptx
@@ -120,6 +120,1476 @@
     </a:lvl9pPr>
   </p:defaultTextStyle>
 </p:presentation>
+</file>
+
+<file path=ppt/notesMasters/notesMaster1.xml><?xml version="1.0" encoding="utf-8"?>
+<p:notesMaster xmlns:a="http://schemas.openxmlformats.org/drawingml/2006/main" xmlns:p="http://schemas.openxmlformats.org/presentationml/2006/main" xmlns:r="http://schemas.openxmlformats.org/officeDocument/2006/relationships">
+  <p:cSld>
+    <p:bg>
+      <p:bgRef idx="1001">
+        <a:schemeClr val="bg1"/>
+      </p:bgRef>
+    </p:bg>
+    <p:spTree>
+      <p:nvGrpSpPr>
+        <p:cNvPr id="1" name=""/>
+        <p:cNvGrpSpPr/>
+        <p:nvPr/>
+      </p:nvGrpSpPr>
+      <p:grpSpPr>
+        <a:xfrm>
+          <a:off x="0" y="0"/>
+          <a:ext cx="0" cy="0"/>
+          <a:chOff x="0" y="0"/>
+          <a:chExt cx="0" cy="0"/>
+        </a:xfrm>
+      </p:grpSpPr>
+      <p:sp>
+        <p:nvSpPr>
+          <p:cNvPr id="2" name="Header Placeholder 1"/>
+          <p:cNvSpPr>
+            <a:spLocks noGrp="1"/>
+          </p:cNvSpPr>
+          <p:nvPr>
+            <p:ph type="hdr" sz="quarter"/>
+          </p:nvPr>
+        </p:nvSpPr>
+        <p:spPr>
+          <a:xfrm>
+            <a:off x="0" y="0"/>
+            <a:ext cx="2971800" cy="457200"/>
+          </a:xfrm>
+          <a:prstGeom prst="rect">
+            <a:avLst/>
+          </a:prstGeom>
+        </p:spPr>
+        <p:txBody>
+          <a:bodyPr vert="horz" lIns="91440" tIns="45720" rIns="91440" bIns="45720" rtlCol="0"/>
+          <a:lstStyle>
+            <a:lvl1pPr algn="l">
+              <a:defRPr sz="1200"/>
+            </a:lvl1pPr>
+          </a:lstStyle>
+          <a:p>
+            <a:endParaRPr lang="en-US"/>
+          </a:p>
+        </p:txBody>
+      </p:sp>
+      <p:sp>
+        <p:nvSpPr>
+          <p:cNvPr id="3" name="Date Placeholder 2"/>
+          <p:cNvSpPr>
+            <a:spLocks noGrp="1"/>
+          </p:cNvSpPr>
+          <p:nvPr>
+            <p:ph type="dt" idx="1"/>
+          </p:nvPr>
+        </p:nvSpPr>
+        <p:spPr>
+          <a:xfrm>
+            <a:off x="3884613" y="0"/>
+            <a:ext cx="2971800" cy="457200"/>
+          </a:xfrm>
+          <a:prstGeom prst="rect">
+            <a:avLst/>
+          </a:prstGeom>
+        </p:spPr>
+        <p:txBody>
+          <a:bodyPr vert="horz" lIns="91440" tIns="45720" rIns="91440" bIns="45720" rtlCol="0"/>
+          <a:lstStyle>
+            <a:lvl1pPr algn="r">
+              <a:defRPr sz="1200"/>
+            </a:lvl1pPr>
+          </a:lstStyle>
+          <a:p>
+            <a:fld id="{0F89C1C7-3DCD-1040-A9CF-14679D8B5DDD}" type="datetimeFigureOut">
+              <a:rPr lang="en-US" smtClean="0"/>
+              <a:t>10/17/16</a:t>
+            </a:fld>
+            <a:endParaRPr lang="en-US"/>
+          </a:p>
+        </p:txBody>
+      </p:sp>
+      <p:sp>
+        <p:nvSpPr>
+          <p:cNvPr id="4" name="Slide Image Placeholder 3"/>
+          <p:cNvSpPr>
+            <a:spLocks noGrp="1" noRot="1" noChangeAspect="1"/>
+          </p:cNvSpPr>
+          <p:nvPr>
+            <p:ph type="sldImg" idx="2"/>
+          </p:nvPr>
+        </p:nvSpPr>
+        <p:spPr>
+          <a:xfrm>
+            <a:off x="1143000" y="685800"/>
+            <a:ext cx="4572000" cy="3429000"/>
+          </a:xfrm>
+          <a:prstGeom prst="rect">
+            <a:avLst/>
+          </a:prstGeom>
+          <a:noFill/>
+          <a:ln w="12700">
+            <a:solidFill>
+              <a:prstClr val="black"/>
+            </a:solidFill>
+          </a:ln>
+        </p:spPr>
+        <p:txBody>
+          <a:bodyPr vert="horz" lIns="91440" tIns="45720" rIns="91440" bIns="45720" rtlCol="0" anchor="ctr"/>
+          <a:lstStyle/>
+          <a:p>
+            <a:endParaRPr lang="en-US"/>
+          </a:p>
+        </p:txBody>
+      </p:sp>
+      <p:sp>
+        <p:nvSpPr>
+          <p:cNvPr id="5" name="Notes Placeholder 4"/>
+          <p:cNvSpPr>
+            <a:spLocks noGrp="1"/>
+          </p:cNvSpPr>
+          <p:nvPr>
+            <p:ph type="body" sz="quarter" idx="3"/>
+          </p:nvPr>
+        </p:nvSpPr>
+        <p:spPr>
+          <a:xfrm>
+            <a:off x="685800" y="4343400"/>
+            <a:ext cx="5486400" cy="4114800"/>
+          </a:xfrm>
+          <a:prstGeom prst="rect">
+            <a:avLst/>
+          </a:prstGeom>
+        </p:spPr>
+        <p:txBody>
+          <a:bodyPr vert="horz" lIns="91440" tIns="45720" rIns="91440" bIns="45720" rtlCol="0"/>
+          <a:lstStyle/>
+          <a:p>
+            <a:pPr lvl="0"/>
+            <a:r>
+              <a:rPr lang="en-US" smtClean="0"/>
+              <a:t>Click to edit Master text styles</a:t>
+            </a:r>
+          </a:p>
+          <a:p>
+            <a:pPr lvl="1"/>
+            <a:r>
+              <a:rPr lang="en-US" smtClean="0"/>
+              <a:t>Second level</a:t>
+            </a:r>
+          </a:p>
+          <a:p>
+            <a:pPr lvl="2"/>
+            <a:r>
+              <a:rPr lang="en-US" smtClean="0"/>
+              <a:t>Third level</a:t>
+            </a:r>
+          </a:p>
+          <a:p>
+            <a:pPr lvl="3"/>
+            <a:r>
+              <a:rPr lang="en-US" smtClean="0"/>
+              <a:t>Fourth level</a:t>
+            </a:r>
+          </a:p>
+          <a:p>
+            <a:pPr lvl="4"/>
+            <a:r>
+              <a:rPr lang="en-US" smtClean="0"/>
+              <a:t>Fifth level</a:t>
+            </a:r>
+            <a:endParaRPr lang="en-US"/>
+          </a:p>
+        </p:txBody>
+      </p:sp>
+      <p:sp>
+        <p:nvSpPr>
+          <p:cNvPr id="6" name="Footer Placeholder 5"/>
+          <p:cNvSpPr>
+            <a:spLocks noGrp="1"/>
+          </p:cNvSpPr>
+          <p:nvPr>
+            <p:ph type="ftr" sz="quarter" idx="4"/>
+          </p:nvPr>
+        </p:nvSpPr>
+        <p:spPr>
+          <a:xfrm>
+            <a:off x="0" y="8685213"/>
+            <a:ext cx="2971800" cy="457200"/>
+          </a:xfrm>
+          <a:prstGeom prst="rect">
+            <a:avLst/>
+          </a:prstGeom>
+        </p:spPr>
+        <p:txBody>
+          <a:bodyPr vert="horz" lIns="91440" tIns="45720" rIns="91440" bIns="45720" rtlCol="0" anchor="b"/>
+          <a:lstStyle>
+            <a:lvl1pPr algn="l">
+              <a:defRPr sz="1200"/>
+            </a:lvl1pPr>
+          </a:lstStyle>
+          <a:p>
+            <a:endParaRPr lang="en-US"/>
+          </a:p>
+        </p:txBody>
+      </p:sp>
+      <p:sp>
+        <p:nvSpPr>
+          <p:cNvPr id="7" name="Slide Number Placeholder 6"/>
+          <p:cNvSpPr>
+            <a:spLocks noGrp="1"/>
+          </p:cNvSpPr>
+          <p:nvPr>
+            <p:ph type="sldNum" sz="quarter" idx="5"/>
+          </p:nvPr>
+        </p:nvSpPr>
+        <p:spPr>
+          <a:xfrm>
+            <a:off x="3884613" y="8685213"/>
+            <a:ext cx="2971800" cy="457200"/>
+          </a:xfrm>
+          <a:prstGeom prst="rect">
+            <a:avLst/>
+          </a:prstGeom>
+        </p:spPr>
+        <p:txBody>
+          <a:bodyPr vert="horz" lIns="91440" tIns="45720" rIns="91440" bIns="45720" rtlCol="0" anchor="b"/>
+          <a:lstStyle>
+            <a:lvl1pPr algn="r">
+              <a:defRPr sz="1200"/>
+            </a:lvl1pPr>
+          </a:lstStyle>
+          <a:p>
+            <a:fld id="{BB5E49A5-4136-284D-997B-48E1D791AD67}" type="slidenum">
+              <a:rPr lang="en-US" smtClean="0"/>
+              <a:t>‹#›</a:t>
+            </a:fld>
+            <a:endParaRPr lang="en-US"/>
+          </a:p>
+        </p:txBody>
+      </p:sp>
+    </p:spTree>
+    <p:extLst>
+      <p:ext uri="{BB962C8B-B14F-4D97-AF65-F5344CB8AC3E}">
+        <p14:creationId xmlns:p14="http://schemas.microsoft.com/office/powerpoint/2010/main" val="2623252185"/>
+      </p:ext>
+    </p:extLst>
+  </p:cSld>
+  <p:clrMap bg1="lt1" tx1="dk1" bg2="lt2" tx2="dk2" accent1="accent1" accent2="accent2" accent3="accent3" accent4="accent4" accent5="accent5" accent6="accent6" hlink="hlink" folHlink="folHlink"/>
+  <p:notesStyle>
+    <a:lvl1pPr marL="0" algn="l" defTabSz="457200" rtl="0" eaLnBrk="1" latinLnBrk="0" hangingPunct="1">
+      <a:defRPr sz="1200" kern="1200">
+        <a:solidFill>
+          <a:schemeClr val="tx1"/>
+        </a:solidFill>
+        <a:latin typeface="+mn-lt"/>
+        <a:ea typeface="+mn-ea"/>
+        <a:cs typeface="+mn-cs"/>
+      </a:defRPr>
+    </a:lvl1pPr>
+    <a:lvl2pPr marL="457200" algn="l" defTabSz="457200" rtl="0" eaLnBrk="1" latinLnBrk="0" hangingPunct="1">
+      <a:defRPr sz="1200" kern="1200">
+        <a:solidFill>
+          <a:schemeClr val="tx1"/>
+        </a:solidFill>
+        <a:latin typeface="+mn-lt"/>
+        <a:ea typeface="+mn-ea"/>
+        <a:cs typeface="+mn-cs"/>
+      </a:defRPr>
+    </a:lvl2pPr>
+    <a:lvl3pPr marL="914400" algn="l" defTabSz="457200" rtl="0" eaLnBrk="1" latinLnBrk="0" hangingPunct="1">
+      <a:defRPr sz="1200" kern="1200">
+        <a:solidFill>
+          <a:schemeClr val="tx1"/>
+        </a:solidFill>
+        <a:latin typeface="+mn-lt"/>
+        <a:ea typeface="+mn-ea"/>
+        <a:cs typeface="+mn-cs"/>
+      </a:defRPr>
+    </a:lvl3pPr>
+    <a:lvl4pPr marL="1371600" algn="l" defTabSz="457200" rtl="0" eaLnBrk="1" latinLnBrk="0" hangingPunct="1">
+      <a:defRPr sz="1200" kern="1200">
+        <a:solidFill>
+          <a:schemeClr val="tx1"/>
+        </a:solidFill>
+        <a:latin typeface="+mn-lt"/>
+        <a:ea typeface="+mn-ea"/>
+        <a:cs typeface="+mn-cs"/>
+      </a:defRPr>
+    </a:lvl4pPr>
+    <a:lvl5pPr marL="1828800" algn="l" defTabSz="457200" rtl="0" eaLnBrk="1" latinLnBrk="0" hangingPunct="1">
+      <a:defRPr sz="1200" kern="1200">
+        <a:solidFill>
+          <a:schemeClr val="tx1"/>
+        </a:solidFill>
+        <a:latin typeface="+mn-lt"/>
+        <a:ea typeface="+mn-ea"/>
+        <a:cs typeface="+mn-cs"/>
+      </a:defRPr>
+    </a:lvl5pPr>
+    <a:lvl6pPr marL="2286000" algn="l" defTabSz="457200" rtl="0" eaLnBrk="1" latinLnBrk="0" hangingPunct="1">
+      <a:defRPr sz="1200" kern="1200">
+        <a:solidFill>
+          <a:schemeClr val="tx1"/>
+        </a:solidFill>
+        <a:latin typeface="+mn-lt"/>
+        <a:ea typeface="+mn-ea"/>
+        <a:cs typeface="+mn-cs"/>
+      </a:defRPr>
+    </a:lvl6pPr>
+    <a:lvl7pPr marL="2743200" algn="l" defTabSz="457200" rtl="0" eaLnBrk="1" latinLnBrk="0" hangingPunct="1">
+      <a:defRPr sz="1200" kern="1200">
+        <a:solidFill>
+          <a:schemeClr val="tx1"/>
+        </a:solidFill>
+        <a:latin typeface="+mn-lt"/>
+        <a:ea typeface="+mn-ea"/>
+        <a:cs typeface="+mn-cs"/>
+      </a:defRPr>
+    </a:lvl7pPr>
+    <a:lvl8pPr marL="3200400" algn="l" defTabSz="457200" rtl="0" eaLnBrk="1" latinLnBrk="0" hangingPunct="1">
+      <a:defRPr sz="1200" kern="1200">
+        <a:solidFill>
+          <a:schemeClr val="tx1"/>
+        </a:solidFill>
+        <a:latin typeface="+mn-lt"/>
+        <a:ea typeface="+mn-ea"/>
+        <a:cs typeface="+mn-cs"/>
+      </a:defRPr>
+    </a:lvl8pPr>
+    <a:lvl9pPr marL="3657600" algn="l" defTabSz="457200" rtl="0" eaLnBrk="1" latinLnBrk="0" hangingPunct="1">
+      <a:defRPr sz="1200" kern="1200">
+        <a:solidFill>
+          <a:schemeClr val="tx1"/>
+        </a:solidFill>
+        <a:latin typeface="+mn-lt"/>
+        <a:ea typeface="+mn-ea"/>
+        <a:cs typeface="+mn-cs"/>
+      </a:defRPr>
+    </a:lvl9pPr>
+  </p:notesStyle>
+</p:notesMaster>
+</file>
+
+<file path=ppt/notesSlides/notesSlide1.xml><?xml version="1.0" encoding="utf-8"?>
+<p:notes xmlns:a="http://schemas.openxmlformats.org/drawingml/2006/main" xmlns:p="http://schemas.openxmlformats.org/presentationml/2006/main" xmlns:r="http://schemas.openxmlformats.org/officeDocument/2006/relationships">
+  <p:cSld>
+    <p:spTree>
+      <p:nvGrpSpPr>
+        <p:cNvPr id="1" name=""/>
+        <p:cNvGrpSpPr/>
+        <p:nvPr/>
+      </p:nvGrpSpPr>
+      <p:grpSpPr>
+        <a:xfrm>
+          <a:off x="0" y="0"/>
+          <a:ext cx="0" cy="0"/>
+          <a:chOff x="0" y="0"/>
+          <a:chExt cx="0" cy="0"/>
+        </a:xfrm>
+      </p:grpSpPr>
+      <p:sp>
+        <p:nvSpPr>
+          <p:cNvPr id="2" name="Slide Image Placeholder 1"/>
+          <p:cNvSpPr>
+            <a:spLocks noGrp="1"/>
+          </p:cNvSpPr>
+          <p:nvPr>
+            <p:ph type="sldImg" idx="2"/>
+          </p:nvPr>
+        </p:nvSpPr>
+        <p:spPr/>
+      </p:sp>
+      <p:sp>
+        <p:nvSpPr>
+          <p:cNvPr id="3" name="Notes Placeholder 2"/>
+          <p:cNvSpPr>
+            <a:spLocks noGrp="1"/>
+          </p:cNvSpPr>
+          <p:nvPr>
+            <p:ph type="body" idx="3" sz="quarter"/>
+          </p:nvPr>
+        </p:nvSpPr>
+        <p:spPr/>
+        <p:txBody>
+          <a:bodyPr/>
+          <a:lstStyle/>
+          <a:p>
+            <a:r>
+              <a:t>Title. One line: cash flows TradFi to TradFi; the permissioned DLT is a shared messaging/coordination layer, not a value rail. FireFly mints CMTAT tokens representing RCNs. Frame the whole talk as fiat-in / coordinate / fiat-out.</a:t>
+            </a:r>
+          </a:p>
+        </p:txBody>
+      </p:sp>
+      <p:sp>
+        <p:nvSpPr>
+          <p:cNvPr id="4" name="Slide Number Placeholder 3"/>
+          <p:cNvSpPr>
+            <a:spLocks noGrp="1"/>
+          </p:cNvSpPr>
+          <p:nvPr>
+            <p:ph type="sldNum" idx="5" sz="quarter"/>
+          </p:nvPr>
+        </p:nvSpPr>
+        <p:spPr/>
+      </p:sp>
+    </p:spTree>
+  </p:cSld>
+  <p:clrMapOvr>
+    <a:masterClrMapping/>
+  </p:clrMapOvr>
+</p:notes>
+</file>
+
+<file path=ppt/notesSlides/notesSlide10.xml><?xml version="1.0" encoding="utf-8"?>
+<p:notes xmlns:a="http://schemas.openxmlformats.org/drawingml/2006/main" xmlns:p="http://schemas.openxmlformats.org/presentationml/2006/main" xmlns:r="http://schemas.openxmlformats.org/officeDocument/2006/relationships">
+  <p:cSld>
+    <p:spTree>
+      <p:nvGrpSpPr>
+        <p:cNvPr id="1" name=""/>
+        <p:cNvGrpSpPr/>
+        <p:nvPr/>
+      </p:nvGrpSpPr>
+      <p:grpSpPr>
+        <a:xfrm>
+          <a:off x="0" y="0"/>
+          <a:ext cx="0" cy="0"/>
+          <a:chOff x="0" y="0"/>
+          <a:chExt cx="0" cy="0"/>
+        </a:xfrm>
+      </p:grpSpPr>
+      <p:sp>
+        <p:nvSpPr>
+          <p:cNvPr id="2" name="Slide Image Placeholder 1"/>
+          <p:cNvSpPr>
+            <a:spLocks noGrp="1"/>
+          </p:cNvSpPr>
+          <p:nvPr>
+            <p:ph type="sldImg" idx="2"/>
+          </p:nvPr>
+        </p:nvSpPr>
+        <p:spPr/>
+      </p:sp>
+      <p:sp>
+        <p:nvSpPr>
+          <p:cNvPr id="3" name="Notes Placeholder 2"/>
+          <p:cNvSpPr>
+            <a:spLocks noGrp="1"/>
+          </p:cNvSpPr>
+          <p:nvPr>
+            <p:ph type="body" idx="3" sz="quarter"/>
+          </p:nvPr>
+        </p:nvSpPr>
+        <p:spPr/>
+        <p:txBody>
+          <a:bodyPr/>
+          <a:lstStyle/>
+          <a:p>
+            <a:r>
+              <a:t>Implementation. Two thin layers. The Solidity token is deliberately minimal - lifecycle is driven by the off-chain FireFly orchestrator holding ISSUER_ROLE. The orchestrator is idempotent on subscriptionId and waits for finality. Business logic stays on upgradeable modules.</a:t>
+            </a:r>
+          </a:p>
+        </p:txBody>
+      </p:sp>
+      <p:sp>
+        <p:nvSpPr>
+          <p:cNvPr id="4" name="Slide Number Placeholder 3"/>
+          <p:cNvSpPr>
+            <a:spLocks noGrp="1"/>
+          </p:cNvSpPr>
+          <p:nvPr>
+            <p:ph type="sldNum" idx="5" sz="quarter"/>
+          </p:nvPr>
+        </p:nvSpPr>
+        <p:spPr/>
+      </p:sp>
+    </p:spTree>
+  </p:cSld>
+  <p:clrMapOvr>
+    <a:masterClrMapping/>
+  </p:clrMapOvr>
+</p:notes>
+</file>
+
+<file path=ppt/notesSlides/notesSlide11.xml><?xml version="1.0" encoding="utf-8"?>
+<p:notes xmlns:a="http://schemas.openxmlformats.org/drawingml/2006/main" xmlns:p="http://schemas.openxmlformats.org/presentationml/2006/main" xmlns:r="http://schemas.openxmlformats.org/officeDocument/2006/relationships">
+  <p:cSld>
+    <p:spTree>
+      <p:nvGrpSpPr>
+        <p:cNvPr id="1" name=""/>
+        <p:cNvGrpSpPr/>
+        <p:nvPr/>
+      </p:nvGrpSpPr>
+      <p:grpSpPr>
+        <a:xfrm>
+          <a:off x="0" y="0"/>
+          <a:ext cx="0" cy="0"/>
+          <a:chOff x="0" y="0"/>
+          <a:chExt cx="0" cy="0"/>
+        </a:xfrm>
+      </p:grpSpPr>
+      <p:sp>
+        <p:nvSpPr>
+          <p:cNvPr id="2" name="Slide Image Placeholder 1"/>
+          <p:cNvSpPr>
+            <a:spLocks noGrp="1"/>
+          </p:cNvSpPr>
+          <p:nvPr>
+            <p:ph type="sldImg" idx="2"/>
+          </p:nvPr>
+        </p:nvSpPr>
+        <p:spPr/>
+      </p:sp>
+      <p:sp>
+        <p:nvSpPr>
+          <p:cNvPr id="3" name="Notes Placeholder 2"/>
+          <p:cNvSpPr>
+            <a:spLocks noGrp="1"/>
+          </p:cNvSpPr>
+          <p:nvPr>
+            <p:ph type="body" idx="3" sz="quarter"/>
+          </p:nvPr>
+        </p:nvSpPr>
+        <p:spPr/>
+        <p:txBody>
+          <a:bodyPr/>
+          <a:lstStyle/>
+          <a:p>
+            <a:r>
+              <a:t>Reliability &amp; threats. Design failure-first: durable streams, idempotency, escrow auto-refund, confirm-on-finality. Threats map to controls: HSM/MPC + multisig for keys, signed multi-source oracle, RuleEngine on every transfer, PII off-chain, jurisdiction enforced on transfer. Invariant: the reconciliation store is the source of truth.</a:t>
+            </a:r>
+          </a:p>
+        </p:txBody>
+      </p:sp>
+      <p:sp>
+        <p:nvSpPr>
+          <p:cNvPr id="4" name="Slide Number Placeholder 3"/>
+          <p:cNvSpPr>
+            <a:spLocks noGrp="1"/>
+          </p:cNvSpPr>
+          <p:nvPr>
+            <p:ph type="sldNum" idx="5" sz="quarter"/>
+          </p:nvPr>
+        </p:nvSpPr>
+        <p:spPr/>
+      </p:sp>
+    </p:spTree>
+  </p:cSld>
+  <p:clrMapOvr>
+    <a:masterClrMapping/>
+  </p:clrMapOvr>
+</p:notes>
+</file>
+
+<file path=ppt/notesSlides/notesSlide12.xml><?xml version="1.0" encoding="utf-8"?>
+<p:notes xmlns:a="http://schemas.openxmlformats.org/drawingml/2006/main" xmlns:p="http://schemas.openxmlformats.org/presentationml/2006/main" xmlns:r="http://schemas.openxmlformats.org/officeDocument/2006/relationships">
+  <p:cSld>
+    <p:spTree>
+      <p:nvGrpSpPr>
+        <p:cNvPr id="1" name=""/>
+        <p:cNvGrpSpPr/>
+        <p:nvPr/>
+      </p:nvGrpSpPr>
+      <p:grpSpPr>
+        <a:xfrm>
+          <a:off x="0" y="0"/>
+          <a:ext cx="0" cy="0"/>
+          <a:chOff x="0" y="0"/>
+          <a:chExt cx="0" cy="0"/>
+        </a:xfrm>
+      </p:grpSpPr>
+      <p:sp>
+        <p:nvSpPr>
+          <p:cNvPr id="2" name="Slide Image Placeholder 1"/>
+          <p:cNvSpPr>
+            <a:spLocks noGrp="1"/>
+          </p:cNvSpPr>
+          <p:nvPr>
+            <p:ph type="sldImg" idx="2"/>
+          </p:nvPr>
+        </p:nvSpPr>
+        <p:spPr/>
+      </p:sp>
+      <p:sp>
+        <p:nvSpPr>
+          <p:cNvPr id="3" name="Notes Placeholder 2"/>
+          <p:cNvSpPr>
+            <a:spLocks noGrp="1"/>
+          </p:cNvSpPr>
+          <p:nvPr>
+            <p:ph type="body" idx="3" sz="quarter"/>
+          </p:nvPr>
+        </p:nvSpPr>
+        <p:spPr/>
+        <p:txBody>
+          <a:bodyPr/>
+          <a:lstStyle/>
+          <a:p>
+            <a:r>
+              <a:t>Fiat-out sequence in detail. Walk the coupon and both redemption branches. Emphasise: burn is the authoritative 'settling' signal and always precedes cash; eventId idempotency makes a crash between burn and payout recoverable.</a:t>
+            </a:r>
+          </a:p>
+        </p:txBody>
+      </p:sp>
+      <p:sp>
+        <p:nvSpPr>
+          <p:cNvPr id="4" name="Slide Number Placeholder 3"/>
+          <p:cNvSpPr>
+            <a:spLocks noGrp="1"/>
+          </p:cNvSpPr>
+          <p:nvPr>
+            <p:ph type="sldNum" idx="5" sz="quarter"/>
+          </p:nvPr>
+        </p:nvSpPr>
+        <p:spPr/>
+      </p:sp>
+    </p:spTree>
+  </p:cSld>
+  <p:clrMapOvr>
+    <a:masterClrMapping/>
+  </p:clrMapOvr>
+</p:notes>
+</file>
+
+<file path=ppt/notesSlides/notesSlide13.xml><?xml version="1.0" encoding="utf-8"?>
+<p:notes xmlns:a="http://schemas.openxmlformats.org/drawingml/2006/main" xmlns:p="http://schemas.openxmlformats.org/presentationml/2006/main" xmlns:r="http://schemas.openxmlformats.org/officeDocument/2006/relationships">
+  <p:cSld>
+    <p:spTree>
+      <p:nvGrpSpPr>
+        <p:cNvPr id="1" name=""/>
+        <p:cNvGrpSpPr/>
+        <p:nvPr/>
+      </p:nvGrpSpPr>
+      <p:grpSpPr>
+        <a:xfrm>
+          <a:off x="0" y="0"/>
+          <a:ext cx="0" cy="0"/>
+          <a:chOff x="0" y="0"/>
+          <a:chExt cx="0" cy="0"/>
+        </a:xfrm>
+      </p:grpSpPr>
+      <p:sp>
+        <p:nvSpPr>
+          <p:cNvPr id="2" name="Slide Image Placeholder 1"/>
+          <p:cNvSpPr>
+            <a:spLocks noGrp="1"/>
+          </p:cNvSpPr>
+          <p:nvPr>
+            <p:ph type="sldImg" idx="2"/>
+          </p:nvPr>
+        </p:nvSpPr>
+        <p:spPr/>
+      </p:sp>
+      <p:sp>
+        <p:nvSpPr>
+          <p:cNvPr id="3" name="Notes Placeholder 2"/>
+          <p:cNvSpPr>
+            <a:spLocks noGrp="1"/>
+          </p:cNvSpPr>
+          <p:nvPr>
+            <p:ph type="body" idx="3" sz="quarter"/>
+          </p:nvPr>
+        </p:nvSpPr>
+        <p:spPr/>
+        <p:txBody>
+          <a:bodyPr/>
+          <a:lstStyle/>
+          <a:p>
+            <a:r>
+              <a:t>Variant-B reconciler. When the register stays at the transfer agent, chain and TA book can drift, so reconcile holder-by-holder plus a supply invariant on every finalized event batch. On divergence: contain (pause) and alarm - never auto-fix legal truth. Optional Merkle-root anchor gives tamper-evident proof with no PII.</a:t>
+            </a:r>
+          </a:p>
+        </p:txBody>
+      </p:sp>
+      <p:sp>
+        <p:nvSpPr>
+          <p:cNvPr id="4" name="Slide Number Placeholder 3"/>
+          <p:cNvSpPr>
+            <a:spLocks noGrp="1"/>
+          </p:cNvSpPr>
+          <p:nvPr>
+            <p:ph type="sldNum" idx="5" sz="quarter"/>
+          </p:nvPr>
+        </p:nvSpPr>
+        <p:spPr/>
+      </p:sp>
+    </p:spTree>
+  </p:cSld>
+  <p:clrMapOvr>
+    <a:masterClrMapping/>
+  </p:clrMapOvr>
+</p:notes>
+</file>
+
+<file path=ppt/notesSlides/notesSlide14.xml><?xml version="1.0" encoding="utf-8"?>
+<p:notes xmlns:a="http://schemas.openxmlformats.org/drawingml/2006/main" xmlns:p="http://schemas.openxmlformats.org/presentationml/2006/main" xmlns:r="http://schemas.openxmlformats.org/officeDocument/2006/relationships">
+  <p:cSld>
+    <p:spTree>
+      <p:nvGrpSpPr>
+        <p:cNvPr id="1" name=""/>
+        <p:cNvGrpSpPr/>
+        <p:nvPr/>
+      </p:nvGrpSpPr>
+      <p:grpSpPr>
+        <a:xfrm>
+          <a:off x="0" y="0"/>
+          <a:ext cx="0" cy="0"/>
+          <a:chOff x="0" y="0"/>
+          <a:chExt cx="0" cy="0"/>
+        </a:xfrm>
+      </p:grpSpPr>
+      <p:sp>
+        <p:nvSpPr>
+          <p:cNvPr id="2" name="Slide Image Placeholder 1"/>
+          <p:cNvSpPr>
+            <a:spLocks noGrp="1"/>
+          </p:cNvSpPr>
+          <p:nvPr>
+            <p:ph type="sldImg" idx="2"/>
+          </p:nvPr>
+        </p:nvSpPr>
+        <p:spPr/>
+      </p:sp>
+      <p:sp>
+        <p:nvSpPr>
+          <p:cNvPr id="3" name="Notes Placeholder 2"/>
+          <p:cNvSpPr>
+            <a:spLocks noGrp="1"/>
+          </p:cNvSpPr>
+          <p:nvPr>
+            <p:ph type="body" idx="3" sz="quarter"/>
+          </p:nvPr>
+        </p:nvSpPr>
+        <p:spPr/>
+        <p:txBody>
+          <a:bodyPr/>
+          <a:lstStyle/>
+          <a:p>
+            <a:r>
+              <a:t>Design fork. Variant A: token IS the register (ledger-based security) - needs DLT securities law, gives on-chain title finality. Variant B: token is only the message, register stays at the transfer agent - deploys anywhere, US in scope. Same code; only the legal wrapper and reconciliation duty change. B is the cross-border default.</a:t>
+            </a:r>
+          </a:p>
+        </p:txBody>
+      </p:sp>
+      <p:sp>
+        <p:nvSpPr>
+          <p:cNvPr id="4" name="Slide Number Placeholder 3"/>
+          <p:cNvSpPr>
+            <a:spLocks noGrp="1"/>
+          </p:cNvSpPr>
+          <p:nvPr>
+            <p:ph type="sldNum" idx="5" sz="quarter"/>
+          </p:nvPr>
+        </p:nvSpPr>
+        <p:spPr/>
+      </p:sp>
+    </p:spTree>
+  </p:cSld>
+  <p:clrMapOvr>
+    <a:masterClrMapping/>
+  </p:clrMapOvr>
+</p:notes>
+</file>
+
+<file path=ppt/notesSlides/notesSlide15.xml><?xml version="1.0" encoding="utf-8"?>
+<p:notes xmlns:a="http://schemas.openxmlformats.org/drawingml/2006/main" xmlns:p="http://schemas.openxmlformats.org/presentationml/2006/main" xmlns:r="http://schemas.openxmlformats.org/officeDocument/2006/relationships">
+  <p:cSld>
+    <p:spTree>
+      <p:nvGrpSpPr>
+        <p:cNvPr id="1" name=""/>
+        <p:cNvGrpSpPr/>
+        <p:nvPr/>
+      </p:nvGrpSpPr>
+      <p:grpSpPr>
+        <a:xfrm>
+          <a:off x="0" y="0"/>
+          <a:ext cx="0" cy="0"/>
+          <a:chOff x="0" y="0"/>
+          <a:chExt cx="0" cy="0"/>
+        </a:xfrm>
+      </p:grpSpPr>
+      <p:sp>
+        <p:nvSpPr>
+          <p:cNvPr id="2" name="Slide Image Placeholder 1"/>
+          <p:cNvSpPr>
+            <a:spLocks noGrp="1"/>
+          </p:cNvSpPr>
+          <p:nvPr>
+            <p:ph type="sldImg" idx="2"/>
+          </p:nvPr>
+        </p:nvSpPr>
+        <p:spPr/>
+      </p:sp>
+      <p:sp>
+        <p:nvSpPr>
+          <p:cNvPr id="3" name="Notes Placeholder 2"/>
+          <p:cNvSpPr>
+            <a:spLocks noGrp="1"/>
+          </p:cNvSpPr>
+          <p:nvPr>
+            <p:ph type="body" idx="3" sz="quarter"/>
+          </p:nvPr>
+        </p:nvSpPr>
+        <p:spPr/>
+        <p:txBody>
+          <a:bodyPr/>
+          <a:lstStyle/>
+          <a:p>
+            <a:r>
+              <a:t>Governance. No ranked decision is unilateral. A standing specialist committee (legal, compliance, risk, payments, DLT) owns the rankings and each product approval. Bound on-chain: committee approval is a mint precondition - no sign-off, no product record, no mint, no cash. Authority is enforced end-to-end, not filed in a drawer.</a:t>
+            </a:r>
+          </a:p>
+        </p:txBody>
+      </p:sp>
+      <p:sp>
+        <p:nvSpPr>
+          <p:cNvPr id="4" name="Slide Number Placeholder 3"/>
+          <p:cNvSpPr>
+            <a:spLocks noGrp="1"/>
+          </p:cNvSpPr>
+          <p:nvPr>
+            <p:ph type="sldNum" idx="5" sz="quarter"/>
+          </p:nvPr>
+        </p:nvSpPr>
+        <p:spPr/>
+      </p:sp>
+    </p:spTree>
+  </p:cSld>
+  <p:clrMapOvr>
+    <a:masterClrMapping/>
+  </p:clrMapOvr>
+</p:notes>
+</file>
+
+<file path=ppt/notesSlides/notesSlide16.xml><?xml version="1.0" encoding="utf-8"?>
+<p:notes xmlns:a="http://schemas.openxmlformats.org/drawingml/2006/main" xmlns:p="http://schemas.openxmlformats.org/presentationml/2006/main" xmlns:r="http://schemas.openxmlformats.org/officeDocument/2006/relationships">
+  <p:cSld>
+    <p:spTree>
+      <p:nvGrpSpPr>
+        <p:cNvPr id="1" name=""/>
+        <p:cNvGrpSpPr/>
+        <p:nvPr/>
+      </p:nvGrpSpPr>
+      <p:grpSpPr>
+        <a:xfrm>
+          <a:off x="0" y="0"/>
+          <a:ext cx="0" cy="0"/>
+          <a:chOff x="0" y="0"/>
+          <a:chExt cx="0" cy="0"/>
+        </a:xfrm>
+      </p:grpSpPr>
+      <p:sp>
+        <p:nvSpPr>
+          <p:cNvPr id="2" name="Slide Image Placeholder 1"/>
+          <p:cNvSpPr>
+            <a:spLocks noGrp="1"/>
+          </p:cNvSpPr>
+          <p:nvPr>
+            <p:ph type="sldImg" idx="2"/>
+          </p:nvPr>
+        </p:nvSpPr>
+        <p:spPr/>
+      </p:sp>
+      <p:sp>
+        <p:nvSpPr>
+          <p:cNvPr id="3" name="Notes Placeholder 2"/>
+          <p:cNvSpPr>
+            <a:spLocks noGrp="1"/>
+          </p:cNvSpPr>
+          <p:nvPr>
+            <p:ph type="body" idx="3" sz="quarter"/>
+          </p:nvPr>
+        </p:nvSpPr>
+        <p:spPr/>
+        <p:txBody>
+          <a:bodyPr/>
+          <a:lstStyle/>
+          <a:p>
+            <a:r>
+              <a:t>Close. Fiat in, fiat out, TradFi both ends. The DLT is a shared message bus; correlation - not value transfer - is the architecture. Everything is illustrative and unaudited; validate with counsel and regulators before production.</a:t>
+            </a:r>
+          </a:p>
+        </p:txBody>
+      </p:sp>
+      <p:sp>
+        <p:nvSpPr>
+          <p:cNvPr id="4" name="Slide Number Placeholder 3"/>
+          <p:cNvSpPr>
+            <a:spLocks noGrp="1"/>
+          </p:cNvSpPr>
+          <p:nvPr>
+            <p:ph type="sldNum" idx="5" sz="quarter"/>
+          </p:nvPr>
+        </p:nvSpPr>
+        <p:spPr/>
+      </p:sp>
+    </p:spTree>
+  </p:cSld>
+  <p:clrMapOvr>
+    <a:masterClrMapping/>
+  </p:clrMapOvr>
+</p:notes>
+</file>
+
+<file path=ppt/notesSlides/notesSlide2.xml><?xml version="1.0" encoding="utf-8"?>
+<p:notes xmlns:a="http://schemas.openxmlformats.org/drawingml/2006/main" xmlns:p="http://schemas.openxmlformats.org/presentationml/2006/main" xmlns:r="http://schemas.openxmlformats.org/officeDocument/2006/relationships">
+  <p:cSld>
+    <p:spTree>
+      <p:nvGrpSpPr>
+        <p:cNvPr id="1" name=""/>
+        <p:cNvGrpSpPr/>
+        <p:nvPr/>
+      </p:nvGrpSpPr>
+      <p:grpSpPr>
+        <a:xfrm>
+          <a:off x="0" y="0"/>
+          <a:ext cx="0" cy="0"/>
+          <a:chOff x="0" y="0"/>
+          <a:chExt cx="0" cy="0"/>
+        </a:xfrm>
+      </p:grpSpPr>
+      <p:sp>
+        <p:nvSpPr>
+          <p:cNvPr id="2" name="Slide Image Placeholder 1"/>
+          <p:cNvSpPr>
+            <a:spLocks noGrp="1"/>
+          </p:cNvSpPr>
+          <p:nvPr>
+            <p:ph type="sldImg" idx="2"/>
+          </p:nvPr>
+        </p:nvSpPr>
+        <p:spPr/>
+      </p:sp>
+      <p:sp>
+        <p:nvSpPr>
+          <p:cNvPr id="3" name="Notes Placeholder 2"/>
+          <p:cNvSpPr>
+            <a:spLocks noGrp="1"/>
+          </p:cNvSpPr>
+          <p:nvPr>
+            <p:ph type="body" idx="3" sz="quarter"/>
+          </p:nvPr>
+        </p:nvSpPr>
+        <p:spPr/>
+        <p:txBody>
+          <a:bodyPr/>
+          <a:lstStyle/>
+          <a:p>
+            <a:r>
+              <a:t>The product. An RCN is a structured debt security = zero-coupon note + a short put the investor implicitly sells for an above-market coupon. Barrier OK -&gt; cash par; barrier breached -&gt; physical delivery at a loss. Classification as a security (not e-money) is what drives the entire compliance overlay.</a:t>
+            </a:r>
+          </a:p>
+        </p:txBody>
+      </p:sp>
+      <p:sp>
+        <p:nvSpPr>
+          <p:cNvPr id="4" name="Slide Number Placeholder 3"/>
+          <p:cNvSpPr>
+            <a:spLocks noGrp="1"/>
+          </p:cNvSpPr>
+          <p:nvPr>
+            <p:ph type="sldNum" idx="5" sz="quarter"/>
+          </p:nvPr>
+        </p:nvSpPr>
+        <p:spPr/>
+      </p:sp>
+    </p:spTree>
+  </p:cSld>
+  <p:clrMapOvr>
+    <a:masterClrMapping/>
+  </p:clrMapOvr>
+</p:notes>
+</file>
+
+<file path=ppt/notesSlides/notesSlide3.xml><?xml version="1.0" encoding="utf-8"?>
+<p:notes xmlns:a="http://schemas.openxmlformats.org/drawingml/2006/main" xmlns:p="http://schemas.openxmlformats.org/presentationml/2006/main" xmlns:r="http://schemas.openxmlformats.org/officeDocument/2006/relationships">
+  <p:cSld>
+    <p:spTree>
+      <p:nvGrpSpPr>
+        <p:cNvPr id="1" name=""/>
+        <p:cNvGrpSpPr/>
+        <p:nvPr/>
+      </p:nvGrpSpPr>
+      <p:grpSpPr>
+        <a:xfrm>
+          <a:off x="0" y="0"/>
+          <a:ext cx="0" cy="0"/>
+          <a:chOff x="0" y="0"/>
+          <a:chExt cx="0" cy="0"/>
+        </a:xfrm>
+      </p:grpSpPr>
+      <p:sp>
+        <p:nvSpPr>
+          <p:cNvPr id="2" name="Slide Image Placeholder 1"/>
+          <p:cNvSpPr>
+            <a:spLocks noGrp="1"/>
+          </p:cNvSpPr>
+          <p:nvPr>
+            <p:ph type="sldImg" idx="2"/>
+          </p:nvPr>
+        </p:nvSpPr>
+        <p:spPr/>
+      </p:sp>
+      <p:sp>
+        <p:nvSpPr>
+          <p:cNvPr id="3" name="Notes Placeholder 2"/>
+          <p:cNvSpPr>
+            <a:spLocks noGrp="1"/>
+          </p:cNvSpPr>
+          <p:nvPr>
+            <p:ph type="body" idx="3" sz="quarter"/>
+          </p:nvPr>
+        </p:nvSpPr>
+        <p:spPr/>
+        <p:txBody>
+          <a:bodyPr/>
+          <a:lstStyle/>
+          <a:p>
+            <a:r>
+              <a:t>Building blocks. CMTAT gives audited security-token primitives (mint/burn, pause, freeze, RuleEngine eligibility, snapshot, debt module). FireFly is the orchestration supernode: token+blockchain connectors, durable event streams, off-chain data exchange for PII, idempotent transaction manager. Together: 'cash settled' -&gt; 'note recorded once, everyone notified.'</a:t>
+            </a:r>
+          </a:p>
+        </p:txBody>
+      </p:sp>
+      <p:sp>
+        <p:nvSpPr>
+          <p:cNvPr id="4" name="Slide Number Placeholder 3"/>
+          <p:cNvSpPr>
+            <a:spLocks noGrp="1"/>
+          </p:cNvSpPr>
+          <p:nvPr>
+            <p:ph type="sldNum" idx="5" sz="quarter"/>
+          </p:nvPr>
+        </p:nvSpPr>
+        <p:spPr/>
+      </p:sp>
+    </p:spTree>
+  </p:cSld>
+  <p:clrMapOvr>
+    <a:masterClrMapping/>
+  </p:clrMapOvr>
+</p:notes>
+</file>
+
+<file path=ppt/notesSlides/notesSlide4.xml><?xml version="1.0" encoding="utf-8"?>
+<p:notes xmlns:a="http://schemas.openxmlformats.org/drawingml/2006/main" xmlns:p="http://schemas.openxmlformats.org/presentationml/2006/main" xmlns:r="http://schemas.openxmlformats.org/officeDocument/2006/relationships">
+  <p:cSld>
+    <p:spTree>
+      <p:nvGrpSpPr>
+        <p:cNvPr id="1" name=""/>
+        <p:cNvGrpSpPr/>
+        <p:nvPr/>
+      </p:nvGrpSpPr>
+      <p:grpSpPr>
+        <a:xfrm>
+          <a:off x="0" y="0"/>
+          <a:ext cx="0" cy="0"/>
+          <a:chOff x="0" y="0"/>
+          <a:chExt cx="0" cy="0"/>
+        </a:xfrm>
+      </p:grpSpPr>
+      <p:sp>
+        <p:nvSpPr>
+          <p:cNvPr id="2" name="Slide Image Placeholder 1"/>
+          <p:cNvSpPr>
+            <a:spLocks noGrp="1"/>
+          </p:cNvSpPr>
+          <p:nvPr>
+            <p:ph type="sldImg" idx="2"/>
+          </p:nvPr>
+        </p:nvSpPr>
+        <p:spPr/>
+      </p:sp>
+      <p:sp>
+        <p:nvSpPr>
+          <p:cNvPr id="3" name="Notes Placeholder 2"/>
+          <p:cNvSpPr>
+            <a:spLocks noGrp="1"/>
+          </p:cNvSpPr>
+          <p:nvPr>
+            <p:ph type="body" idx="3" sz="quarter"/>
+          </p:nvPr>
+        </p:nvSpPr>
+        <p:spPr/>
+        <p:txBody>
+          <a:bodyPr/>
+          <a:lstStyle/>
+          <a:p>
+            <a:r>
+              <a:t>Architecture. Three bands: cash stays in TradFi (rail in -&gt; escrow -&gt; rail out); the gateway correlates; the DLT only messages. Bold arrows are coordination signals, dashed arrows are payout instructions back to the bank. Every institution reads the same ledger instead of reconciling private copies.</a:t>
+            </a:r>
+          </a:p>
+        </p:txBody>
+      </p:sp>
+      <p:sp>
+        <p:nvSpPr>
+          <p:cNvPr id="4" name="Slide Number Placeholder 3"/>
+          <p:cNvSpPr>
+            <a:spLocks noGrp="1"/>
+          </p:cNvSpPr>
+          <p:nvPr>
+            <p:ph type="sldNum" idx="5" sz="quarter"/>
+          </p:nvPr>
+        </p:nvSpPr>
+        <p:spPr/>
+      </p:sp>
+    </p:spTree>
+  </p:cSld>
+  <p:clrMapOvr>
+    <a:masterClrMapping/>
+  </p:clrMapOvr>
+</p:notes>
+</file>
+
+<file path=ppt/notesSlides/notesSlide5.xml><?xml version="1.0" encoding="utf-8"?>
+<p:notes xmlns:a="http://schemas.openxmlformats.org/drawingml/2006/main" xmlns:p="http://schemas.openxmlformats.org/presentationml/2006/main" xmlns:r="http://schemas.openxmlformats.org/officeDocument/2006/relationships">
+  <p:cSld>
+    <p:spTree>
+      <p:nvGrpSpPr>
+        <p:cNvPr id="1" name=""/>
+        <p:cNvGrpSpPr/>
+        <p:nvPr/>
+      </p:nvGrpSpPr>
+      <p:grpSpPr>
+        <a:xfrm>
+          <a:off x="0" y="0"/>
+          <a:ext cx="0" cy="0"/>
+          <a:chOff x="0" y="0"/>
+          <a:chExt cx="0" cy="0"/>
+        </a:xfrm>
+      </p:grpSpPr>
+      <p:sp>
+        <p:nvSpPr>
+          <p:cNvPr id="2" name="Slide Image Placeholder 1"/>
+          <p:cNvSpPr>
+            <a:spLocks noGrp="1"/>
+          </p:cNvSpPr>
+          <p:nvPr>
+            <p:ph type="sldImg" idx="2"/>
+          </p:nvPr>
+        </p:nvSpPr>
+        <p:spPr/>
+      </p:sp>
+      <p:sp>
+        <p:nvSpPr>
+          <p:cNvPr id="3" name="Notes Placeholder 2"/>
+          <p:cNvSpPr>
+            <a:spLocks noGrp="1"/>
+          </p:cNvSpPr>
+          <p:nvPr>
+            <p:ph type="body" idx="3" sz="quarter"/>
+          </p:nvPr>
+        </p:nvSpPr>
+        <p:spPr/>
+        <p:txBody>
+          <a:bodyPr/>
+          <a:lstStyle/>
+          <a:p>
+            <a:r>
+              <a:t>The real hard part. There is NO on-chain value leg to make atomic - that's a feature. The problem is correlating an off-chain cash event to an on-chain message exactly once with a safe reversal. Recommended: escrow + message-on-finality, escrow release gated on the mint event. No value on-chain = tiny failure surface.</a:t>
+            </a:r>
+          </a:p>
+        </p:txBody>
+      </p:sp>
+      <p:sp>
+        <p:nvSpPr>
+          <p:cNvPr id="4" name="Slide Number Placeholder 3"/>
+          <p:cNvSpPr>
+            <a:spLocks noGrp="1"/>
+          </p:cNvSpPr>
+          <p:nvPr>
+            <p:ph type="sldNum" idx="5" sz="quarter"/>
+          </p:nvPr>
+        </p:nvSpPr>
+        <p:spPr/>
+      </p:sp>
+    </p:spTree>
+  </p:cSld>
+  <p:clrMapOvr>
+    <a:masterClrMapping/>
+  </p:clrMapOvr>
+</p:notes>
+</file>
+
+<file path=ppt/notesSlides/notesSlide6.xml><?xml version="1.0" encoding="utf-8"?>
+<p:notes xmlns:a="http://schemas.openxmlformats.org/drawingml/2006/main" xmlns:p="http://schemas.openxmlformats.org/presentationml/2006/main" xmlns:r="http://schemas.openxmlformats.org/officeDocument/2006/relationships">
+  <p:cSld>
+    <p:spTree>
+      <p:nvGrpSpPr>
+        <p:cNvPr id="1" name=""/>
+        <p:cNvGrpSpPr/>
+        <p:nvPr/>
+      </p:nvGrpSpPr>
+      <p:grpSpPr>
+        <a:xfrm>
+          <a:off x="0" y="0"/>
+          <a:ext cx="0" cy="0"/>
+          <a:chOff x="0" y="0"/>
+          <a:chExt cx="0" cy="0"/>
+        </a:xfrm>
+      </p:grpSpPr>
+      <p:sp>
+        <p:nvSpPr>
+          <p:cNvPr id="2" name="Slide Image Placeholder 1"/>
+          <p:cNvSpPr>
+            <a:spLocks noGrp="1"/>
+          </p:cNvSpPr>
+          <p:nvPr>
+            <p:ph type="sldImg" idx="2"/>
+          </p:nvPr>
+        </p:nvSpPr>
+        <p:spPr/>
+      </p:sp>
+      <p:sp>
+        <p:nvSpPr>
+          <p:cNvPr id="3" name="Notes Placeholder 2"/>
+          <p:cNvSpPr>
+            <a:spLocks noGrp="1"/>
+          </p:cNvSpPr>
+          <p:nvPr>
+            <p:ph type="body" idx="3" sz="quarter"/>
+          </p:nvPr>
+        </p:nvSpPr>
+        <p:spPr/>
+        <p:txBody>
+          <a:bodyPr/>
+          <a:lstStyle/>
+          <a:p>
+            <a:r>
+              <a:t>Mint sequence. Client pays -&gt; escrow -&gt; pacs.002 finality -&gt; idempotency check -&gt; FireFly mints (operationId = subscriptionId) -&gt; mint event releases escrow to issuer. Re-delivered payment events never double-mint. On reject/timeout the escrow auto-refunds - cash is never trapped.</a:t>
+            </a:r>
+          </a:p>
+        </p:txBody>
+      </p:sp>
+      <p:sp>
+        <p:nvSpPr>
+          <p:cNvPr id="4" name="Slide Number Placeholder 3"/>
+          <p:cNvSpPr>
+            <a:spLocks noGrp="1"/>
+          </p:cNvSpPr>
+          <p:nvPr>
+            <p:ph type="sldNum" idx="5" sz="quarter"/>
+          </p:nvPr>
+        </p:nvSpPr>
+        <p:spPr/>
+      </p:sp>
+    </p:spTree>
+  </p:cSld>
+  <p:clrMapOvr>
+    <a:masterClrMapping/>
+  </p:clrMapOvr>
+</p:notes>
+</file>
+
+<file path=ppt/notesSlides/notesSlide7.xml><?xml version="1.0" encoding="utf-8"?>
+<p:notes xmlns:a="http://schemas.openxmlformats.org/drawingml/2006/main" xmlns:p="http://schemas.openxmlformats.org/presentationml/2006/main" xmlns:r="http://schemas.openxmlformats.org/officeDocument/2006/relationships">
+  <p:cSld>
+    <p:spTree>
+      <p:nvGrpSpPr>
+        <p:cNvPr id="1" name=""/>
+        <p:cNvGrpSpPr/>
+        <p:nvPr/>
+      </p:nvGrpSpPr>
+      <p:grpSpPr>
+        <a:xfrm>
+          <a:off x="0" y="0"/>
+          <a:ext cx="0" cy="0"/>
+          <a:chOff x="0" y="0"/>
+          <a:chExt cx="0" cy="0"/>
+        </a:xfrm>
+      </p:grpSpPr>
+      <p:sp>
+        <p:nvSpPr>
+          <p:cNvPr id="2" name="Slide Image Placeholder 1"/>
+          <p:cNvSpPr>
+            <a:spLocks noGrp="1"/>
+          </p:cNvSpPr>
+          <p:nvPr>
+            <p:ph type="sldImg" idx="2"/>
+          </p:nvPr>
+        </p:nvSpPr>
+        <p:spPr/>
+      </p:sp>
+      <p:sp>
+        <p:nvSpPr>
+          <p:cNvPr id="3" name="Notes Placeholder 2"/>
+          <p:cNvSpPr>
+            <a:spLocks noGrp="1"/>
+          </p:cNvSpPr>
+          <p:nvPr>
+            <p:ph type="body" idx="3" sz="quarter"/>
+          </p:nvPr>
+        </p:nvSpPr>
+        <p:spPr/>
+        <p:txBody>
+          <a:bodyPr/>
+          <a:lstStyle/>
+          <a:p>
+            <a:r>
+              <a:t>Reverse leg. On-chain event is the trigger, cash is the effect, back out on a TradFi rail. Coupon uses the snapshot holder-of-record set; burn precedes payout; physical settlement is burn + off-chain custodian delivery. Keyed on eventId for exactly-once payout.</a:t>
+            </a:r>
+          </a:p>
+        </p:txBody>
+      </p:sp>
+      <p:sp>
+        <p:nvSpPr>
+          <p:cNvPr id="4" name="Slide Number Placeholder 3"/>
+          <p:cNvSpPr>
+            <a:spLocks noGrp="1"/>
+          </p:cNvSpPr>
+          <p:nvPr>
+            <p:ph type="sldNum" idx="5" sz="quarter"/>
+          </p:nvPr>
+        </p:nvSpPr>
+        <p:spPr/>
+      </p:sp>
+    </p:spTree>
+  </p:cSld>
+  <p:clrMapOvr>
+    <a:masterClrMapping/>
+  </p:clrMapOvr>
+</p:notes>
+</file>
+
+<file path=ppt/notesSlides/notesSlide8.xml><?xml version="1.0" encoding="utf-8"?>
+<p:notes xmlns:a="http://schemas.openxmlformats.org/drawingml/2006/main" xmlns:p="http://schemas.openxmlformats.org/presentationml/2006/main" xmlns:r="http://schemas.openxmlformats.org/officeDocument/2006/relationships">
+  <p:cSld>
+    <p:spTree>
+      <p:nvGrpSpPr>
+        <p:cNvPr id="1" name=""/>
+        <p:cNvGrpSpPr/>
+        <p:nvPr/>
+      </p:nvGrpSpPr>
+      <p:grpSpPr>
+        <a:xfrm>
+          <a:off x="0" y="0"/>
+          <a:ext cx="0" cy="0"/>
+          <a:chOff x="0" y="0"/>
+          <a:chExt cx="0" cy="0"/>
+        </a:xfrm>
+      </p:grpSpPr>
+      <p:sp>
+        <p:nvSpPr>
+          <p:cNvPr id="2" name="Slide Image Placeholder 1"/>
+          <p:cNvSpPr>
+            <a:spLocks noGrp="1"/>
+          </p:cNvSpPr>
+          <p:nvPr>
+            <p:ph type="sldImg" idx="2"/>
+          </p:nvPr>
+        </p:nvSpPr>
+        <p:spPr/>
+      </p:sp>
+      <p:sp>
+        <p:nvSpPr>
+          <p:cNvPr id="3" name="Notes Placeholder 2"/>
+          <p:cNvSpPr>
+            <a:spLocks noGrp="1"/>
+          </p:cNvSpPr>
+          <p:nvPr>
+            <p:ph type="body" idx="3" sz="quarter"/>
+          </p:nvPr>
+        </p:nvSpPr>
+        <p:spPr/>
+        <p:txBody>
+          <a:bodyPr/>
+          <a:lstStyle/>
+          <a:p>
+            <a:r>
+              <a:t>Lifecycle. Three ways out of Active: recurring coupon cycle (snapshot -&gt; pay -&gt; back), an involuntary Frozen hold (sanctions/court), and the terminal Exit where a single barrier decision routes to cash redemption vs physical delivery. Autocall enters Exit early.</a:t>
+            </a:r>
+          </a:p>
+        </p:txBody>
+      </p:sp>
+      <p:sp>
+        <p:nvSpPr>
+          <p:cNvPr id="4" name="Slide Number Placeholder 3"/>
+          <p:cNvSpPr>
+            <a:spLocks noGrp="1"/>
+          </p:cNvSpPr>
+          <p:nvPr>
+            <p:ph type="sldNum" idx="5" sz="quarter"/>
+          </p:nvPr>
+        </p:nvSpPr>
+        <p:spPr/>
+      </p:sp>
+    </p:spTree>
+  </p:cSld>
+  <p:clrMapOvr>
+    <a:masterClrMapping/>
+  </p:clrMapOvr>
+</p:notes>
+</file>
+
+<file path=ppt/notesSlides/notesSlide9.xml><?xml version="1.0" encoding="utf-8"?>
+<p:notes xmlns:a="http://schemas.openxmlformats.org/drawingml/2006/main" xmlns:p="http://schemas.openxmlformats.org/presentationml/2006/main" xmlns:r="http://schemas.openxmlformats.org/officeDocument/2006/relationships">
+  <p:cSld>
+    <p:spTree>
+      <p:nvGrpSpPr>
+        <p:cNvPr id="1" name=""/>
+        <p:cNvGrpSpPr/>
+        <p:nvPr/>
+      </p:nvGrpSpPr>
+      <p:grpSpPr>
+        <a:xfrm>
+          <a:off x="0" y="0"/>
+          <a:ext cx="0" cy="0"/>
+          <a:chOff x="0" y="0"/>
+          <a:chExt cx="0" cy="0"/>
+        </a:xfrm>
+      </p:grpSpPr>
+      <p:sp>
+        <p:nvSpPr>
+          <p:cNvPr id="2" name="Slide Image Placeholder 1"/>
+          <p:cNvSpPr>
+            <a:spLocks noGrp="1"/>
+          </p:cNvSpPr>
+          <p:nvPr>
+            <p:ph type="sldImg" idx="2"/>
+          </p:nvPr>
+        </p:nvSpPr>
+        <p:spPr/>
+      </p:sp>
+      <p:sp>
+        <p:nvSpPr>
+          <p:cNvPr id="3" name="Notes Placeholder 2"/>
+          <p:cNvSpPr>
+            <a:spLocks noGrp="1"/>
+          </p:cNvSpPr>
+          <p:nvPr>
+            <p:ph type="body" idx="3" sz="quarter"/>
+          </p:nvPr>
+        </p:nvSpPr>
+        <p:spPr/>
+        <p:txBody>
+          <a:bodyPr/>
+          <a:lstStyle/>
+          <a:p>
+            <a:r>
+              <a:t>Jurisdiction matrix. The token's nature (structured debt security) is stable, but rails, register law, disclosure and marketing rules diverge. All gating lives in the RuleEngine, not the UI: wallet jurisdiction checked on every transfer, Travel-Rule payloads off-chain (IVMS-101), PII as hashes only.</a:t>
+            </a:r>
+          </a:p>
+        </p:txBody>
+      </p:sp>
+      <p:sp>
+        <p:nvSpPr>
+          <p:cNvPr id="4" name="Slide Number Placeholder 3"/>
+          <p:cNvSpPr>
+            <a:spLocks noGrp="1"/>
+          </p:cNvSpPr>
+          <p:nvPr>
+            <p:ph type="sldNum" idx="5" sz="quarter"/>
+          </p:nvPr>
+        </p:nvSpPr>
+        <p:spPr/>
+      </p:sp>
+    </p:spTree>
+  </p:cSld>
+  <p:clrMapOvr>
+    <a:masterClrMapping/>
+  </p:clrMapOvr>
+</p:notes>
 </file>
 
 <file path=ppt/slideLayouts/slideLayout1.xml><?xml version="1.0" encoding="utf-8"?>
@@ -25394,4 +26864,324 @@
   </a:objectDefaults>
   <a:extraClrSchemeLst/>
 </a:theme>
+</file>
+
+<file path=ppt/theme/theme2.xml><?xml version="1.0" encoding="utf-8"?>
+<a:theme xmlns:a="http://schemas.openxmlformats.org/drawingml/2006/main" name="Office Theme">
+  <a:themeElements>
+    <a:clrScheme name="Office">
+      <a:dk1>
+        <a:sysClr val="windowText" lastClr="000000"/>
+      </a:dk1>
+      <a:lt1>
+        <a:sysClr val="window" lastClr="FFFFFF"/>
+      </a:lt1>
+      <a:dk2>
+        <a:srgbClr val="1F497D"/>
+      </a:dk2>
+      <a:lt2>
+        <a:srgbClr val="EEECE1"/>
+      </a:lt2>
+      <a:accent1>
+        <a:srgbClr val="4F81BD"/>
+      </a:accent1>
+      <a:accent2>
+        <a:srgbClr val="C0504D"/>
+      </a:accent2>
+      <a:accent3>
+        <a:srgbClr val="9BBB59"/>
+      </a:accent3>
+      <a:accent4>
+        <a:srgbClr val="8064A2"/>
+      </a:accent4>
+      <a:accent5>
+        <a:srgbClr val="4BACC6"/>
+      </a:accent5>
+      <a:accent6>
+        <a:srgbClr val="F79646"/>
+      </a:accent6>
+      <a:hlink>
+        <a:srgbClr val="0000FF"/>
+      </a:hlink>
+      <a:folHlink>
+        <a:srgbClr val="800080"/>
+      </a:folHlink>
+    </a:clrScheme>
+    <a:fontScheme name="Office">
+      <a:majorFont>
+        <a:latin typeface="Calibri"/>
+        <a:ea typeface=""/>
+        <a:cs typeface=""/>
+        <a:font script="Jpan" typeface="ＭＳ Ｐゴシック"/>
+        <a:font script="Hang" typeface="맑은 고딕"/>
+        <a:font script="Hans" typeface="宋体"/>
+        <a:font script="Hant" typeface="新細明體"/>
+        <a:font script="Arab" typeface="Times New Roman"/>
+        <a:font script="Hebr" typeface="Times New Roman"/>
+        <a:font script="Thai" typeface="Angsana New"/>
+        <a:font script="Ethi" typeface="Nyala"/>
+        <a:font script="Beng" typeface="Vrinda"/>
+        <a:font script="Gujr" typeface="Shruti"/>
+        <a:font script="Khmr" typeface="MoolBoran"/>
+        <a:font script="Knda" typeface="Tunga"/>
+        <a:font script="Guru" typeface="Raavi"/>
+        <a:font script="Cans" typeface="Euphemia"/>
+        <a:font script="Cher" typeface="Plantagenet Cherokee"/>
+        <a:font script="Yiii" typeface="Microsoft Yi Baiti"/>
+        <a:font script="Tibt" typeface="Microsoft Himalaya"/>
+        <a:font script="Thaa" typeface="MV Boli"/>
+        <a:font script="Deva" typeface="Mangal"/>
+        <a:font script="Telu" typeface="Gautami"/>
+        <a:font script="Taml" typeface="Latha"/>
+        <a:font script="Syrc" typeface="Estrangelo Edessa"/>
+        <a:font script="Orya" typeface="Kalinga"/>
+        <a:font script="Mlym" typeface="Kartika"/>
+        <a:font script="Laoo" typeface="DokChampa"/>
+        <a:font script="Sinh" typeface="Iskoola Pota"/>
+        <a:font script="Mong" typeface="Mongolian Baiti"/>
+        <a:font script="Viet" typeface="Times New Roman"/>
+        <a:font script="Uigh" typeface="Microsoft Uighur"/>
+        <a:font script="Geor" typeface="Sylfaen"/>
+      </a:majorFont>
+      <a:minorFont>
+        <a:latin typeface="Calibri"/>
+        <a:ea typeface=""/>
+        <a:cs typeface=""/>
+        <a:font script="Jpan" typeface="ＭＳ Ｐゴシック"/>
+        <a:font script="Hang" typeface="맑은 고딕"/>
+        <a:font script="Hans" typeface="宋体"/>
+        <a:font script="Hant" typeface="新細明體"/>
+        <a:font script="Arab" typeface="Arial"/>
+        <a:font script="Hebr" typeface="Arial"/>
+        <a:font script="Thai" typeface="Cordia New"/>
+        <a:font script="Ethi" typeface="Nyala"/>
+        <a:font script="Beng" typeface="Vrinda"/>
+        <a:font script="Gujr" typeface="Shruti"/>
+        <a:font script="Khmr" typeface="DaunPenh"/>
+        <a:font script="Knda" typeface="Tunga"/>
+        <a:font script="Guru" typeface="Raavi"/>
+        <a:font script="Cans" typeface="Euphemia"/>
+        <a:font script="Cher" typeface="Plantagenet Cherokee"/>
+        <a:font script="Yiii" typeface="Microsoft Yi Baiti"/>
+        <a:font script="Tibt" typeface="Microsoft Himalaya"/>
+        <a:font script="Thaa" typeface="MV Boli"/>
+        <a:font script="Deva" typeface="Mangal"/>
+        <a:font script="Telu" typeface="Gautami"/>
+        <a:font script="Taml" typeface="Latha"/>
+        <a:font script="Syrc" typeface="Estrangelo Edessa"/>
+        <a:font script="Orya" typeface="Kalinga"/>
+        <a:font script="Mlym" typeface="Kartika"/>
+        <a:font script="Laoo" typeface="DokChampa"/>
+        <a:font script="Sinh" typeface="Iskoola Pota"/>
+        <a:font script="Mong" typeface="Mongolian Baiti"/>
+        <a:font script="Viet" typeface="Arial"/>
+        <a:font script="Uigh" typeface="Microsoft Uighur"/>
+        <a:font script="Geor" typeface="Sylfaen"/>
+      </a:minorFont>
+    </a:fontScheme>
+    <a:fmtScheme name="Office">
+      <a:fillStyleLst>
+        <a:solidFill>
+          <a:schemeClr val="phClr"/>
+        </a:solidFill>
+        <a:gradFill rotWithShape="1">
+          <a:gsLst>
+            <a:gs pos="0">
+              <a:schemeClr val="phClr">
+                <a:tint val="50000"/>
+                <a:satMod val="300000"/>
+              </a:schemeClr>
+            </a:gs>
+            <a:gs pos="35000">
+              <a:schemeClr val="phClr">
+                <a:tint val="37000"/>
+                <a:satMod val="300000"/>
+              </a:schemeClr>
+            </a:gs>
+            <a:gs pos="100000">
+              <a:schemeClr val="phClr">
+                <a:tint val="15000"/>
+                <a:satMod val="350000"/>
+              </a:schemeClr>
+            </a:gs>
+          </a:gsLst>
+          <a:lin ang="16200000" scaled="1"/>
+        </a:gradFill>
+        <a:gradFill rotWithShape="1">
+          <a:gsLst>
+            <a:gs pos="0">
+              <a:schemeClr val="phClr">
+                <a:tint val="100000"/>
+                <a:shade val="100000"/>
+                <a:satMod val="130000"/>
+              </a:schemeClr>
+            </a:gs>
+            <a:gs pos="100000">
+              <a:schemeClr val="phClr">
+                <a:tint val="50000"/>
+                <a:shade val="100000"/>
+                <a:satMod val="350000"/>
+              </a:schemeClr>
+            </a:gs>
+          </a:gsLst>
+          <a:lin ang="16200000" scaled="0"/>
+        </a:gradFill>
+      </a:fillStyleLst>
+      <a:lnStyleLst>
+        <a:ln w="9525" cap="flat" cmpd="sng" algn="ctr">
+          <a:solidFill>
+            <a:schemeClr val="phClr">
+              <a:shade val="95000"/>
+              <a:satMod val="105000"/>
+            </a:schemeClr>
+          </a:solidFill>
+          <a:prstDash val="solid"/>
+        </a:ln>
+        <a:ln w="25400" cap="flat" cmpd="sng" algn="ctr">
+          <a:solidFill>
+            <a:schemeClr val="phClr"/>
+          </a:solidFill>
+          <a:prstDash val="solid"/>
+        </a:ln>
+        <a:ln w="38100" cap="flat" cmpd="sng" algn="ctr">
+          <a:solidFill>
+            <a:schemeClr val="phClr"/>
+          </a:solidFill>
+          <a:prstDash val="solid"/>
+        </a:ln>
+      </a:lnStyleLst>
+      <a:effectStyleLst>
+        <a:effectStyle>
+          <a:effectLst>
+            <a:outerShdw blurRad="40000" dist="20000" dir="5400000" rotWithShape="0">
+              <a:srgbClr val="000000">
+                <a:alpha val="38000"/>
+              </a:srgbClr>
+            </a:outerShdw>
+          </a:effectLst>
+        </a:effectStyle>
+        <a:effectStyle>
+          <a:effectLst>
+            <a:outerShdw blurRad="40000" dist="23000" dir="5400000" rotWithShape="0">
+              <a:srgbClr val="000000">
+                <a:alpha val="35000"/>
+              </a:srgbClr>
+            </a:outerShdw>
+          </a:effectLst>
+        </a:effectStyle>
+        <a:effectStyle>
+          <a:effectLst>
+            <a:outerShdw blurRad="40000" dist="23000" dir="5400000" rotWithShape="0">
+              <a:srgbClr val="000000">
+                <a:alpha val="35000"/>
+              </a:srgbClr>
+            </a:outerShdw>
+          </a:effectLst>
+          <a:scene3d>
+            <a:camera prst="orthographicFront">
+              <a:rot lat="0" lon="0" rev="0"/>
+            </a:camera>
+            <a:lightRig rig="threePt" dir="t">
+              <a:rot lat="0" lon="0" rev="1200000"/>
+            </a:lightRig>
+          </a:scene3d>
+          <a:sp3d>
+            <a:bevelT w="63500" h="25400"/>
+          </a:sp3d>
+        </a:effectStyle>
+      </a:effectStyleLst>
+      <a:bgFillStyleLst>
+        <a:solidFill>
+          <a:schemeClr val="phClr"/>
+        </a:solidFill>
+        <a:gradFill rotWithShape="1">
+          <a:gsLst>
+            <a:gs pos="0">
+              <a:schemeClr val="phClr">
+                <a:tint val="40000"/>
+                <a:satMod val="350000"/>
+              </a:schemeClr>
+            </a:gs>
+            <a:gs pos="40000">
+              <a:schemeClr val="phClr">
+                <a:tint val="45000"/>
+                <a:shade val="99000"/>
+                <a:satMod val="350000"/>
+              </a:schemeClr>
+            </a:gs>
+            <a:gs pos="100000">
+              <a:schemeClr val="phClr">
+                <a:shade val="20000"/>
+                <a:satMod val="255000"/>
+              </a:schemeClr>
+            </a:gs>
+          </a:gsLst>
+          <a:path path="circle">
+            <a:fillToRect l="50000" t="-80000" r="50000" b="180000"/>
+          </a:path>
+        </a:gradFill>
+        <a:gradFill rotWithShape="1">
+          <a:gsLst>
+            <a:gs pos="0">
+              <a:schemeClr val="phClr">
+                <a:tint val="80000"/>
+                <a:satMod val="300000"/>
+              </a:schemeClr>
+            </a:gs>
+            <a:gs pos="100000">
+              <a:schemeClr val="phClr">
+                <a:shade val="30000"/>
+                <a:satMod val="200000"/>
+              </a:schemeClr>
+            </a:gs>
+          </a:gsLst>
+          <a:path path="circle">
+            <a:fillToRect l="50000" t="50000" r="50000" b="50000"/>
+          </a:path>
+        </a:gradFill>
+      </a:bgFillStyleLst>
+    </a:fmtScheme>
+  </a:themeElements>
+  <a:objectDefaults>
+    <a:spDef>
+      <a:spPr/>
+      <a:bodyPr/>
+      <a:lstStyle/>
+      <a:style>
+        <a:lnRef idx="1">
+          <a:schemeClr val="accent1"/>
+        </a:lnRef>
+        <a:fillRef idx="3">
+          <a:schemeClr val="accent1"/>
+        </a:fillRef>
+        <a:effectRef idx="2">
+          <a:schemeClr val="accent1"/>
+        </a:effectRef>
+        <a:fontRef idx="minor">
+          <a:schemeClr val="lt1"/>
+        </a:fontRef>
+      </a:style>
+    </a:spDef>
+    <a:lnDef>
+      <a:spPr/>
+      <a:bodyPr/>
+      <a:lstStyle/>
+      <a:style>
+        <a:lnRef idx="2">
+          <a:schemeClr val="accent1"/>
+        </a:lnRef>
+        <a:fillRef idx="0">
+          <a:schemeClr val="accent1"/>
+        </a:fillRef>
+        <a:effectRef idx="1">
+          <a:schemeClr val="accent1"/>
+        </a:effectRef>
+        <a:fontRef idx="minor">
+          <a:schemeClr val="tx1"/>
+        </a:fontRef>
+      </a:style>
+    </a:lnDef>
+  </a:objectDefaults>
+  <a:extraClrSchemeLst/>
+</a:theme>
 </file>
</xml_diff>